<commit_message>
mailersend added to slides
</commit_message>
<xml_diff>
--- a/Documentation/FinalPresentation/VulcanActivityTracker-Group2.pptx
+++ b/Documentation/FinalPresentation/VulcanActivityTracker-Group2.pptx
@@ -123,21 +123,12 @@
 </p:presentation>
 </file>
 
-<file path=ppt/revisionInfo.xml><?xml version="1.0" encoding="utf-8"?>
-<p1510:revInfo xmlns:a="http://schemas.openxmlformats.org/drawingml/2006/main" xmlns:r="http://schemas.openxmlformats.org/officeDocument/2006/relationships" xmlns:p1510="http://schemas.microsoft.com/office/powerpoint/2015/10/main">
-  <p1510:revLst>
-    <p1510:client id="{378BD0A3-E72A-4148-9985-93B00B834DD1}" v="114" dt="2026-04-09T13:36:42.127"/>
-    <p1510:client id="{E6BD7675-78AE-4F8B-8964-D085977A50B0}" v="66" dt="2026-04-09T12:31:27.940"/>
-  </p1510:revLst>
-</p1510:revInfo>
-</file>
-
 <file path=ppt/changesInfos/changesInfo1.xml><?xml version="1.0" encoding="utf-8"?>
 <pc:chgInfo xmlns:a="http://schemas.openxmlformats.org/drawingml/2006/main" xmlns:r="http://schemas.openxmlformats.org/officeDocument/2006/relationships" xmlns:ac="http://schemas.microsoft.com/office/drawing/2013/main/command" xmlns:pc="http://schemas.microsoft.com/office/powerpoint/2013/main/command">
   <pc:docChgLst>
     <pc:chgData name="John Gerega" userId="bd3e1e46fb6a714b" providerId="LiveId" clId="{45F0C402-C550-4C82-B31D-5B32217A5E94}"/>
     <pc:docChg chg="undo custSel addSld delSld modSld">
-      <pc:chgData name="John Gerega" userId="bd3e1e46fb6a714b" providerId="LiveId" clId="{45F0C402-C550-4C82-B31D-5B32217A5E94}" dt="2026-03-29T13:00:56.525" v="2636" actId="20577"/>
+      <pc:chgData name="John Gerega" userId="bd3e1e46fb6a714b" providerId="LiveId" clId="{45F0C402-C550-4C82-B31D-5B32217A5E94}" dt="2026-04-14T17:16:21.241" v="2683" actId="20577"/>
       <pc:docMkLst>
         <pc:docMk/>
       </pc:docMkLst>
@@ -147,6 +138,21 @@
           <pc:docMk/>
           <pc:sldMk cId="2561402868" sldId="264"/>
         </pc:sldMkLst>
+      </pc:sldChg>
+      <pc:sldChg chg="modSp mod">
+        <pc:chgData name="John Gerega" userId="bd3e1e46fb6a714b" providerId="LiveId" clId="{45F0C402-C550-4C82-B31D-5B32217A5E94}" dt="2026-04-14T17:16:21.241" v="2683" actId="20577"/>
+        <pc:sldMkLst>
+          <pc:docMk/>
+          <pc:sldMk cId="606434410" sldId="275"/>
+        </pc:sldMkLst>
+        <pc:graphicFrameChg chg="modGraphic">
+          <ac:chgData name="John Gerega" userId="bd3e1e46fb6a714b" providerId="LiveId" clId="{45F0C402-C550-4C82-B31D-5B32217A5E94}" dt="2026-04-14T17:16:21.241" v="2683" actId="20577"/>
+          <ac:graphicFrameMkLst>
+            <pc:docMk/>
+            <pc:sldMk cId="606434410" sldId="275"/>
+            <ac:graphicFrameMk id="6" creationId="{27EACA2E-750E-36F7-A7AE-14DB1D64E678}"/>
+          </ac:graphicFrameMkLst>
+        </pc:graphicFrameChg>
       </pc:sldChg>
     </pc:docChg>
   </pc:docChgLst>
@@ -212,13 +218,6 @@
           </ac:picMkLst>
         </pc:picChg>
       </pc:sldChg>
-      <pc:sldChg chg="addSp delSp modSp del mod ord modClrScheme delDesignElem chgLayout">
-        <pc:chgData name="Margo Bonal" userId="18c9fa0f-b53d-478b-9dc0-6ad88786c19f" providerId="ADAL" clId="{93D479E5-F67F-4B8A-A78F-A0B574A116B6}" dt="2026-04-09T13:07:15.003" v="3110" actId="2696"/>
-        <pc:sldMkLst>
-          <pc:docMk/>
-          <pc:sldMk cId="2065992260" sldId="258"/>
-        </pc:sldMkLst>
-      </pc:sldChg>
       <pc:sldChg chg="addSp delSp modSp mod ord">
         <pc:chgData name="Margo Bonal" userId="18c9fa0f-b53d-478b-9dc0-6ad88786c19f" providerId="ADAL" clId="{93D479E5-F67F-4B8A-A78F-A0B574A116B6}" dt="2026-04-09T13:35:36.677" v="3814" actId="122"/>
         <pc:sldMkLst>
@@ -250,29 +249,6 @@
           </ac:picMkLst>
         </pc:picChg>
       </pc:sldChg>
-      <pc:sldChg chg="addSp modSp del mod">
-        <pc:chgData name="Margo Bonal" userId="18c9fa0f-b53d-478b-9dc0-6ad88786c19f" providerId="ADAL" clId="{93D479E5-F67F-4B8A-A78F-A0B574A116B6}" dt="2026-04-09T12:37:04.938" v="2857" actId="2696"/>
-        <pc:sldMkLst>
-          <pc:docMk/>
-          <pc:sldMk cId="3921983173" sldId="260"/>
-        </pc:sldMkLst>
-        <pc:spChg chg="mod">
-          <ac:chgData name="Margo Bonal" userId="18c9fa0f-b53d-478b-9dc0-6ad88786c19f" providerId="ADAL" clId="{93D479E5-F67F-4B8A-A78F-A0B574A116B6}" dt="2026-04-09T12:36:54.246" v="2853" actId="1076"/>
-          <ac:spMkLst>
-            <pc:docMk/>
-            <pc:sldMk cId="3921983173" sldId="260"/>
-            <ac:spMk id="2" creationId="{9C9AD6B9-1CEE-7976-0BB7-22F5E9535735}"/>
-          </ac:spMkLst>
-        </pc:spChg>
-        <pc:spChg chg="add mod">
-          <ac:chgData name="Margo Bonal" userId="18c9fa0f-b53d-478b-9dc0-6ad88786c19f" providerId="ADAL" clId="{93D479E5-F67F-4B8A-A78F-A0B574A116B6}" dt="2026-04-09T12:32:26.245" v="2837" actId="1076"/>
-          <ac:spMkLst>
-            <pc:docMk/>
-            <pc:sldMk cId="3921983173" sldId="260"/>
-            <ac:spMk id="3" creationId="{43E12FD0-F8AE-69F2-0588-3EDA6A286A22}"/>
-          </ac:spMkLst>
-        </pc:spChg>
-      </pc:sldChg>
       <pc:sldChg chg="addSp delSp modSp mod ord">
         <pc:chgData name="Margo Bonal" userId="18c9fa0f-b53d-478b-9dc0-6ad88786c19f" providerId="ADAL" clId="{93D479E5-F67F-4B8A-A78F-A0B574A116B6}" dt="2026-04-09T13:35:17.931" v="3813" actId="115"/>
         <pc:sldMkLst>
@@ -301,22 +277,6 @@
             <pc:docMk/>
             <pc:sldMk cId="2561402868" sldId="264"/>
             <ac:spMk id="4" creationId="{1C887DFC-839F-0DF5-2BFF-4D0D0149ACB2}"/>
-          </ac:spMkLst>
-        </pc:spChg>
-        <pc:spChg chg="add del mod">
-          <ac:chgData name="Margo Bonal" userId="18c9fa0f-b53d-478b-9dc0-6ad88786c19f" providerId="ADAL" clId="{93D479E5-F67F-4B8A-A78F-A0B574A116B6}" dt="2026-04-09T13:20:12.551" v="3417" actId="478"/>
-          <ac:spMkLst>
-            <pc:docMk/>
-            <pc:sldMk cId="2561402868" sldId="264"/>
-            <ac:spMk id="5" creationId="{FFF8B1EF-408A-3DC7-AC54-151B43CF7BE0}"/>
-          </ac:spMkLst>
-        </pc:spChg>
-        <pc:spChg chg="add del mod">
-          <ac:chgData name="Margo Bonal" userId="18c9fa0f-b53d-478b-9dc0-6ad88786c19f" providerId="ADAL" clId="{93D479E5-F67F-4B8A-A78F-A0B574A116B6}" dt="2026-04-09T13:20:24.353" v="3421" actId="478"/>
-          <ac:spMkLst>
-            <pc:docMk/>
-            <pc:sldMk cId="2561402868" sldId="264"/>
-            <ac:spMk id="7" creationId="{791E2233-D9BC-558E-FCB0-1BFAE870CB38}"/>
           </ac:spMkLst>
         </pc:spChg>
         <pc:spChg chg="add">
@@ -376,35 +336,6 @@
           </ac:picMkLst>
         </pc:picChg>
       </pc:sldChg>
-      <pc:sldChg chg="addSp delSp modSp del mod">
-        <pc:chgData name="Margo Bonal" userId="18c9fa0f-b53d-478b-9dc0-6ad88786c19f" providerId="ADAL" clId="{93D479E5-F67F-4B8A-A78F-A0B574A116B6}" dt="2026-04-09T13:24:30.766" v="3517" actId="2696"/>
-        <pc:sldMkLst>
-          <pc:docMk/>
-          <pc:sldMk cId="3526335932" sldId="266"/>
-        </pc:sldMkLst>
-        <pc:spChg chg="add del mod">
-          <ac:chgData name="Margo Bonal" userId="18c9fa0f-b53d-478b-9dc0-6ad88786c19f" providerId="ADAL" clId="{93D479E5-F67F-4B8A-A78F-A0B574A116B6}" dt="2026-04-09T13:23:29.443" v="3511" actId="1076"/>
-          <ac:spMkLst>
-            <pc:docMk/>
-            <pc:sldMk cId="3526335932" sldId="266"/>
-            <ac:spMk id="12" creationId="{C1592817-F778-6064-F584-CD08A00F548D}"/>
-          </ac:spMkLst>
-        </pc:spChg>
-      </pc:sldChg>
-      <pc:sldChg chg="add del">
-        <pc:chgData name="Margo Bonal" userId="18c9fa0f-b53d-478b-9dc0-6ad88786c19f" providerId="ADAL" clId="{93D479E5-F67F-4B8A-A78F-A0B574A116B6}" dt="2026-04-09T12:36:20.872" v="2840" actId="2696"/>
-        <pc:sldMkLst>
-          <pc:docMk/>
-          <pc:sldMk cId="3784518536" sldId="272"/>
-        </pc:sldMkLst>
-      </pc:sldChg>
-      <pc:sldChg chg="addSp modSp add del mod ord">
-        <pc:chgData name="Margo Bonal" userId="18c9fa0f-b53d-478b-9dc0-6ad88786c19f" providerId="ADAL" clId="{93D479E5-F67F-4B8A-A78F-A0B574A116B6}" dt="2026-04-09T12:36:08.578" v="2839" actId="2696"/>
-        <pc:sldMkLst>
-          <pc:docMk/>
-          <pc:sldMk cId="1955700403" sldId="273"/>
-        </pc:sldMkLst>
-      </pc:sldChg>
       <pc:sldChg chg="addSp delSp modSp new mod setBg">
         <pc:chgData name="Margo Bonal" userId="18c9fa0f-b53d-478b-9dc0-6ad88786c19f" providerId="ADAL" clId="{93D479E5-F67F-4B8A-A78F-A0B574A116B6}" dt="2026-04-09T13:36:42.127" v="3827"/>
         <pc:sldMkLst>
@@ -427,14 +358,6 @@
             <ac:spMk id="3" creationId="{5BA1FDAB-BF64-1FC7-8CE6-75537E5CD8D5}"/>
           </ac:spMkLst>
         </pc:spChg>
-        <pc:spChg chg="add del mod">
-          <ac:chgData name="Margo Bonal" userId="18c9fa0f-b53d-478b-9dc0-6ad88786c19f" providerId="ADAL" clId="{93D479E5-F67F-4B8A-A78F-A0B574A116B6}" dt="2026-04-09T12:59:31.424" v="3005" actId="478"/>
-          <ac:spMkLst>
-            <pc:docMk/>
-            <pc:sldMk cId="606434410" sldId="275"/>
-            <ac:spMk id="8" creationId="{255C3630-3358-8D39-1436-CE2C9E16E210}"/>
-          </ac:spMkLst>
-        </pc:spChg>
         <pc:spChg chg="add">
           <ac:chgData name="Margo Bonal" userId="18c9fa0f-b53d-478b-9dc0-6ad88786c19f" providerId="ADAL" clId="{93D479E5-F67F-4B8A-A78F-A0B574A116B6}" dt="2026-03-30T22:06:38.945" v="2506" actId="26606"/>
           <ac:spMkLst>
@@ -451,22 +374,6 @@
             <ac:spMk id="22" creationId="{F13BE4D7-0C3D-4906-B230-A1C5B4665CCF}"/>
           </ac:spMkLst>
         </pc:spChg>
-        <pc:graphicFrameChg chg="add del mod modGraphic">
-          <ac:chgData name="Margo Bonal" userId="18c9fa0f-b53d-478b-9dc0-6ad88786c19f" providerId="ADAL" clId="{93D479E5-F67F-4B8A-A78F-A0B574A116B6}" dt="2026-04-09T12:58:35.332" v="2986" actId="3680"/>
-          <ac:graphicFrameMkLst>
-            <pc:docMk/>
-            <pc:sldMk cId="606434410" sldId="275"/>
-            <ac:graphicFrameMk id="4" creationId="{15449C7F-6585-D7AB-B3E8-6BF6780F946F}"/>
-          </ac:graphicFrameMkLst>
-        </pc:graphicFrameChg>
-        <pc:graphicFrameChg chg="add del mod modGraphic">
-          <ac:chgData name="Margo Bonal" userId="18c9fa0f-b53d-478b-9dc0-6ad88786c19f" providerId="ADAL" clId="{93D479E5-F67F-4B8A-A78F-A0B574A116B6}" dt="2026-04-09T12:59:25.911" v="3003" actId="21"/>
-          <ac:graphicFrameMkLst>
-            <pc:docMk/>
-            <pc:sldMk cId="606434410" sldId="275"/>
-            <ac:graphicFrameMk id="5" creationId="{B637E48A-5144-C661-B92C-99B33A6272A7}"/>
-          </ac:graphicFrameMkLst>
-        </pc:graphicFrameChg>
         <pc:graphicFrameChg chg="add mod modGraphic">
           <ac:chgData name="Margo Bonal" userId="18c9fa0f-b53d-478b-9dc0-6ad88786c19f" providerId="ADAL" clId="{93D479E5-F67F-4B8A-A78F-A0B574A116B6}" dt="2026-04-09T13:36:42.127" v="3827"/>
           <ac:graphicFrameMkLst>
@@ -475,117 +382,6 @@
             <ac:graphicFrameMk id="6" creationId="{27EACA2E-750E-36F7-A7AE-14DB1D64E678}"/>
           </ac:graphicFrameMkLst>
         </pc:graphicFrameChg>
-        <pc:graphicFrameChg chg="add mod">
-          <ac:chgData name="Margo Bonal" userId="18c9fa0f-b53d-478b-9dc0-6ad88786c19f" providerId="ADAL" clId="{93D479E5-F67F-4B8A-A78F-A0B574A116B6}" dt="2026-04-09T13:03:01.529" v="3059"/>
-          <ac:graphicFrameMkLst>
-            <pc:docMk/>
-            <pc:sldMk cId="606434410" sldId="275"/>
-            <ac:graphicFrameMk id="9" creationId="{D74A3989-561F-61C2-CF1A-0A6FCF9B354C}"/>
-          </ac:graphicFrameMkLst>
-        </pc:graphicFrameChg>
-      </pc:sldChg>
-      <pc:sldChg chg="addSp delSp modSp add del mod ord">
-        <pc:chgData name="Margo Bonal" userId="18c9fa0f-b53d-478b-9dc0-6ad88786c19f" providerId="ADAL" clId="{93D479E5-F67F-4B8A-A78F-A0B574A116B6}" dt="2026-04-09T13:17:41.439" v="3259" actId="2696"/>
-        <pc:sldMkLst>
-          <pc:docMk/>
-          <pc:sldMk cId="1826588013" sldId="277"/>
-        </pc:sldMkLst>
-        <pc:spChg chg="add mod">
-          <ac:chgData name="Margo Bonal" userId="18c9fa0f-b53d-478b-9dc0-6ad88786c19f" providerId="ADAL" clId="{93D479E5-F67F-4B8A-A78F-A0B574A116B6}" dt="2026-04-09T13:11:39.498" v="3149" actId="20577"/>
-          <ac:spMkLst>
-            <pc:docMk/>
-            <pc:sldMk cId="1826588013" sldId="277"/>
-            <ac:spMk id="2" creationId="{8D2E6DA5-8082-69ED-46FE-761CD03BD4F4}"/>
-          </ac:spMkLst>
-        </pc:spChg>
-        <pc:spChg chg="add mod">
-          <ac:chgData name="Margo Bonal" userId="18c9fa0f-b53d-478b-9dc0-6ad88786c19f" providerId="ADAL" clId="{93D479E5-F67F-4B8A-A78F-A0B574A116B6}" dt="2026-04-09T13:13:30.930" v="3223" actId="1076"/>
-          <ac:spMkLst>
-            <pc:docMk/>
-            <pc:sldMk cId="1826588013" sldId="277"/>
-            <ac:spMk id="3" creationId="{C862E3E6-BAA5-7853-4E9E-1C33A7B6964E}"/>
-          </ac:spMkLst>
-        </pc:spChg>
-        <pc:spChg chg="add mod">
-          <ac:chgData name="Margo Bonal" userId="18c9fa0f-b53d-478b-9dc0-6ad88786c19f" providerId="ADAL" clId="{93D479E5-F67F-4B8A-A78F-A0B574A116B6}" dt="2026-04-09T13:11:02.974" v="3131" actId="1076"/>
-          <ac:spMkLst>
-            <pc:docMk/>
-            <pc:sldMk cId="1826588013" sldId="277"/>
-            <ac:spMk id="5" creationId="{F0507379-E14B-ECC4-A908-CD67A5D06E3B}"/>
-          </ac:spMkLst>
-        </pc:spChg>
-        <pc:spChg chg="add mod">
-          <ac:chgData name="Margo Bonal" userId="18c9fa0f-b53d-478b-9dc0-6ad88786c19f" providerId="ADAL" clId="{93D479E5-F67F-4B8A-A78F-A0B574A116B6}" dt="2026-04-09T13:12:38.653" v="3205" actId="1076"/>
-          <ac:spMkLst>
-            <pc:docMk/>
-            <pc:sldMk cId="1826588013" sldId="277"/>
-            <ac:spMk id="6" creationId="{9347F810-2AE5-661D-6132-64453EEF1EC8}"/>
-          </ac:spMkLst>
-        </pc:spChg>
-        <pc:graphicFrameChg chg="add del mod modGraphic">
-          <ac:chgData name="Margo Bonal" userId="18c9fa0f-b53d-478b-9dc0-6ad88786c19f" providerId="ADAL" clId="{93D479E5-F67F-4B8A-A78F-A0B574A116B6}" dt="2026-04-09T13:11:27.711" v="3140" actId="478"/>
-          <ac:graphicFrameMkLst>
-            <pc:docMk/>
-            <pc:sldMk cId="1826588013" sldId="277"/>
-            <ac:graphicFrameMk id="4" creationId="{40CDF1D4-2B6D-00A5-1CAF-68193EE8F1B9}"/>
-          </ac:graphicFrameMkLst>
-        </pc:graphicFrameChg>
-        <pc:picChg chg="add mod">
-          <ac:chgData name="Margo Bonal" userId="18c9fa0f-b53d-478b-9dc0-6ad88786c19f" providerId="ADAL" clId="{93D479E5-F67F-4B8A-A78F-A0B574A116B6}" dt="2026-04-09T13:12:54.721" v="3214" actId="1076"/>
-          <ac:picMkLst>
-            <pc:docMk/>
-            <pc:sldMk cId="1826588013" sldId="277"/>
-            <ac:picMk id="1026" creationId="{AFC6D719-0E2B-3D09-E742-22BE9A2ACEF1}"/>
-          </ac:picMkLst>
-        </pc:picChg>
-        <pc:picChg chg="add mod">
-          <ac:chgData name="Margo Bonal" userId="18c9fa0f-b53d-478b-9dc0-6ad88786c19f" providerId="ADAL" clId="{93D479E5-F67F-4B8A-A78F-A0B574A116B6}" dt="2026-04-09T13:13:22.969" v="3221" actId="1076"/>
-          <ac:picMkLst>
-            <pc:docMk/>
-            <pc:sldMk cId="1826588013" sldId="277"/>
-            <ac:picMk id="1028" creationId="{9D05F3D4-AF92-9969-D68B-1D704FF6B5A8}"/>
-          </ac:picMkLst>
-        </pc:picChg>
-        <pc:picChg chg="add">
-          <ac:chgData name="Margo Bonal" userId="18c9fa0f-b53d-478b-9dc0-6ad88786c19f" providerId="ADAL" clId="{93D479E5-F67F-4B8A-A78F-A0B574A116B6}" dt="2026-04-09T13:09:47.520" v="3113"/>
-          <ac:picMkLst>
-            <pc:docMk/>
-            <pc:sldMk cId="1826588013" sldId="277"/>
-            <ac:picMk id="1030" creationId="{C3E66DE2-D7B8-56EE-88CB-CF2562ABD39B}"/>
-          </ac:picMkLst>
-        </pc:picChg>
-        <pc:picChg chg="add mod">
-          <ac:chgData name="Margo Bonal" userId="18c9fa0f-b53d-478b-9dc0-6ad88786c19f" providerId="ADAL" clId="{93D479E5-F67F-4B8A-A78F-A0B574A116B6}" dt="2026-04-09T13:13:20.698" v="3220" actId="1076"/>
-          <ac:picMkLst>
-            <pc:docMk/>
-            <pc:sldMk cId="1826588013" sldId="277"/>
-            <ac:picMk id="1032" creationId="{59F10362-3DCA-8E2C-EA52-BFB7648276DF}"/>
-          </ac:picMkLst>
-        </pc:picChg>
-        <pc:picChg chg="add del mod">
-          <ac:chgData name="Margo Bonal" userId="18c9fa0f-b53d-478b-9dc0-6ad88786c19f" providerId="ADAL" clId="{93D479E5-F67F-4B8A-A78F-A0B574A116B6}" dt="2026-04-09T13:16:50.172" v="3253" actId="21"/>
-          <ac:picMkLst>
-            <pc:docMk/>
-            <pc:sldMk cId="1826588013" sldId="277"/>
-            <ac:picMk id="1034" creationId="{27F73DA7-C342-ABE2-B9AD-95561A89D216}"/>
-          </ac:picMkLst>
-        </pc:picChg>
-        <pc:picChg chg="add">
-          <ac:chgData name="Margo Bonal" userId="18c9fa0f-b53d-478b-9dc0-6ad88786c19f" providerId="ADAL" clId="{93D479E5-F67F-4B8A-A78F-A0B574A116B6}" dt="2026-04-09T13:11:40.788" v="3150"/>
-          <ac:picMkLst>
-            <pc:docMk/>
-            <pc:sldMk cId="1826588013" sldId="277"/>
-            <ac:picMk id="1036" creationId="{7D743F9D-B14A-D178-EE4E-3FDBBD50B4D7}"/>
-          </ac:picMkLst>
-        </pc:picChg>
-        <pc:picChg chg="add">
-          <ac:chgData name="Margo Bonal" userId="18c9fa0f-b53d-478b-9dc0-6ad88786c19f" providerId="ADAL" clId="{93D479E5-F67F-4B8A-A78F-A0B574A116B6}" dt="2026-04-09T13:11:43.973" v="3151"/>
-          <ac:picMkLst>
-            <pc:docMk/>
-            <pc:sldMk cId="1826588013" sldId="277"/>
-            <ac:picMk id="1038" creationId="{DF0630DD-337E-2D1E-8183-DF5FBCD659D2}"/>
-          </ac:picMkLst>
-        </pc:picChg>
       </pc:sldChg>
       <pc:sldChg chg="addSp delSp modSp new mod setBg">
         <pc:chgData name="Margo Bonal" userId="18c9fa0f-b53d-478b-9dc0-6ad88786c19f" providerId="ADAL" clId="{93D479E5-F67F-4B8A-A78F-A0B574A116B6}" dt="2026-04-09T13:34:23.453" v="3806" actId="27636"/>
@@ -599,14 +395,6 @@
             <pc:docMk/>
             <pc:sldMk cId="3773506301" sldId="278"/>
             <ac:spMk id="2" creationId="{153C799C-4835-C8CB-B090-70E82B558CED}"/>
-          </ac:spMkLst>
-        </pc:spChg>
-        <pc:spChg chg="del mod">
-          <ac:chgData name="Margo Bonal" userId="18c9fa0f-b53d-478b-9dc0-6ad88786c19f" providerId="ADAL" clId="{93D479E5-F67F-4B8A-A78F-A0B574A116B6}" dt="2026-04-09T12:36:59.074" v="2854" actId="478"/>
-          <ac:spMkLst>
-            <pc:docMk/>
-            <pc:sldMk cId="3773506301" sldId="278"/>
-            <ac:spMk id="3" creationId="{F8FED67F-FCC2-6EE8-21DE-770B433943CA}"/>
           </ac:spMkLst>
         </pc:spChg>
         <pc:spChg chg="add mod">
@@ -654,150 +442,6 @@
             <pc:docMk/>
             <pc:sldMk cId="532806018" sldId="279"/>
             <ac:spMk id="2" creationId="{255BA779-BC14-3414-2543-22E141EF061A}"/>
-          </ac:spMkLst>
-        </pc:spChg>
-        <pc:spChg chg="add del">
-          <ac:chgData name="Margo Bonal" userId="18c9fa0f-b53d-478b-9dc0-6ad88786c19f" providerId="ADAL" clId="{93D479E5-F67F-4B8A-A78F-A0B574A116B6}" dt="2026-04-09T13:06:45.235" v="3104" actId="26606"/>
-          <ac:spMkLst>
-            <pc:docMk/>
-            <pc:sldMk cId="532806018" sldId="279"/>
-            <ac:spMk id="3" creationId="{30B4AFC1-9291-98EA-4DE8-15546E190472}"/>
-          </ac:spMkLst>
-        </pc:spChg>
-        <pc:spChg chg="add del">
-          <ac:chgData name="Margo Bonal" userId="18c9fa0f-b53d-478b-9dc0-6ad88786c19f" providerId="ADAL" clId="{93D479E5-F67F-4B8A-A78F-A0B574A116B6}" dt="2026-04-09T13:06:18.433" v="3097" actId="26606"/>
-          <ac:spMkLst>
-            <pc:docMk/>
-            <pc:sldMk cId="532806018" sldId="279"/>
-            <ac:spMk id="8" creationId="{C2554CA6-288E-4202-BC52-2E5A8F0C0AED}"/>
-          </ac:spMkLst>
-        </pc:spChg>
-        <pc:spChg chg="add del">
-          <ac:chgData name="Margo Bonal" userId="18c9fa0f-b53d-478b-9dc0-6ad88786c19f" providerId="ADAL" clId="{93D479E5-F67F-4B8A-A78F-A0B574A116B6}" dt="2026-04-09T13:06:13.669" v="3095" actId="26606"/>
-          <ac:spMkLst>
-            <pc:docMk/>
-            <pc:sldMk cId="532806018" sldId="279"/>
-            <ac:spMk id="10" creationId="{A3363022-C969-41E9-8EB2-E4C94908C1FA}"/>
-          </ac:spMkLst>
-        </pc:spChg>
-        <pc:spChg chg="add del">
-          <ac:chgData name="Margo Bonal" userId="18c9fa0f-b53d-478b-9dc0-6ad88786c19f" providerId="ADAL" clId="{93D479E5-F67F-4B8A-A78F-A0B574A116B6}" dt="2026-04-09T13:06:13.669" v="3095" actId="26606"/>
-          <ac:spMkLst>
-            <pc:docMk/>
-            <pc:sldMk cId="532806018" sldId="279"/>
-            <ac:spMk id="12" creationId="{8D1AD6B3-BE88-4CEB-BA17-790657CC4729}"/>
-          </ac:spMkLst>
-        </pc:spChg>
-        <pc:spChg chg="add del">
-          <ac:chgData name="Margo Bonal" userId="18c9fa0f-b53d-478b-9dc0-6ad88786c19f" providerId="ADAL" clId="{93D479E5-F67F-4B8A-A78F-A0B574A116B6}" dt="2026-04-09T13:06:45.208" v="3103" actId="26606"/>
-          <ac:spMkLst>
-            <pc:docMk/>
-            <pc:sldMk cId="532806018" sldId="279"/>
-            <ac:spMk id="16" creationId="{EA804283-B929-4503-802F-4585376E2B42}"/>
-          </ac:spMkLst>
-        </pc:spChg>
-        <pc:spChg chg="add del">
-          <ac:chgData name="Margo Bonal" userId="18c9fa0f-b53d-478b-9dc0-6ad88786c19f" providerId="ADAL" clId="{93D479E5-F67F-4B8A-A78F-A0B574A116B6}" dt="2026-04-09T13:06:45.208" v="3103" actId="26606"/>
-          <ac:spMkLst>
-            <pc:docMk/>
-            <pc:sldMk cId="532806018" sldId="279"/>
-            <ac:spMk id="18" creationId="{AD3811F5-514E-49A4-B382-673ED228A4CC}"/>
-          </ac:spMkLst>
-        </pc:spChg>
-        <pc:spChg chg="add del">
-          <ac:chgData name="Margo Bonal" userId="18c9fa0f-b53d-478b-9dc0-6ad88786c19f" providerId="ADAL" clId="{93D479E5-F67F-4B8A-A78F-A0B574A116B6}" dt="2026-04-09T13:06:18.433" v="3097" actId="26606"/>
-          <ac:spMkLst>
-            <pc:docMk/>
-            <pc:sldMk cId="532806018" sldId="279"/>
-            <ac:spMk id="19" creationId="{B10BB131-AC8E-4A8E-A5D1-36260F720C3B}"/>
-          </ac:spMkLst>
-        </pc:spChg>
-        <pc:spChg chg="add del">
-          <ac:chgData name="Margo Bonal" userId="18c9fa0f-b53d-478b-9dc0-6ad88786c19f" providerId="ADAL" clId="{93D479E5-F67F-4B8A-A78F-A0B574A116B6}" dt="2026-04-09T13:06:18.433" v="3097" actId="26606"/>
-          <ac:spMkLst>
-            <pc:docMk/>
-            <pc:sldMk cId="532806018" sldId="279"/>
-            <ac:spMk id="20" creationId="{5B7778FC-632E-4DCA-A7CB-0D7731CCF970}"/>
-          </ac:spMkLst>
-        </pc:spChg>
-        <pc:spChg chg="add del">
-          <ac:chgData name="Margo Bonal" userId="18c9fa0f-b53d-478b-9dc0-6ad88786c19f" providerId="ADAL" clId="{93D479E5-F67F-4B8A-A78F-A0B574A116B6}" dt="2026-04-09T13:06:18.433" v="3097" actId="26606"/>
-          <ac:spMkLst>
-            <pc:docMk/>
-            <pc:sldMk cId="532806018" sldId="279"/>
-            <ac:spMk id="21" creationId="{FA23A907-97FB-4A8F-880A-DD77401C4296}"/>
-          </ac:spMkLst>
-        </pc:spChg>
-        <pc:spChg chg="add del">
-          <ac:chgData name="Margo Bonal" userId="18c9fa0f-b53d-478b-9dc0-6ad88786c19f" providerId="ADAL" clId="{93D479E5-F67F-4B8A-A78F-A0B574A116B6}" dt="2026-04-09T13:06:18.433" v="3097" actId="26606"/>
-          <ac:spMkLst>
-            <pc:docMk/>
-            <pc:sldMk cId="532806018" sldId="279"/>
-            <ac:spMk id="22" creationId="{30B4AFC1-9291-98EA-4DE8-15546E190472}"/>
-          </ac:spMkLst>
-        </pc:spChg>
-        <pc:spChg chg="add del">
-          <ac:chgData name="Margo Bonal" userId="18c9fa0f-b53d-478b-9dc0-6ad88786c19f" providerId="ADAL" clId="{93D479E5-F67F-4B8A-A78F-A0B574A116B6}" dt="2026-04-09T13:06:22.191" v="3099" actId="26606"/>
-          <ac:spMkLst>
-            <pc:docMk/>
-            <pc:sldMk cId="532806018" sldId="279"/>
-            <ac:spMk id="24" creationId="{A3363022-C969-41E9-8EB2-E4C94908C1FA}"/>
-          </ac:spMkLst>
-        </pc:spChg>
-        <pc:spChg chg="add del">
-          <ac:chgData name="Margo Bonal" userId="18c9fa0f-b53d-478b-9dc0-6ad88786c19f" providerId="ADAL" clId="{93D479E5-F67F-4B8A-A78F-A0B574A116B6}" dt="2026-04-09T13:06:22.191" v="3099" actId="26606"/>
-          <ac:spMkLst>
-            <pc:docMk/>
-            <pc:sldMk cId="532806018" sldId="279"/>
-            <ac:spMk id="25" creationId="{8D1AD6B3-BE88-4CEB-BA17-790657CC4729}"/>
-          </ac:spMkLst>
-        </pc:spChg>
-        <pc:spChg chg="add del">
-          <ac:chgData name="Margo Bonal" userId="18c9fa0f-b53d-478b-9dc0-6ad88786c19f" providerId="ADAL" clId="{93D479E5-F67F-4B8A-A78F-A0B574A116B6}" dt="2026-04-09T13:06:36.319" v="3101" actId="26606"/>
-          <ac:spMkLst>
-            <pc:docMk/>
-            <pc:sldMk cId="532806018" sldId="279"/>
-            <ac:spMk id="29" creationId="{74751229-0244-4FBB-BED1-407467F4C951}"/>
-          </ac:spMkLst>
-        </pc:spChg>
-        <pc:spChg chg="add del">
-          <ac:chgData name="Margo Bonal" userId="18c9fa0f-b53d-478b-9dc0-6ad88786c19f" providerId="ADAL" clId="{93D479E5-F67F-4B8A-A78F-A0B574A116B6}" dt="2026-04-09T13:06:45.208" v="3103" actId="26606"/>
-          <ac:spMkLst>
-            <pc:docMk/>
-            <pc:sldMk cId="532806018" sldId="279"/>
-            <ac:spMk id="32" creationId="{59EF30C2-29AC-4A0D-BC0A-A679CF113EDD}"/>
-          </ac:spMkLst>
-        </pc:spChg>
-        <pc:spChg chg="add del">
-          <ac:chgData name="Margo Bonal" userId="18c9fa0f-b53d-478b-9dc0-6ad88786c19f" providerId="ADAL" clId="{93D479E5-F67F-4B8A-A78F-A0B574A116B6}" dt="2026-04-09T13:06:45.208" v="3103" actId="26606"/>
-          <ac:spMkLst>
-            <pc:docMk/>
-            <pc:sldMk cId="532806018" sldId="279"/>
-            <ac:spMk id="33" creationId="{9C682A1A-5B2D-4111-BBD6-620165633E5B}"/>
-          </ac:spMkLst>
-        </pc:spChg>
-        <pc:spChg chg="add del">
-          <ac:chgData name="Margo Bonal" userId="18c9fa0f-b53d-478b-9dc0-6ad88786c19f" providerId="ADAL" clId="{93D479E5-F67F-4B8A-A78F-A0B574A116B6}" dt="2026-04-09T13:06:45.208" v="3103" actId="26606"/>
-          <ac:spMkLst>
-            <pc:docMk/>
-            <pc:sldMk cId="532806018" sldId="279"/>
-            <ac:spMk id="35" creationId="{A04F1504-431A-4D86-9091-AE7E4B33376B}"/>
-          </ac:spMkLst>
-        </pc:spChg>
-        <pc:spChg chg="add del">
-          <ac:chgData name="Margo Bonal" userId="18c9fa0f-b53d-478b-9dc0-6ad88786c19f" providerId="ADAL" clId="{93D479E5-F67F-4B8A-A78F-A0B574A116B6}" dt="2026-04-09T13:06:45.208" v="3103" actId="26606"/>
-          <ac:spMkLst>
-            <pc:docMk/>
-            <pc:sldMk cId="532806018" sldId="279"/>
-            <ac:spMk id="36" creationId="{067AD921-1CEE-4C1B-9AA3-C66D908DDD14}"/>
-          </ac:spMkLst>
-        </pc:spChg>
-        <pc:spChg chg="add del">
-          <ac:chgData name="Margo Bonal" userId="18c9fa0f-b53d-478b-9dc0-6ad88786c19f" providerId="ADAL" clId="{93D479E5-F67F-4B8A-A78F-A0B574A116B6}" dt="2026-04-09T13:06:45.208" v="3103" actId="26606"/>
-          <ac:spMkLst>
-            <pc:docMk/>
-            <pc:sldMk cId="532806018" sldId="279"/>
-            <ac:spMk id="37" creationId="{C36A08F5-3B56-47C5-A371-9187BE56E1E5}"/>
           </ac:spMkLst>
         </pc:spChg>
         <pc:spChg chg="add">
@@ -856,62 +500,6 @@
             <ac:spMk id="46" creationId="{C39ADB8F-D187-49D7-BDCF-C1B6DC727068}"/>
           </ac:spMkLst>
         </pc:spChg>
-        <pc:grpChg chg="add del">
-          <ac:chgData name="Margo Bonal" userId="18c9fa0f-b53d-478b-9dc0-6ad88786c19f" providerId="ADAL" clId="{93D479E5-F67F-4B8A-A78F-A0B574A116B6}" dt="2026-04-09T13:06:13.669" v="3095" actId="26606"/>
-          <ac:grpSpMkLst>
-            <pc:docMk/>
-            <pc:sldMk cId="532806018" sldId="279"/>
-            <ac:grpSpMk id="14" creationId="{89D1390B-7E13-4B4F-9CB2-391063412E54}"/>
-          </ac:grpSpMkLst>
-        </pc:grpChg>
-        <pc:grpChg chg="add del">
-          <ac:chgData name="Margo Bonal" userId="18c9fa0f-b53d-478b-9dc0-6ad88786c19f" providerId="ADAL" clId="{93D479E5-F67F-4B8A-A78F-A0B574A116B6}" dt="2026-04-09T13:06:22.191" v="3099" actId="26606"/>
-          <ac:grpSpMkLst>
-            <pc:docMk/>
-            <pc:sldMk cId="532806018" sldId="279"/>
-            <ac:grpSpMk id="27" creationId="{89D1390B-7E13-4B4F-9CB2-391063412E54}"/>
-          </ac:grpSpMkLst>
-        </pc:grpChg>
-        <pc:picChg chg="add del">
-          <ac:chgData name="Margo Bonal" userId="18c9fa0f-b53d-478b-9dc0-6ad88786c19f" providerId="ADAL" clId="{93D479E5-F67F-4B8A-A78F-A0B574A116B6}" dt="2026-04-09T13:06:13.669" v="3095" actId="26606"/>
-          <ac:picMkLst>
-            <pc:docMk/>
-            <pc:sldMk cId="532806018" sldId="279"/>
-            <ac:picMk id="7" creationId="{0C4A7D0B-1A59-4872-6B6E-30145F4D71E6}"/>
-          </ac:picMkLst>
-        </pc:picChg>
-        <pc:picChg chg="add del">
-          <ac:chgData name="Margo Bonal" userId="18c9fa0f-b53d-478b-9dc0-6ad88786c19f" providerId="ADAL" clId="{93D479E5-F67F-4B8A-A78F-A0B574A116B6}" dt="2026-04-09T13:06:36.319" v="3101" actId="26606"/>
-          <ac:picMkLst>
-            <pc:docMk/>
-            <pc:sldMk cId="532806018" sldId="279"/>
-            <ac:picMk id="9" creationId="{CD697151-E863-4AAC-BD2A-9DBA95DA5C40}"/>
-          </ac:picMkLst>
-        </pc:picChg>
-        <pc:picChg chg="add del">
-          <ac:chgData name="Margo Bonal" userId="18c9fa0f-b53d-478b-9dc0-6ad88786c19f" providerId="ADAL" clId="{93D479E5-F67F-4B8A-A78F-A0B574A116B6}" dt="2026-04-09T13:06:22.191" v="3099" actId="26606"/>
-          <ac:picMkLst>
-            <pc:docMk/>
-            <pc:sldMk cId="532806018" sldId="279"/>
-            <ac:picMk id="26" creationId="{0C4A7D0B-1A59-4872-6B6E-30145F4D71E6}"/>
-          </ac:picMkLst>
-        </pc:picChg>
-        <pc:picChg chg="add del">
-          <ac:chgData name="Margo Bonal" userId="18c9fa0f-b53d-478b-9dc0-6ad88786c19f" providerId="ADAL" clId="{93D479E5-F67F-4B8A-A78F-A0B574A116B6}" dt="2026-04-09T13:06:36.319" v="3101" actId="26606"/>
-          <ac:picMkLst>
-            <pc:docMk/>
-            <pc:sldMk cId="532806018" sldId="279"/>
-            <ac:picMk id="30" creationId="{C8B71412-8AFB-1168-32B0-73F1BE1953FA}"/>
-          </ac:picMkLst>
-        </pc:picChg>
-        <pc:cxnChg chg="add del">
-          <ac:chgData name="Margo Bonal" userId="18c9fa0f-b53d-478b-9dc0-6ad88786c19f" providerId="ADAL" clId="{93D479E5-F67F-4B8A-A78F-A0B574A116B6}" dt="2026-04-09T13:06:45.208" v="3103" actId="26606"/>
-          <ac:cxnSpMkLst>
-            <pc:docMk/>
-            <pc:sldMk cId="532806018" sldId="279"/>
-            <ac:cxnSpMk id="34" creationId="{266A0658-1CC4-4B0D-AAB7-A702286AFB03}"/>
-          </ac:cxnSpMkLst>
-        </pc:cxnChg>
         <pc:cxnChg chg="add">
           <ac:chgData name="Margo Bonal" userId="18c9fa0f-b53d-478b-9dc0-6ad88786c19f" providerId="ADAL" clId="{93D479E5-F67F-4B8A-A78F-A0B574A116B6}" dt="2026-04-09T13:06:45.235" v="3104" actId="26606"/>
           <ac:cxnSpMkLst>
@@ -933,126 +521,6 @@
             <pc:docMk/>
             <pc:sldMk cId="2474028920" sldId="280"/>
             <ac:spMk id="2" creationId="{B666C79B-15BD-0F1D-9881-740DA4CFFAB2}"/>
-          </ac:spMkLst>
-        </pc:spChg>
-        <pc:spChg chg="del mod">
-          <ac:chgData name="Margo Bonal" userId="18c9fa0f-b53d-478b-9dc0-6ad88786c19f" providerId="ADAL" clId="{93D479E5-F67F-4B8A-A78F-A0B574A116B6}" dt="2026-04-09T13:18:19.303" v="3267" actId="478"/>
-          <ac:spMkLst>
-            <pc:docMk/>
-            <pc:sldMk cId="2474028920" sldId="280"/>
-            <ac:spMk id="3" creationId="{08CB39A4-F3C4-3C83-E665-9F0433D826CA}"/>
-          </ac:spMkLst>
-        </pc:spChg>
-        <pc:spChg chg="add del">
-          <ac:chgData name="Margo Bonal" userId="18c9fa0f-b53d-478b-9dc0-6ad88786c19f" providerId="ADAL" clId="{93D479E5-F67F-4B8A-A78F-A0B574A116B6}" dt="2026-04-09T13:18:12.670" v="3266" actId="26606"/>
-          <ac:spMkLst>
-            <pc:docMk/>
-            <pc:sldMk cId="2474028920" sldId="280"/>
-            <ac:spMk id="12" creationId="{0855A890-B60B-4670-9DC2-69DC05015AB3}"/>
-          </ac:spMkLst>
-        </pc:spChg>
-        <pc:spChg chg="add del">
-          <ac:chgData name="Margo Bonal" userId="18c9fa0f-b53d-478b-9dc0-6ad88786c19f" providerId="ADAL" clId="{93D479E5-F67F-4B8A-A78F-A0B574A116B6}" dt="2026-04-09T13:18:12.670" v="3266" actId="26606"/>
-          <ac:spMkLst>
-            <pc:docMk/>
-            <pc:sldMk cId="2474028920" sldId="280"/>
-            <ac:spMk id="14" creationId="{90F533E9-6690-41A8-A372-4C6C622D028D}"/>
-          </ac:spMkLst>
-        </pc:spChg>
-        <pc:spChg chg="add del">
-          <ac:chgData name="Margo Bonal" userId="18c9fa0f-b53d-478b-9dc0-6ad88786c19f" providerId="ADAL" clId="{93D479E5-F67F-4B8A-A78F-A0B574A116B6}" dt="2026-04-09T13:18:12.670" v="3266" actId="26606"/>
-          <ac:spMkLst>
-            <pc:docMk/>
-            <pc:sldMk cId="2474028920" sldId="280"/>
-            <ac:spMk id="16" creationId="{99413ED5-9ED4-4772-BCE4-2BCAE6B12E35}"/>
-          </ac:spMkLst>
-        </pc:spChg>
-        <pc:spChg chg="add del">
-          <ac:chgData name="Margo Bonal" userId="18c9fa0f-b53d-478b-9dc0-6ad88786c19f" providerId="ADAL" clId="{93D479E5-F67F-4B8A-A78F-A0B574A116B6}" dt="2026-04-09T13:18:12.670" v="3266" actId="26606"/>
-          <ac:spMkLst>
-            <pc:docMk/>
-            <pc:sldMk cId="2474028920" sldId="280"/>
-            <ac:spMk id="18" creationId="{04357C93-F0CB-4A1C-8F77-4E9063789819}"/>
-          </ac:spMkLst>
-        </pc:spChg>
-        <pc:spChg chg="add del">
-          <ac:chgData name="Margo Bonal" userId="18c9fa0f-b53d-478b-9dc0-6ad88786c19f" providerId="ADAL" clId="{93D479E5-F67F-4B8A-A78F-A0B574A116B6}" dt="2026-04-09T13:18:00.843" v="3261" actId="26606"/>
-          <ac:spMkLst>
-            <pc:docMk/>
-            <pc:sldMk cId="2474028920" sldId="280"/>
-            <ac:spMk id="23" creationId="{18ED5DE8-CA8B-4332-9D76-60AD9B81830E}"/>
-          </ac:spMkLst>
-        </pc:spChg>
-        <pc:spChg chg="add del">
-          <ac:chgData name="Margo Bonal" userId="18c9fa0f-b53d-478b-9dc0-6ad88786c19f" providerId="ADAL" clId="{93D479E5-F67F-4B8A-A78F-A0B574A116B6}" dt="2026-04-09T13:18:12.647" v="3265" actId="26606"/>
-          <ac:spMkLst>
-            <pc:docMk/>
-            <pc:sldMk cId="2474028920" sldId="280"/>
-            <ac:spMk id="27" creationId="{99413ED5-9ED4-4772-BCE4-2BCAE6B12E35}"/>
-          </ac:spMkLst>
-        </pc:spChg>
-        <pc:spChg chg="add del">
-          <ac:chgData name="Margo Bonal" userId="18c9fa0f-b53d-478b-9dc0-6ad88786c19f" providerId="ADAL" clId="{93D479E5-F67F-4B8A-A78F-A0B574A116B6}" dt="2026-04-09T13:18:00.843" v="3261" actId="26606"/>
-          <ac:spMkLst>
-            <pc:docMk/>
-            <pc:sldMk cId="2474028920" sldId="280"/>
-            <ac:spMk id="29" creationId="{04357C93-F0CB-4A1C-8F77-4E9063789819}"/>
-          </ac:spMkLst>
-        </pc:spChg>
-        <pc:spChg chg="add del">
-          <ac:chgData name="Margo Bonal" userId="18c9fa0f-b53d-478b-9dc0-6ad88786c19f" providerId="ADAL" clId="{93D479E5-F67F-4B8A-A78F-A0B574A116B6}" dt="2026-04-09T13:18:03.410" v="3263" actId="26606"/>
-          <ac:spMkLst>
-            <pc:docMk/>
-            <pc:sldMk cId="2474028920" sldId="280"/>
-            <ac:spMk id="31" creationId="{6C9ECD1F-1B32-4E48-9736-A1BC9A3237E0}"/>
-          </ac:spMkLst>
-        </pc:spChg>
-        <pc:spChg chg="add del">
-          <ac:chgData name="Margo Bonal" userId="18c9fa0f-b53d-478b-9dc0-6ad88786c19f" providerId="ADAL" clId="{93D479E5-F67F-4B8A-A78F-A0B574A116B6}" dt="2026-04-09T13:18:03.410" v="3263" actId="26606"/>
-          <ac:spMkLst>
-            <pc:docMk/>
-            <pc:sldMk cId="2474028920" sldId="280"/>
-            <ac:spMk id="32" creationId="{90F533E9-6690-41A8-A372-4C6C622D028D}"/>
-          </ac:spMkLst>
-        </pc:spChg>
-        <pc:spChg chg="add del">
-          <ac:chgData name="Margo Bonal" userId="18c9fa0f-b53d-478b-9dc0-6ad88786c19f" providerId="ADAL" clId="{93D479E5-F67F-4B8A-A78F-A0B574A116B6}" dt="2026-04-09T13:18:03.410" v="3263" actId="26606"/>
-          <ac:spMkLst>
-            <pc:docMk/>
-            <pc:sldMk cId="2474028920" sldId="280"/>
-            <ac:spMk id="33" creationId="{99413ED5-9ED4-4772-BCE4-2BCAE6B12E35}"/>
-          </ac:spMkLst>
-        </pc:spChg>
-        <pc:spChg chg="add del">
-          <ac:chgData name="Margo Bonal" userId="18c9fa0f-b53d-478b-9dc0-6ad88786c19f" providerId="ADAL" clId="{93D479E5-F67F-4B8A-A78F-A0B574A116B6}" dt="2026-04-09T13:18:03.410" v="3263" actId="26606"/>
-          <ac:spMkLst>
-            <pc:docMk/>
-            <pc:sldMk cId="2474028920" sldId="280"/>
-            <ac:spMk id="34" creationId="{04357C93-F0CB-4A1C-8F77-4E9063789819}"/>
-          </ac:spMkLst>
-        </pc:spChg>
-        <pc:spChg chg="add del">
-          <ac:chgData name="Margo Bonal" userId="18c9fa0f-b53d-478b-9dc0-6ad88786c19f" providerId="ADAL" clId="{93D479E5-F67F-4B8A-A78F-A0B574A116B6}" dt="2026-04-09T13:18:12.647" v="3265" actId="26606"/>
-          <ac:spMkLst>
-            <pc:docMk/>
-            <pc:sldMk cId="2474028920" sldId="280"/>
-            <ac:spMk id="36" creationId="{0855A890-B60B-4670-9DC2-69DC05015AB3}"/>
-          </ac:spMkLst>
-        </pc:spChg>
-        <pc:spChg chg="add del">
-          <ac:chgData name="Margo Bonal" userId="18c9fa0f-b53d-478b-9dc0-6ad88786c19f" providerId="ADAL" clId="{93D479E5-F67F-4B8A-A78F-A0B574A116B6}" dt="2026-04-09T13:18:12.647" v="3265" actId="26606"/>
-          <ac:spMkLst>
-            <pc:docMk/>
-            <pc:sldMk cId="2474028920" sldId="280"/>
-            <ac:spMk id="37" creationId="{90F533E9-6690-41A8-A372-4C6C622D028D}"/>
-          </ac:spMkLst>
-        </pc:spChg>
-        <pc:spChg chg="add del">
-          <ac:chgData name="Margo Bonal" userId="18c9fa0f-b53d-478b-9dc0-6ad88786c19f" providerId="ADAL" clId="{93D479E5-F67F-4B8A-A78F-A0B574A116B6}" dt="2026-04-09T13:18:12.647" v="3265" actId="26606"/>
-          <ac:spMkLst>
-            <pc:docMk/>
-            <pc:sldMk cId="2474028920" sldId="280"/>
-            <ac:spMk id="38" creationId="{04357C93-F0CB-4A1C-8F77-4E9063789819}"/>
           </ac:spMkLst>
         </pc:spChg>
         <pc:spChg chg="add">
@@ -1142,102 +610,6 @@
             <ac:spMk id="3" creationId="{88E87286-C813-E53C-8EAF-C70AA9478D5A}"/>
           </ac:spMkLst>
         </pc:spChg>
-        <pc:spChg chg="add del">
-          <ac:chgData name="Margo Bonal" userId="18c9fa0f-b53d-478b-9dc0-6ad88786c19f" providerId="ADAL" clId="{93D479E5-F67F-4B8A-A78F-A0B574A116B6}" dt="2026-04-09T13:28:39.561" v="3684" actId="26606"/>
-          <ac:spMkLst>
-            <pc:docMk/>
-            <pc:sldMk cId="2582527457" sldId="281"/>
-            <ac:spMk id="7" creationId="{5E7AA7E8-8006-4E1F-A566-FCF37EE6F35D}"/>
-          </ac:spMkLst>
-        </pc:spChg>
-        <pc:spChg chg="add del">
-          <ac:chgData name="Margo Bonal" userId="18c9fa0f-b53d-478b-9dc0-6ad88786c19f" providerId="ADAL" clId="{93D479E5-F67F-4B8A-A78F-A0B574A116B6}" dt="2026-04-09T13:27:45.678" v="3680" actId="26606"/>
-          <ac:spMkLst>
-            <pc:docMk/>
-            <pc:sldMk cId="2582527457" sldId="281"/>
-            <ac:spMk id="8" creationId="{FFD48BC7-DC40-47DE-87EE-9F4B6ECB9ABB}"/>
-          </ac:spMkLst>
-        </pc:spChg>
-        <pc:spChg chg="add del">
-          <ac:chgData name="Margo Bonal" userId="18c9fa0f-b53d-478b-9dc0-6ad88786c19f" providerId="ADAL" clId="{93D479E5-F67F-4B8A-A78F-A0B574A116B6}" dt="2026-04-09T13:27:35.277" v="3674" actId="26606"/>
-          <ac:spMkLst>
-            <pc:docMk/>
-            <pc:sldMk cId="2582527457" sldId="281"/>
-            <ac:spMk id="9" creationId="{8DE2E8FE-B87B-430D-9722-167B5E2C2577}"/>
-          </ac:spMkLst>
-        </pc:spChg>
-        <pc:spChg chg="add del">
-          <ac:chgData name="Margo Bonal" userId="18c9fa0f-b53d-478b-9dc0-6ad88786c19f" providerId="ADAL" clId="{93D479E5-F67F-4B8A-A78F-A0B574A116B6}" dt="2026-04-09T13:27:45.678" v="3680" actId="26606"/>
-          <ac:spMkLst>
-            <pc:docMk/>
-            <pc:sldMk cId="2582527457" sldId="281"/>
-            <ac:spMk id="10" creationId="{E502BBC7-2C76-46F3-BC24-5985BC13DB88}"/>
-          </ac:spMkLst>
-        </pc:spChg>
-        <pc:spChg chg="add del">
-          <ac:chgData name="Margo Bonal" userId="18c9fa0f-b53d-478b-9dc0-6ad88786c19f" providerId="ADAL" clId="{93D479E5-F67F-4B8A-A78F-A0B574A116B6}" dt="2026-04-09T13:27:35.277" v="3674" actId="26606"/>
-          <ac:spMkLst>
-            <pc:docMk/>
-            <pc:sldMk cId="2582527457" sldId="281"/>
-            <ac:spMk id="11" creationId="{5E7AA7E8-8006-4E1F-A566-FCF37EE6F35D}"/>
-          </ac:spMkLst>
-        </pc:spChg>
-        <pc:spChg chg="add del">
-          <ac:chgData name="Margo Bonal" userId="18c9fa0f-b53d-478b-9dc0-6ad88786c19f" providerId="ADAL" clId="{93D479E5-F67F-4B8A-A78F-A0B574A116B6}" dt="2026-04-09T13:27:45.678" v="3680" actId="26606"/>
-          <ac:spMkLst>
-            <pc:docMk/>
-            <pc:sldMk cId="2582527457" sldId="281"/>
-            <ac:spMk id="12" creationId="{C7F28D52-2A5F-4D23-81AE-7CB8B591C7AF}"/>
-          </ac:spMkLst>
-        </pc:spChg>
-        <pc:spChg chg="add del">
-          <ac:chgData name="Margo Bonal" userId="18c9fa0f-b53d-478b-9dc0-6ad88786c19f" providerId="ADAL" clId="{93D479E5-F67F-4B8A-A78F-A0B574A116B6}" dt="2026-04-09T13:27:45.678" v="3680" actId="26606"/>
-          <ac:spMkLst>
-            <pc:docMk/>
-            <pc:sldMk cId="2582527457" sldId="281"/>
-            <ac:spMk id="14" creationId="{3629484E-3792-4B3D-89AD-7C8A1ED0E0D4}"/>
-          </ac:spMkLst>
-        </pc:spChg>
-        <pc:spChg chg="add del">
-          <ac:chgData name="Margo Bonal" userId="18c9fa0f-b53d-478b-9dc0-6ad88786c19f" providerId="ADAL" clId="{93D479E5-F67F-4B8A-A78F-A0B574A116B6}" dt="2026-04-09T13:28:39.536" v="3683" actId="26606"/>
-          <ac:spMkLst>
-            <pc:docMk/>
-            <pc:sldMk cId="2582527457" sldId="281"/>
-            <ac:spMk id="20" creationId="{88EB6E95-9C89-4CFF-A598-F278D0DFB39E}"/>
-          </ac:spMkLst>
-        </pc:spChg>
-        <pc:spChg chg="add del">
-          <ac:chgData name="Margo Bonal" userId="18c9fa0f-b53d-478b-9dc0-6ad88786c19f" providerId="ADAL" clId="{93D479E5-F67F-4B8A-A78F-A0B574A116B6}" dt="2026-04-09T13:28:39.536" v="3683" actId="26606"/>
-          <ac:spMkLst>
-            <pc:docMk/>
-            <pc:sldMk cId="2582527457" sldId="281"/>
-            <ac:spMk id="22" creationId="{474CD0F4-EA2A-4E5D-AE73-1112C1CA2A19}"/>
-          </ac:spMkLst>
-        </pc:spChg>
-        <pc:spChg chg="add del">
-          <ac:chgData name="Margo Bonal" userId="18c9fa0f-b53d-478b-9dc0-6ad88786c19f" providerId="ADAL" clId="{93D479E5-F67F-4B8A-A78F-A0B574A116B6}" dt="2026-04-09T13:28:52.291" v="3687" actId="26606"/>
-          <ac:spMkLst>
-            <pc:docMk/>
-            <pc:sldMk cId="2582527457" sldId="281"/>
-            <ac:spMk id="29" creationId="{35BB14B4-EC3F-47C7-9AF3-B0E017B75C42}"/>
-          </ac:spMkLst>
-        </pc:spChg>
-        <pc:spChg chg="add del">
-          <ac:chgData name="Margo Bonal" userId="18c9fa0f-b53d-478b-9dc0-6ad88786c19f" providerId="ADAL" clId="{93D479E5-F67F-4B8A-A78F-A0B574A116B6}" dt="2026-04-09T13:28:52.291" v="3687" actId="26606"/>
-          <ac:spMkLst>
-            <pc:docMk/>
-            <pc:sldMk cId="2582527457" sldId="281"/>
-            <ac:spMk id="36" creationId="{8E2CC403-21CD-41DF-BAC4-329D7FF03C5C}"/>
-          </ac:spMkLst>
-        </pc:spChg>
-        <pc:spChg chg="add del">
-          <ac:chgData name="Margo Bonal" userId="18c9fa0f-b53d-478b-9dc0-6ad88786c19f" providerId="ADAL" clId="{93D479E5-F67F-4B8A-A78F-A0B574A116B6}" dt="2026-04-09T13:28:52.291" v="3687" actId="26606"/>
-          <ac:spMkLst>
-            <pc:docMk/>
-            <pc:sldMk cId="2582527457" sldId="281"/>
-            <ac:spMk id="40" creationId="{7653717E-6F8C-43E0-9893-C03AE87D18D6}"/>
-          </ac:spMkLst>
-        </pc:spChg>
         <pc:spChg chg="add">
           <ac:chgData name="Margo Bonal" userId="18c9fa0f-b53d-478b-9dc0-6ad88786c19f" providerId="ADAL" clId="{93D479E5-F67F-4B8A-A78F-A0B574A116B6}" dt="2026-04-09T13:28:52.291" v="3687" actId="26606"/>
           <ac:spMkLst>
@@ -1262,62 +634,6 @@
             <ac:spMk id="49" creationId="{871AEA07-1E14-44B4-8E55-64EF049CD66F}"/>
           </ac:spMkLst>
         </pc:spChg>
-        <pc:grpChg chg="add del">
-          <ac:chgData name="Margo Bonal" userId="18c9fa0f-b53d-478b-9dc0-6ad88786c19f" providerId="ADAL" clId="{93D479E5-F67F-4B8A-A78F-A0B574A116B6}" dt="2026-04-09T13:28:39.536" v="3683" actId="26606"/>
-          <ac:grpSpMkLst>
-            <pc:docMk/>
-            <pc:sldMk cId="2582527457" sldId="281"/>
-            <ac:grpSpMk id="24" creationId="{A1EDC8FC-C3D1-4FE4-8E66-29767478DBDB}"/>
-          </ac:grpSpMkLst>
-        </pc:grpChg>
-        <pc:grpChg chg="add del">
-          <ac:chgData name="Margo Bonal" userId="18c9fa0f-b53d-478b-9dc0-6ad88786c19f" providerId="ADAL" clId="{93D479E5-F67F-4B8A-A78F-A0B574A116B6}" dt="2026-04-09T13:28:39.536" v="3683" actId="26606"/>
-          <ac:grpSpMkLst>
-            <pc:docMk/>
-            <pc:sldMk cId="2582527457" sldId="281"/>
-            <ac:grpSpMk id="30" creationId="{1BC136B2-4D8D-4561-95D5-56167F4116BD}"/>
-          </ac:grpSpMkLst>
-        </pc:grpChg>
-        <pc:grpChg chg="add del">
-          <ac:chgData name="Margo Bonal" userId="18c9fa0f-b53d-478b-9dc0-6ad88786c19f" providerId="ADAL" clId="{93D479E5-F67F-4B8A-A78F-A0B574A116B6}" dt="2026-04-09T13:28:52.291" v="3687" actId="26606"/>
-          <ac:grpSpMkLst>
-            <pc:docMk/>
-            <pc:sldMk cId="2582527457" sldId="281"/>
-            <ac:grpSpMk id="37" creationId="{B13AA5FE-3FFC-4725-9ADD-E428544EC61B}"/>
-          </ac:grpSpMkLst>
-        </pc:grpChg>
-        <pc:graphicFrameChg chg="add del">
-          <ac:chgData name="Margo Bonal" userId="18c9fa0f-b53d-478b-9dc0-6ad88786c19f" providerId="ADAL" clId="{93D479E5-F67F-4B8A-A78F-A0B574A116B6}" dt="2026-04-09T13:26:05.456" v="3551" actId="26606"/>
-          <ac:graphicFrameMkLst>
-            <pc:docMk/>
-            <pc:sldMk cId="2582527457" sldId="281"/>
-            <ac:graphicFrameMk id="5" creationId="{7906FA88-DCF7-474D-34F4-73224A3B638E}"/>
-          </ac:graphicFrameMkLst>
-        </pc:graphicFrameChg>
-        <pc:picChg chg="add del">
-          <ac:chgData name="Margo Bonal" userId="18c9fa0f-b53d-478b-9dc0-6ad88786c19f" providerId="ADAL" clId="{93D479E5-F67F-4B8A-A78F-A0B574A116B6}" dt="2026-04-09T13:27:35.277" v="3674" actId="26606"/>
-          <ac:picMkLst>
-            <pc:docMk/>
-            <pc:sldMk cId="2582527457" sldId="281"/>
-            <ac:picMk id="6" creationId="{2F63DFD2-0F9B-1880-7D5E-EF9CA9E975C0}"/>
-          </ac:picMkLst>
-        </pc:picChg>
-        <pc:cxnChg chg="add del">
-          <ac:chgData name="Margo Bonal" userId="18c9fa0f-b53d-478b-9dc0-6ad88786c19f" providerId="ADAL" clId="{93D479E5-F67F-4B8A-A78F-A0B574A116B6}" dt="2026-04-09T13:27:35.277" v="3674" actId="26606"/>
-          <ac:cxnSpMkLst>
-            <pc:docMk/>
-            <pc:sldMk cId="2582527457" sldId="281"/>
-            <ac:cxnSpMk id="13" creationId="{56020367-4FD5-4596-8E10-C5F095CD8DBF}"/>
-          </ac:cxnSpMkLst>
-        </pc:cxnChg>
-        <pc:cxnChg chg="add del">
-          <ac:chgData name="Margo Bonal" userId="18c9fa0f-b53d-478b-9dc0-6ad88786c19f" providerId="ADAL" clId="{93D479E5-F67F-4B8A-A78F-A0B574A116B6}" dt="2026-04-09T13:28:39.561" v="3684" actId="26606"/>
-          <ac:cxnSpMkLst>
-            <pc:docMk/>
-            <pc:sldMk cId="2582527457" sldId="281"/>
-            <ac:cxnSpMk id="15" creationId="{56020367-4FD5-4596-8E10-C5F095CD8DBF}"/>
-          </ac:cxnSpMkLst>
-        </pc:cxnChg>
         <pc:cxnChg chg="add">
           <ac:chgData name="Margo Bonal" userId="18c9fa0f-b53d-478b-9dc0-6ad88786c19f" providerId="ADAL" clId="{93D479E5-F67F-4B8A-A78F-A0B574A116B6}" dt="2026-04-09T13:28:52.291" v="3687" actId="26606"/>
           <ac:cxnSpMkLst>
@@ -1430,7 +746,7 @@
           <a:p>
             <a:fld id="{B1F2A6E6-BB86-4722-837C-048EA2408876}" type="datetimeFigureOut">
               <a:rPr lang="en-US" smtClean="0"/>
-              <a:t>4/9/2026</a:t>
+              <a:t>4/14/2026</a:t>
             </a:fld>
             <a:endParaRPr lang="en-US"/>
           </a:p>
@@ -1844,7 +1160,7 @@
           <a:p>
             <a:fld id="{C882E6FB-EB88-4936-BED9-9E37159958CA}" type="datetimeFigureOut">
               <a:rPr lang="en-US" smtClean="0"/>
-              <a:t>4/9/2026</a:t>
+              <a:t>4/14/2026</a:t>
             </a:fld>
             <a:endParaRPr lang="en-US"/>
           </a:p>
@@ -2042,7 +1358,7 @@
           <a:p>
             <a:fld id="{C882E6FB-EB88-4936-BED9-9E37159958CA}" type="datetimeFigureOut">
               <a:rPr lang="en-US" smtClean="0"/>
-              <a:t>4/9/2026</a:t>
+              <a:t>4/14/2026</a:t>
             </a:fld>
             <a:endParaRPr lang="en-US"/>
           </a:p>
@@ -2250,7 +1566,7 @@
           <a:p>
             <a:fld id="{C882E6FB-EB88-4936-BED9-9E37159958CA}" type="datetimeFigureOut">
               <a:rPr lang="en-US" smtClean="0"/>
-              <a:t>4/9/2026</a:t>
+              <a:t>4/14/2026</a:t>
             </a:fld>
             <a:endParaRPr lang="en-US"/>
           </a:p>
@@ -2448,7 +1764,7 @@
           <a:p>
             <a:fld id="{C882E6FB-EB88-4936-BED9-9E37159958CA}" type="datetimeFigureOut">
               <a:rPr lang="en-US" smtClean="0"/>
-              <a:t>4/9/2026</a:t>
+              <a:t>4/14/2026</a:t>
             </a:fld>
             <a:endParaRPr lang="en-US"/>
           </a:p>
@@ -2723,7 +2039,7 @@
           <a:p>
             <a:fld id="{C882E6FB-EB88-4936-BED9-9E37159958CA}" type="datetimeFigureOut">
               <a:rPr lang="en-US" smtClean="0"/>
-              <a:t>4/9/2026</a:t>
+              <a:t>4/14/2026</a:t>
             </a:fld>
             <a:endParaRPr lang="en-US"/>
           </a:p>
@@ -2988,7 +2304,7 @@
           <a:p>
             <a:fld id="{C882E6FB-EB88-4936-BED9-9E37159958CA}" type="datetimeFigureOut">
               <a:rPr lang="en-US" smtClean="0"/>
-              <a:t>4/9/2026</a:t>
+              <a:t>4/14/2026</a:t>
             </a:fld>
             <a:endParaRPr lang="en-US"/>
           </a:p>
@@ -3400,7 +2716,7 @@
           <a:p>
             <a:fld id="{C882E6FB-EB88-4936-BED9-9E37159958CA}" type="datetimeFigureOut">
               <a:rPr lang="en-US" smtClean="0"/>
-              <a:t>4/9/2026</a:t>
+              <a:t>4/14/2026</a:t>
             </a:fld>
             <a:endParaRPr lang="en-US"/>
           </a:p>
@@ -3541,7 +2857,7 @@
           <a:p>
             <a:fld id="{C882E6FB-EB88-4936-BED9-9E37159958CA}" type="datetimeFigureOut">
               <a:rPr lang="en-US" smtClean="0"/>
-              <a:t>4/9/2026</a:t>
+              <a:t>4/14/2026</a:t>
             </a:fld>
             <a:endParaRPr lang="en-US"/>
           </a:p>
@@ -3654,7 +2970,7 @@
           <a:p>
             <a:fld id="{C882E6FB-EB88-4936-BED9-9E37159958CA}" type="datetimeFigureOut">
               <a:rPr lang="en-US" smtClean="0"/>
-              <a:t>4/9/2026</a:t>
+              <a:t>4/14/2026</a:t>
             </a:fld>
             <a:endParaRPr lang="en-US"/>
           </a:p>
@@ -3965,7 +3281,7 @@
           <a:p>
             <a:fld id="{C882E6FB-EB88-4936-BED9-9E37159958CA}" type="datetimeFigureOut">
               <a:rPr lang="en-US" smtClean="0"/>
-              <a:t>4/9/2026</a:t>
+              <a:t>4/14/2026</a:t>
             </a:fld>
             <a:endParaRPr lang="en-US"/>
           </a:p>
@@ -4253,7 +3569,7 @@
           <a:p>
             <a:fld id="{C882E6FB-EB88-4936-BED9-9E37159958CA}" type="datetimeFigureOut">
               <a:rPr lang="en-US" smtClean="0"/>
-              <a:t>4/9/2026</a:t>
+              <a:t>4/14/2026</a:t>
             </a:fld>
             <a:endParaRPr lang="en-US"/>
           </a:p>
@@ -4494,7 +3810,7 @@
           <a:p>
             <a:fld id="{C882E6FB-EB88-4936-BED9-9E37159958CA}" type="datetimeFigureOut">
               <a:rPr lang="en-US" smtClean="0"/>
-              <a:t>4/9/2026</a:t>
+              <a:t>4/14/2026</a:t>
             </a:fld>
             <a:endParaRPr lang="en-US"/>
           </a:p>
@@ -8202,14 +7518,14 @@
           <p:nvPr>
             <p:extLst>
               <p:ext uri="{D42A27DB-BD31-4B8C-83A1-F6EECF244321}">
-                <p14:modId xmlns:p14="http://schemas.microsoft.com/office/powerpoint/2010/main" val="517662819"/>
+                <p14:modId xmlns:p14="http://schemas.microsoft.com/office/powerpoint/2010/main" val="2563126350"/>
               </p:ext>
             </p:extLst>
           </p:nvPr>
         </p:nvGraphicFramePr>
         <p:xfrm>
           <a:off x="2195502" y="3044990"/>
-          <a:ext cx="8128000" cy="2590800"/>
+          <a:ext cx="8128000" cy="2956560"/>
         </p:xfrm>
         <a:graphic>
           <a:graphicData uri="http://schemas.openxmlformats.org/drawingml/2006/table">
@@ -8658,6 +7974,83 @@
                   </a:ext>
                 </a:extLst>
               </a:tr>
+              <a:tr h="0">
+                <a:tc>
+                  <a:txBody>
+                    <a:bodyPr/>
+                    <a:lstStyle/>
+                    <a:p>
+                      <a:pPr marL="0" marR="0" lvl="0" indent="0" algn="l" defTabSz="914400" rtl="0" eaLnBrk="1" fontAlgn="auto" latinLnBrk="0" hangingPunct="1">
+                        <a:lnSpc>
+                          <a:spcPct val="100000"/>
+                        </a:lnSpc>
+                        <a:spcBef>
+                          <a:spcPts val="0"/>
+                        </a:spcBef>
+                        <a:spcAft>
+                          <a:spcPts val="0"/>
+                        </a:spcAft>
+                        <a:buClrTx/>
+                        <a:buSzTx/>
+                        <a:buFontTx/>
+                        <a:buNone/>
+                        <a:tabLst/>
+                        <a:defRPr/>
+                      </a:pPr>
+                      <a:r>
+                        <a:rPr lang="en-US" dirty="0" err="1"/>
+                        <a:t>MailerSend</a:t>
+                      </a:r>
+                      <a:r>
+                        <a:rPr lang="en-US" dirty="0"/>
+                        <a:t> Starter Subscription</a:t>
+                      </a:r>
+                    </a:p>
+                  </a:txBody>
+                  <a:tcPr>
+                    <a:lnL w="12700" cap="flat" cmpd="sng" algn="ctr">
+                      <a:solidFill>
+                        <a:schemeClr val="tx1"/>
+                      </a:solidFill>
+                      <a:prstDash val="solid"/>
+                      <a:round/>
+                      <a:headEnd type="none" w="med" len="med"/>
+                      <a:tailEnd type="none" w="med" len="med"/>
+                    </a:lnL>
+                  </a:tcPr>
+                </a:tc>
+                <a:tc>
+                  <a:txBody>
+                    <a:bodyPr/>
+                    <a:lstStyle/>
+                    <a:p>
+                      <a:pPr>
+                        <a:buNone/>
+                      </a:pPr>
+                      <a:r>
+                        <a:rPr lang="en-US" dirty="0"/>
+                        <a:t>$28</a:t>
+                      </a:r>
+                    </a:p>
+                  </a:txBody>
+                  <a:tcPr anchor="ctr">
+                    <a:lnR w="12700" cap="flat" cmpd="sng" algn="ctr">
+                      <a:solidFill>
+                        <a:schemeClr val="tx1"/>
+                      </a:solidFill>
+                      <a:prstDash val="solid"/>
+                      <a:round/>
+                      <a:headEnd type="none" w="med" len="med"/>
+                      <a:tailEnd type="none" w="med" len="med"/>
+                    </a:lnR>
+                  </a:tcPr>
+                </a:tc>
+                <a:extLst>
+                  <a:ext uri="{0D108BD9-81ED-4DB2-BD59-A6C34878D82A}">
+                    <a16:rowId xmlns:a16="http://schemas.microsoft.com/office/drawing/2014/main" val="2062421038"/>
+                  </a:ext>
+                </a:extLst>
+              </a:tr>
               <a:tr h="370840">
                 <a:tc>
                   <a:txBody>
@@ -8715,7 +8108,7 @@
                     <a:p>
                       <a:r>
                         <a:rPr lang="en-US" dirty="0"/>
-                        <a:t>$27 – $61</a:t>
+                        <a:t>$55 – $89</a:t>
                       </a:r>
                     </a:p>
                   </a:txBody>

</xml_diff>

<commit_message>
add render img, lol forgot to push
</commit_message>
<xml_diff>
--- a/Documentation/FinalPresentation/VulcanActivityTracker-Group2.pptx
+++ b/Documentation/FinalPresentation/VulcanActivityTracker-Group2.pptx
@@ -123,6 +123,14 @@
 </p:presentation>
 </file>
 
+<file path=ppt/revisionInfo.xml><?xml version="1.0" encoding="utf-8"?>
+<p1510:revInfo xmlns:a="http://schemas.openxmlformats.org/drawingml/2006/main" xmlns:r="http://schemas.openxmlformats.org/officeDocument/2006/relationships" xmlns:p1510="http://schemas.microsoft.com/office/powerpoint/2015/10/main">
+  <p1510:revLst>
+    <p1510:client id="{378BD0A3-E72A-4148-9985-93B00B834DD1}" v="1" dt="2026-04-16T14:00:22.771"/>
+  </p1510:revLst>
+</p1510:revInfo>
+</file>
+
 <file path=ppt/changesInfos/changesInfo1.xml><?xml version="1.0" encoding="utf-8"?>
 <pc:chgInfo xmlns:a="http://schemas.openxmlformats.org/drawingml/2006/main" xmlns:r="http://schemas.openxmlformats.org/officeDocument/2006/relationships" xmlns:ac="http://schemas.microsoft.com/office/drawing/2013/main/command" xmlns:pc="http://schemas.microsoft.com/office/powerpoint/2013/main/command">
   <pc:docChgLst>
@@ -159,7 +167,7 @@
   <pc:docChgLst>
     <pc:chgData name="Margo Bonal" userId="18c9fa0f-b53d-478b-9dc0-6ad88786c19f" providerId="ADAL" clId="{93D479E5-F67F-4B8A-A78F-A0B574A116B6}"/>
     <pc:docChg chg="undo redo custSel addSld delSld modSld sldOrd addSection delSection">
-      <pc:chgData name="Margo Bonal" userId="18c9fa0f-b53d-478b-9dc0-6ad88786c19f" providerId="ADAL" clId="{93D479E5-F67F-4B8A-A78F-A0B574A116B6}" dt="2026-04-09T13:36:42.127" v="3827"/>
+      <pc:chgData name="Margo Bonal" userId="18c9fa0f-b53d-478b-9dc0-6ad88786c19f" providerId="ADAL" clId="{93D479E5-F67F-4B8A-A78F-A0B574A116B6}" dt="2026-04-16T14:00:34.226" v="3829" actId="1076"/>
       <pc:docMkLst>
         <pc:docMk/>
       </pc:docMkLst>
@@ -510,7 +518,7 @@
         </pc:cxnChg>
       </pc:sldChg>
       <pc:sldChg chg="addSp delSp modSp new mod setBg">
-        <pc:chgData name="Margo Bonal" userId="18c9fa0f-b53d-478b-9dc0-6ad88786c19f" providerId="ADAL" clId="{93D479E5-F67F-4B8A-A78F-A0B574A116B6}" dt="2026-04-09T13:18:19.303" v="3267" actId="478"/>
+        <pc:chgData name="Margo Bonal" userId="18c9fa0f-b53d-478b-9dc0-6ad88786c19f" providerId="ADAL" clId="{93D479E5-F67F-4B8A-A78F-A0B574A116B6}" dt="2026-04-16T14:00:34.226" v="3829" actId="1076"/>
         <pc:sldMkLst>
           <pc:docMk/>
           <pc:sldMk cId="2474028920" sldId="280"/>
@@ -555,6 +563,14 @@
             <ac:spMk id="44" creationId="{DCBE52EF-2889-423F-947C-0E44A760D696}"/>
           </ac:spMkLst>
         </pc:spChg>
+        <pc:picChg chg="add mod">
+          <ac:chgData name="Margo Bonal" userId="18c9fa0f-b53d-478b-9dc0-6ad88786c19f" providerId="ADAL" clId="{93D479E5-F67F-4B8A-A78F-A0B574A116B6}" dt="2026-04-16T14:00:34.226" v="3829" actId="1076"/>
+          <ac:picMkLst>
+            <pc:docMk/>
+            <pc:sldMk cId="2474028920" sldId="280"/>
+            <ac:picMk id="3" creationId="{0F1D920F-0BAE-D0DE-A928-BA4537274DDF}"/>
+          </ac:picMkLst>
+        </pc:picChg>
         <pc:picChg chg="add mod ord">
           <ac:chgData name="Margo Bonal" userId="18c9fa0f-b53d-478b-9dc0-6ad88786c19f" providerId="ADAL" clId="{93D479E5-F67F-4B8A-A78F-A0B574A116B6}" dt="2026-04-09T13:18:00.843" v="3261" actId="26606"/>
           <ac:picMkLst>
@@ -746,7 +762,7 @@
           <a:p>
             <a:fld id="{B1F2A6E6-BB86-4722-837C-048EA2408876}" type="datetimeFigureOut">
               <a:rPr lang="en-US" smtClean="0"/>
-              <a:t>4/14/2026</a:t>
+              <a:t>4/16/2026</a:t>
             </a:fld>
             <a:endParaRPr lang="en-US"/>
           </a:p>
@@ -1160,7 +1176,7 @@
           <a:p>
             <a:fld id="{C882E6FB-EB88-4936-BED9-9E37159958CA}" type="datetimeFigureOut">
               <a:rPr lang="en-US" smtClean="0"/>
-              <a:t>4/14/2026</a:t>
+              <a:t>4/16/2026</a:t>
             </a:fld>
             <a:endParaRPr lang="en-US"/>
           </a:p>
@@ -1358,7 +1374,7 @@
           <a:p>
             <a:fld id="{C882E6FB-EB88-4936-BED9-9E37159958CA}" type="datetimeFigureOut">
               <a:rPr lang="en-US" smtClean="0"/>
-              <a:t>4/14/2026</a:t>
+              <a:t>4/16/2026</a:t>
             </a:fld>
             <a:endParaRPr lang="en-US"/>
           </a:p>
@@ -1566,7 +1582,7 @@
           <a:p>
             <a:fld id="{C882E6FB-EB88-4936-BED9-9E37159958CA}" type="datetimeFigureOut">
               <a:rPr lang="en-US" smtClean="0"/>
-              <a:t>4/14/2026</a:t>
+              <a:t>4/16/2026</a:t>
             </a:fld>
             <a:endParaRPr lang="en-US"/>
           </a:p>
@@ -1764,7 +1780,7 @@
           <a:p>
             <a:fld id="{C882E6FB-EB88-4936-BED9-9E37159958CA}" type="datetimeFigureOut">
               <a:rPr lang="en-US" smtClean="0"/>
-              <a:t>4/14/2026</a:t>
+              <a:t>4/16/2026</a:t>
             </a:fld>
             <a:endParaRPr lang="en-US"/>
           </a:p>
@@ -2039,7 +2055,7 @@
           <a:p>
             <a:fld id="{C882E6FB-EB88-4936-BED9-9E37159958CA}" type="datetimeFigureOut">
               <a:rPr lang="en-US" smtClean="0"/>
-              <a:t>4/14/2026</a:t>
+              <a:t>4/16/2026</a:t>
             </a:fld>
             <a:endParaRPr lang="en-US"/>
           </a:p>
@@ -2304,7 +2320,7 @@
           <a:p>
             <a:fld id="{C882E6FB-EB88-4936-BED9-9E37159958CA}" type="datetimeFigureOut">
               <a:rPr lang="en-US" smtClean="0"/>
-              <a:t>4/14/2026</a:t>
+              <a:t>4/16/2026</a:t>
             </a:fld>
             <a:endParaRPr lang="en-US"/>
           </a:p>
@@ -2716,7 +2732,7 @@
           <a:p>
             <a:fld id="{C882E6FB-EB88-4936-BED9-9E37159958CA}" type="datetimeFigureOut">
               <a:rPr lang="en-US" smtClean="0"/>
-              <a:t>4/14/2026</a:t>
+              <a:t>4/16/2026</a:t>
             </a:fld>
             <a:endParaRPr lang="en-US"/>
           </a:p>
@@ -2857,7 +2873,7 @@
           <a:p>
             <a:fld id="{C882E6FB-EB88-4936-BED9-9E37159958CA}" type="datetimeFigureOut">
               <a:rPr lang="en-US" smtClean="0"/>
-              <a:t>4/14/2026</a:t>
+              <a:t>4/16/2026</a:t>
             </a:fld>
             <a:endParaRPr lang="en-US"/>
           </a:p>
@@ -2970,7 +2986,7 @@
           <a:p>
             <a:fld id="{C882E6FB-EB88-4936-BED9-9E37159958CA}" type="datetimeFigureOut">
               <a:rPr lang="en-US" smtClean="0"/>
-              <a:t>4/14/2026</a:t>
+              <a:t>4/16/2026</a:t>
             </a:fld>
             <a:endParaRPr lang="en-US"/>
           </a:p>
@@ -3281,7 +3297,7 @@
           <a:p>
             <a:fld id="{C882E6FB-EB88-4936-BED9-9E37159958CA}" type="datetimeFigureOut">
               <a:rPr lang="en-US" smtClean="0"/>
-              <a:t>4/14/2026</a:t>
+              <a:t>4/16/2026</a:t>
             </a:fld>
             <a:endParaRPr lang="en-US"/>
           </a:p>
@@ -3569,7 +3585,7 @@
           <a:p>
             <a:fld id="{C882E6FB-EB88-4936-BED9-9E37159958CA}" type="datetimeFigureOut">
               <a:rPr lang="en-US" smtClean="0"/>
-              <a:t>4/14/2026</a:t>
+              <a:t>4/16/2026</a:t>
             </a:fld>
             <a:endParaRPr lang="en-US"/>
           </a:p>
@@ -3810,7 +3826,7 @@
           <a:p>
             <a:fld id="{C882E6FB-EB88-4936-BED9-9E37159958CA}" type="datetimeFigureOut">
               <a:rPr lang="en-US" smtClean="0"/>
-              <a:t>4/14/2026</a:t>
+              <a:t>4/16/2026</a:t>
             </a:fld>
             <a:endParaRPr lang="en-US"/>
           </a:p>
@@ -5812,6 +5828,37 @@
               </a14:hiddenFill>
             </a:ext>
           </a:extLst>
+        </p:spPr>
+      </p:pic>
+      <p:pic>
+        <p:nvPicPr>
+          <p:cNvPr id="3" name="Picture 2">
+            <a:extLst>
+              <a:ext uri="{FF2B5EF4-FFF2-40B4-BE49-F238E27FC236}">
+                <a16:creationId xmlns:a16="http://schemas.microsoft.com/office/drawing/2014/main" id="{0F1D920F-0BAE-D0DE-A928-BA4537274DDF}"/>
+              </a:ext>
+            </a:extLst>
+          </p:cNvPr>
+          <p:cNvPicPr>
+            <a:picLocks noChangeAspect="1"/>
+          </p:cNvPicPr>
+          <p:nvPr/>
+        </p:nvPicPr>
+        <p:blipFill>
+          <a:blip r:embed="rId6"/>
+          <a:srcRect t="35218" b="34796"/>
+          <a:stretch>
+            <a:fillRect/>
+          </a:stretch>
+        </p:blipFill>
+        <p:spPr>
+          <a:xfrm>
+            <a:off x="6746111" y="5673235"/>
+            <a:ext cx="3728977" cy="1118166"/>
+          </a:xfrm>
+          <a:prstGeom prst="rect">
+            <a:avLst/>
+          </a:prstGeom>
         </p:spPr>
       </p:pic>
     </p:spTree>

</xml_diff>

<commit_message>
final slide revison pyz recomendations
</commit_message>
<xml_diff>
--- a/Documentation/FinalPresentation/VulcanActivityTracker-Group2.pptx
+++ b/Documentation/FinalPresentation/VulcanActivityTracker-Group2.pptx
@@ -5,10 +5,10 @@
     <p:sldMasterId id="2147483648" r:id="rId1"/>
   </p:sldMasterIdLst>
   <p:notesMasterIdLst>
-    <p:notesMasterId r:id="rId11"/>
+    <p:notesMasterId r:id="rId12"/>
   </p:notesMasterIdLst>
   <p:handoutMasterIdLst>
-    <p:handoutMasterId r:id="rId12"/>
+    <p:handoutMasterId r:id="rId13"/>
   </p:handoutMasterIdLst>
   <p:sldIdLst>
     <p:sldId id="256" r:id="rId2"/>
@@ -19,7 +19,8 @@
     <p:sldId id="259" r:id="rId7"/>
     <p:sldId id="279" r:id="rId8"/>
     <p:sldId id="275" r:id="rId9"/>
-    <p:sldId id="278" r:id="rId10"/>
+    <p:sldId id="286" r:id="rId10"/>
+    <p:sldId id="278" r:id="rId11"/>
   </p:sldIdLst>
   <p:sldSz cx="12192000" cy="6858000"/>
   <p:notesSz cx="6858000" cy="9144000"/>
@@ -130,6 +131,7 @@
 <p1510:revInfo xmlns:a="http://schemas.openxmlformats.org/drawingml/2006/main" xmlns:r="http://schemas.openxmlformats.org/officeDocument/2006/relationships" xmlns:p1510="http://schemas.microsoft.com/office/powerpoint/2015/10/main">
   <p1510:revLst>
     <p1510:client id="{378BD0A3-E72A-4148-9985-93B00B834DD1}" v="38" dt="2026-04-23T17:28:29.484"/>
+    <p1510:client id="{C2FA33C1-F523-4383-BC77-0B58484EDADC}" v="47" dt="2026-04-24T14:17:33.929"/>
   </p1510:revLst>
 </p1510:revInfo>
 </file>
@@ -243,14 +245,6 @@
             <ac:spMk id="5" creationId="{331CE70E-6CCB-81A3-9CE7-F5BEF0B6CA1C}"/>
           </ac:spMkLst>
         </pc:spChg>
-        <pc:spChg chg="add mod">
-          <ac:chgData name="Margo Bonal" userId="18c9fa0f-b53d-478b-9dc0-6ad88786c19f" providerId="ADAL" clId="{93D479E5-F67F-4B8A-A78F-A0B574A116B6}" dt="2026-03-30T21:23:47.482" v="987" actId="478"/>
-          <ac:spMkLst>
-            <pc:docMk/>
-            <pc:sldMk cId="3713997872" sldId="259"/>
-            <ac:spMk id="8" creationId="{243C43E9-308C-3F97-571D-4B2588459719}"/>
-          </ac:spMkLst>
-        </pc:spChg>
         <pc:picChg chg="add mod">
           <ac:chgData name="Margo Bonal" userId="18c9fa0f-b53d-478b-9dc0-6ad88786c19f" providerId="ADAL" clId="{93D479E5-F67F-4B8A-A78F-A0B574A116B6}" dt="2026-03-30T21:56:07.063" v="2111" actId="14100"/>
           <ac:picMkLst>
@@ -408,14 +402,6 @@
             <ac:spMk id="2" creationId="{153C799C-4835-C8CB-B090-70E82B558CED}"/>
           </ac:spMkLst>
         </pc:spChg>
-        <pc:spChg chg="add mod">
-          <ac:chgData name="Margo Bonal" userId="18c9fa0f-b53d-478b-9dc0-6ad88786c19f" providerId="ADAL" clId="{93D479E5-F67F-4B8A-A78F-A0B574A116B6}" dt="2026-04-09T13:34:23.453" v="3806" actId="27636"/>
-          <ac:spMkLst>
-            <pc:docMk/>
-            <pc:sldMk cId="3773506301" sldId="278"/>
-            <ac:spMk id="4" creationId="{B7AD252D-6AEF-5D34-92C0-C2F37203AEB8}"/>
-          </ac:spMkLst>
-        </pc:spChg>
         <pc:spChg chg="add del mod">
           <ac:chgData name="Margo Bonal" userId="18c9fa0f-b53d-478b-9dc0-6ad88786c19f" providerId="ADAL" clId="{93D479E5-F67F-4B8A-A78F-A0B574A116B6}" dt="2026-04-23T17:16:33.163" v="4140" actId="478"/>
           <ac:spMkLst>
@@ -770,18 +756,1203 @@
   </pc:docChgLst>
   <pc:docChgLst>
     <pc:chgData name="Margo Bonal" userId="18c9fa0f-b53d-478b-9dc0-6ad88786c19f" providerId="ADAL" clId="{57E2D5E0-CA32-47BE-A2DC-7B0365E99328}"/>
-    <pc:docChg chg="undo custSel addSld delSld modSld sldOrd">
-      <pc:chgData name="Margo Bonal" userId="18c9fa0f-b53d-478b-9dc0-6ad88786c19f" providerId="ADAL" clId="{57E2D5E0-CA32-47BE-A2DC-7B0365E99328}" dt="2026-03-28T15:16:48.747" v="374" actId="9405"/>
+    <pc:docChg chg="undo custSel addSld delSld modSld sldOrd modMainMaster">
+      <pc:chgData name="Margo Bonal" userId="18c9fa0f-b53d-478b-9dc0-6ad88786c19f" providerId="ADAL" clId="{57E2D5E0-CA32-47BE-A2DC-7B0365E99328}" dt="2026-04-24T14:17:59.695" v="1153" actId="26606"/>
       <pc:docMkLst>
         <pc:docMk/>
       </pc:docMkLst>
-      <pc:sldChg chg="modSp mod">
-        <pc:chgData name="Margo Bonal" userId="18c9fa0f-b53d-478b-9dc0-6ad88786c19f" providerId="ADAL" clId="{57E2D5E0-CA32-47BE-A2DC-7B0365E99328}" dt="2026-03-28T15:09:10.496" v="233" actId="20577"/>
+      <pc:sldChg chg="setBg">
+        <pc:chgData name="Margo Bonal" userId="18c9fa0f-b53d-478b-9dc0-6ad88786c19f" providerId="ADAL" clId="{57E2D5E0-CA32-47BE-A2DC-7B0365E99328}" dt="2026-04-24T13:54:46.104" v="857"/>
+        <pc:sldMkLst>
+          <pc:docMk/>
+          <pc:sldMk cId="1562194928" sldId="256"/>
+        </pc:sldMkLst>
+      </pc:sldChg>
+      <pc:sldChg chg="modSp mod setBg">
+        <pc:chgData name="Margo Bonal" userId="18c9fa0f-b53d-478b-9dc0-6ad88786c19f" providerId="ADAL" clId="{57E2D5E0-CA32-47BE-A2DC-7B0365E99328}" dt="2026-04-24T13:54:46.104" v="857"/>
+        <pc:sldMkLst>
+          <pc:docMk/>
+          <pc:sldMk cId="850630602" sldId="257"/>
+        </pc:sldMkLst>
+        <pc:spChg chg="mod">
+          <ac:chgData name="Margo Bonal" userId="18c9fa0f-b53d-478b-9dc0-6ad88786c19f" providerId="ADAL" clId="{57E2D5E0-CA32-47BE-A2DC-7B0365E99328}" dt="2026-04-24T13:23:06.260" v="392" actId="20577"/>
+          <ac:spMkLst>
+            <pc:docMk/>
+            <pc:sldMk cId="850630602" sldId="257"/>
+            <ac:spMk id="2" creationId="{F4D47601-A3D5-5EAD-C1BB-4EBE55051F15}"/>
+          </ac:spMkLst>
+        </pc:spChg>
+        <pc:spChg chg="mod">
+          <ac:chgData name="Margo Bonal" userId="18c9fa0f-b53d-478b-9dc0-6ad88786c19f" providerId="ADAL" clId="{57E2D5E0-CA32-47BE-A2DC-7B0365E99328}" dt="2026-04-24T13:23:44.085" v="446" actId="20577"/>
+          <ac:spMkLst>
+            <pc:docMk/>
+            <pc:sldMk cId="850630602" sldId="257"/>
+            <ac:spMk id="3" creationId="{3AD821AA-AA04-E3EB-5027-44FA0EFD591D}"/>
+          </ac:spMkLst>
+        </pc:spChg>
+      </pc:sldChg>
+      <pc:sldChg chg="addSp delSp modSp mod setBg">
+        <pc:chgData name="Margo Bonal" userId="18c9fa0f-b53d-478b-9dc0-6ad88786c19f" providerId="ADAL" clId="{57E2D5E0-CA32-47BE-A2DC-7B0365E99328}" dt="2026-04-24T14:07:14.763" v="995" actId="27636"/>
+        <pc:sldMkLst>
+          <pc:docMk/>
+          <pc:sldMk cId="3713997872" sldId="259"/>
+        </pc:sldMkLst>
+        <pc:spChg chg="add mod">
+          <ac:chgData name="Margo Bonal" userId="18c9fa0f-b53d-478b-9dc0-6ad88786c19f" providerId="ADAL" clId="{57E2D5E0-CA32-47BE-A2DC-7B0365E99328}" dt="2026-04-24T14:07:14.763" v="995" actId="27636"/>
+          <ac:spMkLst>
+            <pc:docMk/>
+            <pc:sldMk cId="3713997872" sldId="259"/>
+            <ac:spMk id="3" creationId="{5DF54A17-E1B3-F303-456C-DA742E6BC8C0}"/>
+          </ac:spMkLst>
+        </pc:spChg>
+        <pc:spChg chg="del mod">
+          <ac:chgData name="Margo Bonal" userId="18c9fa0f-b53d-478b-9dc0-6ad88786c19f" providerId="ADAL" clId="{57E2D5E0-CA32-47BE-A2DC-7B0365E99328}" dt="2026-04-24T13:48:16.709" v="756" actId="478"/>
+          <ac:spMkLst>
+            <pc:docMk/>
+            <pc:sldMk cId="3713997872" sldId="259"/>
+            <ac:spMk id="8" creationId="{243C43E9-308C-3F97-571D-4B2588459719}"/>
+          </ac:spMkLst>
+        </pc:spChg>
+        <pc:picChg chg="mod">
+          <ac:chgData name="Margo Bonal" userId="18c9fa0f-b53d-478b-9dc0-6ad88786c19f" providerId="ADAL" clId="{57E2D5E0-CA32-47BE-A2DC-7B0365E99328}" dt="2026-04-24T14:07:05.115" v="993" actId="1076"/>
+          <ac:picMkLst>
+            <pc:docMk/>
+            <pc:sldMk cId="3713997872" sldId="259"/>
+            <ac:picMk id="9" creationId="{5C02B36E-6D51-126E-4A69-0F52E1A3FB24}"/>
+          </ac:picMkLst>
+        </pc:picChg>
+      </pc:sldChg>
+      <pc:sldChg chg="modSp mod setBg">
+        <pc:chgData name="Margo Bonal" userId="18c9fa0f-b53d-478b-9dc0-6ad88786c19f" providerId="ADAL" clId="{57E2D5E0-CA32-47BE-A2DC-7B0365E99328}" dt="2026-04-24T13:54:46.104" v="857"/>
         <pc:sldMkLst>
           <pc:docMk/>
           <pc:sldMk cId="2561402868" sldId="264"/>
         </pc:sldMkLst>
       </pc:sldChg>
+      <pc:sldChg chg="modSp mod setBg">
+        <pc:chgData name="Margo Bonal" userId="18c9fa0f-b53d-478b-9dc0-6ad88786c19f" providerId="ADAL" clId="{57E2D5E0-CA32-47BE-A2DC-7B0365E99328}" dt="2026-04-24T13:54:46.104" v="857"/>
+        <pc:sldMkLst>
+          <pc:docMk/>
+          <pc:sldMk cId="606434410" sldId="275"/>
+        </pc:sldMkLst>
+        <pc:graphicFrameChg chg="modGraphic">
+          <ac:chgData name="Margo Bonal" userId="18c9fa0f-b53d-478b-9dc0-6ad88786c19f" providerId="ADAL" clId="{57E2D5E0-CA32-47BE-A2DC-7B0365E99328}" dt="2026-04-24T13:44:14.296" v="701" actId="20577"/>
+          <ac:graphicFrameMkLst>
+            <pc:docMk/>
+            <pc:sldMk cId="606434410" sldId="275"/>
+            <ac:graphicFrameMk id="6" creationId="{27EACA2E-750E-36F7-A7AE-14DB1D64E678}"/>
+          </ac:graphicFrameMkLst>
+        </pc:graphicFrameChg>
+      </pc:sldChg>
+      <pc:sldChg chg="addSp delSp modSp mod ord setBg">
+        <pc:chgData name="Margo Bonal" userId="18c9fa0f-b53d-478b-9dc0-6ad88786c19f" providerId="ADAL" clId="{57E2D5E0-CA32-47BE-A2DC-7B0365E99328}" dt="2026-04-24T14:16:08.580" v="1117" actId="403"/>
+        <pc:sldMkLst>
+          <pc:docMk/>
+          <pc:sldMk cId="3773506301" sldId="278"/>
+        </pc:sldMkLst>
+        <pc:spChg chg="mod">
+          <ac:chgData name="Margo Bonal" userId="18c9fa0f-b53d-478b-9dc0-6ad88786c19f" providerId="ADAL" clId="{57E2D5E0-CA32-47BE-A2DC-7B0365E99328}" dt="2026-04-24T14:16:08.580" v="1117" actId="403"/>
+          <ac:spMkLst>
+            <pc:docMk/>
+            <pc:sldMk cId="3773506301" sldId="278"/>
+            <ac:spMk id="2" creationId="{153C799C-4835-C8CB-B090-70E82B558CED}"/>
+          </ac:spMkLst>
+        </pc:spChg>
+        <pc:spChg chg="del">
+          <ac:chgData name="Margo Bonal" userId="18c9fa0f-b53d-478b-9dc0-6ad88786c19f" providerId="ADAL" clId="{57E2D5E0-CA32-47BE-A2DC-7B0365E99328}" dt="2026-04-24T13:49:25.665" v="768" actId="478"/>
+          <ac:spMkLst>
+            <pc:docMk/>
+            <pc:sldMk cId="3773506301" sldId="278"/>
+            <ac:spMk id="4" creationId="{B7AD252D-6AEF-5D34-92C0-C2F37203AEB8}"/>
+          </ac:spMkLst>
+        </pc:spChg>
+        <pc:spChg chg="add del mod">
+          <ac:chgData name="Margo Bonal" userId="18c9fa0f-b53d-478b-9dc0-6ad88786c19f" providerId="ADAL" clId="{57E2D5E0-CA32-47BE-A2DC-7B0365E99328}" dt="2026-04-24T13:52:46.194" v="833" actId="478"/>
+          <ac:spMkLst>
+            <pc:docMk/>
+            <pc:sldMk cId="3773506301" sldId="278"/>
+            <ac:spMk id="5" creationId="{631D97D9-F2CF-CE18-F07B-21DBCD200E93}"/>
+          </ac:spMkLst>
+        </pc:spChg>
+        <pc:spChg chg="del">
+          <ac:chgData name="Margo Bonal" userId="18c9fa0f-b53d-478b-9dc0-6ad88786c19f" providerId="ADAL" clId="{57E2D5E0-CA32-47BE-A2DC-7B0365E99328}" dt="2026-04-24T13:20:58.019" v="377" actId="21"/>
+          <ac:spMkLst>
+            <pc:docMk/>
+            <pc:sldMk cId="3773506301" sldId="278"/>
+            <ac:spMk id="6" creationId="{58B38568-C5E6-EDF1-6A58-E97B3EF311B9}"/>
+          </ac:spMkLst>
+        </pc:spChg>
+        <pc:spChg chg="add del mod">
+          <ac:chgData name="Margo Bonal" userId="18c9fa0f-b53d-478b-9dc0-6ad88786c19f" providerId="ADAL" clId="{57E2D5E0-CA32-47BE-A2DC-7B0365E99328}" dt="2026-04-24T13:52:43.220" v="831" actId="478"/>
+          <ac:spMkLst>
+            <pc:docMk/>
+            <pc:sldMk cId="3773506301" sldId="278"/>
+            <ac:spMk id="8" creationId="{EA426327-080E-D6DC-5429-A7B7570CC266}"/>
+          </ac:spMkLst>
+        </pc:spChg>
+        <pc:spChg chg="del mod">
+          <ac:chgData name="Margo Bonal" userId="18c9fa0f-b53d-478b-9dc0-6ad88786c19f" providerId="ADAL" clId="{57E2D5E0-CA32-47BE-A2DC-7B0365E99328}" dt="2026-04-24T13:20:55.583" v="376" actId="21"/>
+          <ac:spMkLst>
+            <pc:docMk/>
+            <pc:sldMk cId="3773506301" sldId="278"/>
+            <ac:spMk id="10" creationId="{B6A5AF98-EEC8-FE54-703A-15987C5508C2}"/>
+          </ac:spMkLst>
+        </pc:spChg>
+        <pc:spChg chg="add del mod">
+          <ac:chgData name="Margo Bonal" userId="18c9fa0f-b53d-478b-9dc0-6ad88786c19f" providerId="ADAL" clId="{57E2D5E0-CA32-47BE-A2DC-7B0365E99328}" dt="2026-04-24T13:52:48.137" v="834" actId="478"/>
+          <ac:spMkLst>
+            <pc:docMk/>
+            <pc:sldMk cId="3773506301" sldId="278"/>
+            <ac:spMk id="13" creationId="{1C4C850A-583D-D196-B5D7-40C5935759EE}"/>
+          </ac:spMkLst>
+        </pc:spChg>
+        <pc:spChg chg="add mod">
+          <ac:chgData name="Margo Bonal" userId="18c9fa0f-b53d-478b-9dc0-6ad88786c19f" providerId="ADAL" clId="{57E2D5E0-CA32-47BE-A2DC-7B0365E99328}" dt="2026-04-24T13:53:55.627" v="842"/>
+          <ac:spMkLst>
+            <pc:docMk/>
+            <pc:sldMk cId="3773506301" sldId="278"/>
+            <ac:spMk id="14" creationId="{9001C0F1-9D22-C1D5-96C7-35D5BED1B84C}"/>
+          </ac:spMkLst>
+        </pc:spChg>
+        <pc:spChg chg="add del mod">
+          <ac:chgData name="Margo Bonal" userId="18c9fa0f-b53d-478b-9dc0-6ad88786c19f" providerId="ADAL" clId="{57E2D5E0-CA32-47BE-A2DC-7B0365E99328}" dt="2026-04-24T14:15:46.216" v="1104" actId="478"/>
+          <ac:spMkLst>
+            <pc:docMk/>
+            <pc:sldMk cId="3773506301" sldId="278"/>
+            <ac:spMk id="16" creationId="{BBFBA1DF-66E9-5C80-6D7A-94EC63939216}"/>
+          </ac:spMkLst>
+        </pc:spChg>
+        <pc:spChg chg="add del mod">
+          <ac:chgData name="Margo Bonal" userId="18c9fa0f-b53d-478b-9dc0-6ad88786c19f" providerId="ADAL" clId="{57E2D5E0-CA32-47BE-A2DC-7B0365E99328}" dt="2026-04-24T14:15:44.689" v="1103" actId="478"/>
+          <ac:spMkLst>
+            <pc:docMk/>
+            <pc:sldMk cId="3773506301" sldId="278"/>
+            <ac:spMk id="17" creationId="{57D7FD09-9060-08AC-D1F1-3FCD0406291A}"/>
+          </ac:spMkLst>
+        </pc:spChg>
+        <pc:spChg chg="add del mod">
+          <ac:chgData name="Margo Bonal" userId="18c9fa0f-b53d-478b-9dc0-6ad88786c19f" providerId="ADAL" clId="{57E2D5E0-CA32-47BE-A2DC-7B0365E99328}" dt="2026-04-24T14:15:49.554" v="1105" actId="478"/>
+          <ac:spMkLst>
+            <pc:docMk/>
+            <pc:sldMk cId="3773506301" sldId="278"/>
+            <ac:spMk id="19" creationId="{22B165CE-91DC-F170-E814-58D6EB03F783}"/>
+          </ac:spMkLst>
+        </pc:spChg>
+        <pc:graphicFrameChg chg="add del mod">
+          <ac:chgData name="Margo Bonal" userId="18c9fa0f-b53d-478b-9dc0-6ad88786c19f" providerId="ADAL" clId="{57E2D5E0-CA32-47BE-A2DC-7B0365E99328}" dt="2026-04-24T13:57:31.822" v="910" actId="478"/>
+          <ac:graphicFrameMkLst>
+            <pc:docMk/>
+            <pc:sldMk cId="3773506301" sldId="278"/>
+            <ac:graphicFrameMk id="15" creationId="{C21209C8-6801-ADE3-BF08-45AB9D8C5449}"/>
+          </ac:graphicFrameMkLst>
+        </pc:graphicFrameChg>
+        <pc:picChg chg="mod">
+          <ac:chgData name="Margo Bonal" userId="18c9fa0f-b53d-478b-9dc0-6ad88786c19f" providerId="ADAL" clId="{57E2D5E0-CA32-47BE-A2DC-7B0365E99328}" dt="2026-04-24T14:15:56.356" v="1107" actId="1076"/>
+          <ac:picMkLst>
+            <pc:docMk/>
+            <pc:sldMk cId="3773506301" sldId="278"/>
+            <ac:picMk id="7" creationId="{69A52293-75E5-359D-7395-51D899F9087B}"/>
+          </ac:picMkLst>
+        </pc:picChg>
+      </pc:sldChg>
+      <pc:sldChg chg="setBg">
+        <pc:chgData name="Margo Bonal" userId="18c9fa0f-b53d-478b-9dc0-6ad88786c19f" providerId="ADAL" clId="{57E2D5E0-CA32-47BE-A2DC-7B0365E99328}" dt="2026-04-24T13:54:46.104" v="857"/>
+        <pc:sldMkLst>
+          <pc:docMk/>
+          <pc:sldMk cId="532806018" sldId="279"/>
+        </pc:sldMkLst>
+      </pc:sldChg>
+      <pc:sldChg chg="setBg">
+        <pc:chgData name="Margo Bonal" userId="18c9fa0f-b53d-478b-9dc0-6ad88786c19f" providerId="ADAL" clId="{57E2D5E0-CA32-47BE-A2DC-7B0365E99328}" dt="2026-04-24T13:54:46.104" v="857"/>
+        <pc:sldMkLst>
+          <pc:docMk/>
+          <pc:sldMk cId="2474028920" sldId="280"/>
+        </pc:sldMkLst>
+      </pc:sldChg>
+      <pc:sldChg chg="modSp mod setBg">
+        <pc:chgData name="Margo Bonal" userId="18c9fa0f-b53d-478b-9dc0-6ad88786c19f" providerId="ADAL" clId="{57E2D5E0-CA32-47BE-A2DC-7B0365E99328}" dt="2026-04-24T13:54:46.104" v="857"/>
+        <pc:sldMkLst>
+          <pc:docMk/>
+          <pc:sldMk cId="2582527457" sldId="281"/>
+        </pc:sldMkLst>
+        <pc:spChg chg="mod">
+          <ac:chgData name="Margo Bonal" userId="18c9fa0f-b53d-478b-9dc0-6ad88786c19f" providerId="ADAL" clId="{57E2D5E0-CA32-47BE-A2DC-7B0365E99328}" dt="2026-04-24T13:26:43.270" v="580" actId="20577"/>
+          <ac:spMkLst>
+            <pc:docMk/>
+            <pc:sldMk cId="2582527457" sldId="281"/>
+            <ac:spMk id="3" creationId="{88E87286-C813-E53C-8EAF-C70AA9478D5A}"/>
+          </ac:spMkLst>
+        </pc:spChg>
+      </pc:sldChg>
+      <pc:sldChg chg="addSp delSp modSp new del mod setBg">
+        <pc:chgData name="Margo Bonal" userId="18c9fa0f-b53d-478b-9dc0-6ad88786c19f" providerId="ADAL" clId="{57E2D5E0-CA32-47BE-A2DC-7B0365E99328}" dt="2026-04-24T13:58:04.062" v="925" actId="2696"/>
+        <pc:sldMkLst>
+          <pc:docMk/>
+          <pc:sldMk cId="197347208" sldId="282"/>
+        </pc:sldMkLst>
+        <pc:spChg chg="del mod">
+          <ac:chgData name="Margo Bonal" userId="18c9fa0f-b53d-478b-9dc0-6ad88786c19f" providerId="ADAL" clId="{57E2D5E0-CA32-47BE-A2DC-7B0365E99328}" dt="2026-04-24T13:46:52.761" v="741" actId="478"/>
+          <ac:spMkLst>
+            <pc:docMk/>
+            <pc:sldMk cId="197347208" sldId="282"/>
+            <ac:spMk id="2" creationId="{07E0F2CA-3ED0-43B1-3FE2-C1C90CD72DE6}"/>
+          </ac:spMkLst>
+        </pc:spChg>
+        <pc:spChg chg="del mod">
+          <ac:chgData name="Margo Bonal" userId="18c9fa0f-b53d-478b-9dc0-6ad88786c19f" providerId="ADAL" clId="{57E2D5E0-CA32-47BE-A2DC-7B0365E99328}" dt="2026-04-24T13:51:17.457" v="801" actId="26606"/>
+          <ac:spMkLst>
+            <pc:docMk/>
+            <pc:sldMk cId="197347208" sldId="282"/>
+            <ac:spMk id="3" creationId="{E4613216-8F4F-9D6C-04F8-E25CB1CCE7E6}"/>
+          </ac:spMkLst>
+        </pc:spChg>
+        <pc:spChg chg="mod">
+          <ac:chgData name="Margo Bonal" userId="18c9fa0f-b53d-478b-9dc0-6ad88786c19f" providerId="ADAL" clId="{57E2D5E0-CA32-47BE-A2DC-7B0365E99328}" dt="2026-04-24T13:50:10.608" v="781" actId="26606"/>
+          <ac:spMkLst>
+            <pc:docMk/>
+            <pc:sldMk cId="197347208" sldId="282"/>
+            <ac:spMk id="4" creationId="{794027C0-DC06-4E10-AABC-026D36281EFA}"/>
+          </ac:spMkLst>
+        </pc:spChg>
+        <pc:spChg chg="add mod">
+          <ac:chgData name="Margo Bonal" userId="18c9fa0f-b53d-478b-9dc0-6ad88786c19f" providerId="ADAL" clId="{57E2D5E0-CA32-47BE-A2DC-7B0365E99328}" dt="2026-04-24T13:51:26.350" v="803" actId="1076"/>
+          <ac:spMkLst>
+            <pc:docMk/>
+            <pc:sldMk cId="197347208" sldId="282"/>
+            <ac:spMk id="5" creationId="{F8524EAF-A812-318B-0AEC-68BA09C5C2AE}"/>
+          </ac:spMkLst>
+        </pc:spChg>
+        <pc:spChg chg="add del mod">
+          <ac:chgData name="Margo Bonal" userId="18c9fa0f-b53d-478b-9dc0-6ad88786c19f" providerId="ADAL" clId="{57E2D5E0-CA32-47BE-A2DC-7B0365E99328}" dt="2026-04-24T13:46:56.495" v="743" actId="478"/>
+          <ac:spMkLst>
+            <pc:docMk/>
+            <pc:sldMk cId="197347208" sldId="282"/>
+            <ac:spMk id="7" creationId="{7F7B6506-35BD-C61D-8997-8848854DC2F6}"/>
+          </ac:spMkLst>
+        </pc:spChg>
+        <pc:spChg chg="add mod ord">
+          <ac:chgData name="Margo Bonal" userId="18c9fa0f-b53d-478b-9dc0-6ad88786c19f" providerId="ADAL" clId="{57E2D5E0-CA32-47BE-A2DC-7B0365E99328}" dt="2026-04-24T13:51:22.376" v="802" actId="1076"/>
+          <ac:spMkLst>
+            <pc:docMk/>
+            <pc:sldMk cId="197347208" sldId="282"/>
+            <ac:spMk id="9" creationId="{6F0D6FD4-4C57-953D-F8EA-5AEAC2DCFF55}"/>
+          </ac:spMkLst>
+        </pc:spChg>
+        <pc:spChg chg="add">
+          <ac:chgData name="Margo Bonal" userId="18c9fa0f-b53d-478b-9dc0-6ad88786c19f" providerId="ADAL" clId="{57E2D5E0-CA32-47BE-A2DC-7B0365E99328}" dt="2026-04-24T13:50:10.608" v="781" actId="26606"/>
+          <ac:spMkLst>
+            <pc:docMk/>
+            <pc:sldMk cId="197347208" sldId="282"/>
+            <ac:spMk id="14" creationId="{5E7AA7E8-8006-4E1F-A566-FCF37EE6F35D}"/>
+          </ac:spMkLst>
+        </pc:spChg>
+        <pc:spChg chg="add del">
+          <ac:chgData name="Margo Bonal" userId="18c9fa0f-b53d-478b-9dc0-6ad88786c19f" providerId="ADAL" clId="{57E2D5E0-CA32-47BE-A2DC-7B0365E99328}" dt="2026-04-24T13:50:10.603" v="780" actId="26606"/>
+          <ac:spMkLst>
+            <pc:docMk/>
+            <pc:sldMk cId="197347208" sldId="282"/>
+            <ac:spMk id="15" creationId="{0671A8AE-40A1-4631-A6B8-581AFF065482}"/>
+          </ac:spMkLst>
+        </pc:spChg>
+        <pc:spChg chg="add del">
+          <ac:chgData name="Margo Bonal" userId="18c9fa0f-b53d-478b-9dc0-6ad88786c19f" providerId="ADAL" clId="{57E2D5E0-CA32-47BE-A2DC-7B0365E99328}" dt="2026-04-24T13:50:10.603" v="780" actId="26606"/>
+          <ac:spMkLst>
+            <pc:docMk/>
+            <pc:sldMk cId="197347208" sldId="282"/>
+            <ac:spMk id="17" creationId="{AB58EF07-17C2-48CF-ABB0-EEF1F17CB8F0}"/>
+          </ac:spMkLst>
+        </pc:spChg>
+        <pc:spChg chg="add del">
+          <ac:chgData name="Margo Bonal" userId="18c9fa0f-b53d-478b-9dc0-6ad88786c19f" providerId="ADAL" clId="{57E2D5E0-CA32-47BE-A2DC-7B0365E99328}" dt="2026-04-24T13:50:10.603" v="780" actId="26606"/>
+          <ac:spMkLst>
+            <pc:docMk/>
+            <pc:sldMk cId="197347208" sldId="282"/>
+            <ac:spMk id="19" creationId="{AF2F604E-43BE-4DC3-B983-E071523364F8}"/>
+          </ac:spMkLst>
+        </pc:spChg>
+        <pc:spChg chg="add del">
+          <ac:chgData name="Margo Bonal" userId="18c9fa0f-b53d-478b-9dc0-6ad88786c19f" providerId="ADAL" clId="{57E2D5E0-CA32-47BE-A2DC-7B0365E99328}" dt="2026-04-24T13:50:10.603" v="780" actId="26606"/>
+          <ac:spMkLst>
+            <pc:docMk/>
+            <pc:sldMk cId="197347208" sldId="282"/>
+            <ac:spMk id="21" creationId="{08C9B587-E65E-4B52-B37C-ABEBB6E87928}"/>
+          </ac:spMkLst>
+        </pc:spChg>
+        <pc:graphicFrameChg chg="add">
+          <ac:chgData name="Margo Bonal" userId="18c9fa0f-b53d-478b-9dc0-6ad88786c19f" providerId="ADAL" clId="{57E2D5E0-CA32-47BE-A2DC-7B0365E99328}" dt="2026-04-24T13:51:17.457" v="801" actId="26606"/>
+          <ac:graphicFrameMkLst>
+            <pc:docMk/>
+            <pc:sldMk cId="197347208" sldId="282"/>
+            <ac:graphicFrameMk id="18" creationId="{0F1D30AF-3AED-15F6-64A5-3B7F245FE4D0}"/>
+          </ac:graphicFrameMkLst>
+        </pc:graphicFrameChg>
+        <pc:picChg chg="add mod">
+          <ac:chgData name="Margo Bonal" userId="18c9fa0f-b53d-478b-9dc0-6ad88786c19f" providerId="ADAL" clId="{57E2D5E0-CA32-47BE-A2DC-7B0365E99328}" dt="2026-04-24T13:50:45.311" v="792" actId="1076"/>
+          <ac:picMkLst>
+            <pc:docMk/>
+            <pc:sldMk cId="197347208" sldId="282"/>
+            <ac:picMk id="8" creationId="{53A89106-2493-A374-FA5E-A88716AC4EF2}"/>
+          </ac:picMkLst>
+        </pc:picChg>
+        <pc:picChg chg="add del">
+          <ac:chgData name="Margo Bonal" userId="18c9fa0f-b53d-478b-9dc0-6ad88786c19f" providerId="ADAL" clId="{57E2D5E0-CA32-47BE-A2DC-7B0365E99328}" dt="2026-04-24T13:50:10.603" v="780" actId="26606"/>
+          <ac:picMkLst>
+            <pc:docMk/>
+            <pc:sldMk cId="197347208" sldId="282"/>
+            <ac:picMk id="11" creationId="{EAB94BA2-5493-91A9-5FAA-BC4114FCAF01}"/>
+          </ac:picMkLst>
+        </pc:picChg>
+        <pc:cxnChg chg="add">
+          <ac:chgData name="Margo Bonal" userId="18c9fa0f-b53d-478b-9dc0-6ad88786c19f" providerId="ADAL" clId="{57E2D5E0-CA32-47BE-A2DC-7B0365E99328}" dt="2026-04-24T13:50:10.608" v="781" actId="26606"/>
+          <ac:cxnSpMkLst>
+            <pc:docMk/>
+            <pc:sldMk cId="197347208" sldId="282"/>
+            <ac:cxnSpMk id="16" creationId="{56020367-4FD5-4596-8E10-C5F095CD8DBF}"/>
+          </ac:cxnSpMkLst>
+        </pc:cxnChg>
+      </pc:sldChg>
+      <pc:sldChg chg="addSp delSp modSp new del mod setBg">
+        <pc:chgData name="Margo Bonal" userId="18c9fa0f-b53d-478b-9dc0-6ad88786c19f" providerId="ADAL" clId="{57E2D5E0-CA32-47BE-A2DC-7B0365E99328}" dt="2026-04-24T14:01:17.296" v="948" actId="2696"/>
+        <pc:sldMkLst>
+          <pc:docMk/>
+          <pc:sldMk cId="2301772930" sldId="283"/>
+        </pc:sldMkLst>
+        <pc:spChg chg="mod">
+          <ac:chgData name="Margo Bonal" userId="18c9fa0f-b53d-478b-9dc0-6ad88786c19f" providerId="ADAL" clId="{57E2D5E0-CA32-47BE-A2DC-7B0365E99328}" dt="2026-04-24T14:00:30.564" v="935" actId="26606"/>
+          <ac:spMkLst>
+            <pc:docMk/>
+            <pc:sldMk cId="2301772930" sldId="283"/>
+            <ac:spMk id="2" creationId="{702D0311-707B-2725-581D-738A23DB0279}"/>
+          </ac:spMkLst>
+        </pc:spChg>
+        <pc:spChg chg="mod">
+          <ac:chgData name="Margo Bonal" userId="18c9fa0f-b53d-478b-9dc0-6ad88786c19f" providerId="ADAL" clId="{57E2D5E0-CA32-47BE-A2DC-7B0365E99328}" dt="2026-04-24T14:00:30.564" v="935" actId="26606"/>
+          <ac:spMkLst>
+            <pc:docMk/>
+            <pc:sldMk cId="2301772930" sldId="283"/>
+            <ac:spMk id="3" creationId="{83222A3C-F5F7-1F9C-8FF3-34F551F1D6AA}"/>
+          </ac:spMkLst>
+        </pc:spChg>
+        <pc:spChg chg="mod">
+          <ac:chgData name="Margo Bonal" userId="18c9fa0f-b53d-478b-9dc0-6ad88786c19f" providerId="ADAL" clId="{57E2D5E0-CA32-47BE-A2DC-7B0365E99328}" dt="2026-04-24T14:00:30.564" v="935" actId="26606"/>
+          <ac:spMkLst>
+            <pc:docMk/>
+            <pc:sldMk cId="2301772930" sldId="283"/>
+            <ac:spMk id="4" creationId="{6575FDCF-0BAA-5362-D2C8-077AC27BCE97}"/>
+          </ac:spMkLst>
+        </pc:spChg>
+        <pc:spChg chg="add del">
+          <ac:chgData name="Margo Bonal" userId="18c9fa0f-b53d-478b-9dc0-6ad88786c19f" providerId="ADAL" clId="{57E2D5E0-CA32-47BE-A2DC-7B0365E99328}" dt="2026-04-24T13:59:54.689" v="928" actId="26606"/>
+          <ac:spMkLst>
+            <pc:docMk/>
+            <pc:sldMk cId="2301772930" sldId="283"/>
+            <ac:spMk id="9" creationId="{6F5A5072-7B47-4D32-B52A-4EBBF590B8A5}"/>
+          </ac:spMkLst>
+        </pc:spChg>
+        <pc:spChg chg="add del">
+          <ac:chgData name="Margo Bonal" userId="18c9fa0f-b53d-478b-9dc0-6ad88786c19f" providerId="ADAL" clId="{57E2D5E0-CA32-47BE-A2DC-7B0365E99328}" dt="2026-04-24T14:00:30.564" v="935" actId="26606"/>
+          <ac:spMkLst>
+            <pc:docMk/>
+            <pc:sldMk cId="2301772930" sldId="283"/>
+            <ac:spMk id="10" creationId="{8DE2E8FE-B87B-430D-9722-167B5E2C2577}"/>
+          </ac:spMkLst>
+        </pc:spChg>
+        <pc:spChg chg="add del">
+          <ac:chgData name="Margo Bonal" userId="18c9fa0f-b53d-478b-9dc0-6ad88786c19f" providerId="ADAL" clId="{57E2D5E0-CA32-47BE-A2DC-7B0365E99328}" dt="2026-04-24T13:59:54.689" v="928" actId="26606"/>
+          <ac:spMkLst>
+            <pc:docMk/>
+            <pc:sldMk cId="2301772930" sldId="283"/>
+            <ac:spMk id="11" creationId="{9715DAF0-AE1B-46C9-8A6B-DB2AA05AB91D}"/>
+          </ac:spMkLst>
+        </pc:spChg>
+        <pc:spChg chg="add del">
+          <ac:chgData name="Margo Bonal" userId="18c9fa0f-b53d-478b-9dc0-6ad88786c19f" providerId="ADAL" clId="{57E2D5E0-CA32-47BE-A2DC-7B0365E99328}" dt="2026-04-24T14:00:30.564" v="935" actId="26606"/>
+          <ac:spMkLst>
+            <pc:docMk/>
+            <pc:sldMk cId="2301772930" sldId="283"/>
+            <ac:spMk id="12" creationId="{5E7AA7E8-8006-4E1F-A566-FCF37EE6F35D}"/>
+          </ac:spMkLst>
+        </pc:spChg>
+        <pc:spChg chg="add del">
+          <ac:chgData name="Margo Bonal" userId="18c9fa0f-b53d-478b-9dc0-6ad88786c19f" providerId="ADAL" clId="{57E2D5E0-CA32-47BE-A2DC-7B0365E99328}" dt="2026-04-24T13:59:54.689" v="928" actId="26606"/>
+          <ac:spMkLst>
+            <pc:docMk/>
+            <pc:sldMk cId="2301772930" sldId="283"/>
+            <ac:spMk id="13" creationId="{6016219D-510E-4184-9090-6D5578A87BD1}"/>
+          </ac:spMkLst>
+        </pc:spChg>
+        <pc:spChg chg="add del">
+          <ac:chgData name="Margo Bonal" userId="18c9fa0f-b53d-478b-9dc0-6ad88786c19f" providerId="ADAL" clId="{57E2D5E0-CA32-47BE-A2DC-7B0365E99328}" dt="2026-04-24T13:59:54.689" v="928" actId="26606"/>
+          <ac:spMkLst>
+            <pc:docMk/>
+            <pc:sldMk cId="2301772930" sldId="283"/>
+            <ac:spMk id="15" creationId="{AFF4A713-7B75-4B21-90D7-5AB19547C728}"/>
+          </ac:spMkLst>
+        </pc:spChg>
+        <pc:spChg chg="add del">
+          <ac:chgData name="Margo Bonal" userId="18c9fa0f-b53d-478b-9dc0-6ad88786c19f" providerId="ADAL" clId="{57E2D5E0-CA32-47BE-A2DC-7B0365E99328}" dt="2026-04-24T13:59:54.689" v="928" actId="26606"/>
+          <ac:spMkLst>
+            <pc:docMk/>
+            <pc:sldMk cId="2301772930" sldId="283"/>
+            <ac:spMk id="17" creationId="{DC631C0B-6DA6-4E57-8231-CE32B3434A7E}"/>
+          </ac:spMkLst>
+        </pc:spChg>
+        <pc:spChg chg="add del">
+          <ac:chgData name="Margo Bonal" userId="18c9fa0f-b53d-478b-9dc0-6ad88786c19f" providerId="ADAL" clId="{57E2D5E0-CA32-47BE-A2DC-7B0365E99328}" dt="2026-04-24T13:59:54.689" v="928" actId="26606"/>
+          <ac:spMkLst>
+            <pc:docMk/>
+            <pc:sldMk cId="2301772930" sldId="283"/>
+            <ac:spMk id="19" creationId="{C29501E6-A978-4A61-9689-9085AF97A53A}"/>
+          </ac:spMkLst>
+        </pc:spChg>
+        <pc:spChg chg="add del">
+          <ac:chgData name="Margo Bonal" userId="18c9fa0f-b53d-478b-9dc0-6ad88786c19f" providerId="ADAL" clId="{57E2D5E0-CA32-47BE-A2DC-7B0365E99328}" dt="2026-04-24T13:59:57.634" v="930" actId="26606"/>
+          <ac:spMkLst>
+            <pc:docMk/>
+            <pc:sldMk cId="2301772930" sldId="283"/>
+            <ac:spMk id="21" creationId="{934F1179-B481-4F9E-BCA3-AFB972070F83}"/>
+          </ac:spMkLst>
+        </pc:spChg>
+        <pc:spChg chg="add del">
+          <ac:chgData name="Margo Bonal" userId="18c9fa0f-b53d-478b-9dc0-6ad88786c19f" providerId="ADAL" clId="{57E2D5E0-CA32-47BE-A2DC-7B0365E99328}" dt="2026-04-24T13:59:57.634" v="930" actId="26606"/>
+          <ac:spMkLst>
+            <pc:docMk/>
+            <pc:sldMk cId="2301772930" sldId="283"/>
+            <ac:spMk id="22" creationId="{827DC2C4-B485-428A-BF4A-472D2967F47F}"/>
+          </ac:spMkLst>
+        </pc:spChg>
+        <pc:spChg chg="add del">
+          <ac:chgData name="Margo Bonal" userId="18c9fa0f-b53d-478b-9dc0-6ad88786c19f" providerId="ADAL" clId="{57E2D5E0-CA32-47BE-A2DC-7B0365E99328}" dt="2026-04-24T13:59:57.634" v="930" actId="26606"/>
+          <ac:spMkLst>
+            <pc:docMk/>
+            <pc:sldMk cId="2301772930" sldId="283"/>
+            <ac:spMk id="23" creationId="{EE04B5EB-F158-4507-90DD-BD23620C7CC9}"/>
+          </ac:spMkLst>
+        </pc:spChg>
+        <pc:spChg chg="add del">
+          <ac:chgData name="Margo Bonal" userId="18c9fa0f-b53d-478b-9dc0-6ad88786c19f" providerId="ADAL" clId="{57E2D5E0-CA32-47BE-A2DC-7B0365E99328}" dt="2026-04-24T14:00:05.524" v="933" actId="26606"/>
+          <ac:spMkLst>
+            <pc:docMk/>
+            <pc:sldMk cId="2301772930" sldId="283"/>
+            <ac:spMk id="29" creationId="{5A292AEA-2528-46C0-B426-95822B6141FB}"/>
+          </ac:spMkLst>
+        </pc:spChg>
+        <pc:spChg chg="add del">
+          <ac:chgData name="Margo Bonal" userId="18c9fa0f-b53d-478b-9dc0-6ad88786c19f" providerId="ADAL" clId="{57E2D5E0-CA32-47BE-A2DC-7B0365E99328}" dt="2026-04-24T14:00:05.524" v="933" actId="26606"/>
+          <ac:spMkLst>
+            <pc:docMk/>
+            <pc:sldMk cId="2301772930" sldId="283"/>
+            <ac:spMk id="35" creationId="{D8B7B198-E4DF-43CD-AD8C-199884323745}"/>
+          </ac:spMkLst>
+        </pc:spChg>
+        <pc:spChg chg="add del">
+          <ac:chgData name="Margo Bonal" userId="18c9fa0f-b53d-478b-9dc0-6ad88786c19f" providerId="ADAL" clId="{57E2D5E0-CA32-47BE-A2DC-7B0365E99328}" dt="2026-04-24T14:00:05.524" v="933" actId="26606"/>
+          <ac:spMkLst>
+            <pc:docMk/>
+            <pc:sldMk cId="2301772930" sldId="283"/>
+            <ac:spMk id="36" creationId="{2BE67753-EA0E-4819-8D22-0B6600CF7231}"/>
+          </ac:spMkLst>
+        </pc:spChg>
+        <pc:grpChg chg="add del">
+          <ac:chgData name="Margo Bonal" userId="18c9fa0f-b53d-478b-9dc0-6ad88786c19f" providerId="ADAL" clId="{57E2D5E0-CA32-47BE-A2DC-7B0365E99328}" dt="2026-04-24T14:00:05.524" v="933" actId="26606"/>
+          <ac:grpSpMkLst>
+            <pc:docMk/>
+            <pc:sldMk cId="2301772930" sldId="283"/>
+            <ac:grpSpMk id="24" creationId="{87F87F1B-42BA-4AC7-A4E2-41544DDB2CE3}"/>
+          </ac:grpSpMkLst>
+        </pc:grpChg>
+        <pc:grpChg chg="add del">
+          <ac:chgData name="Margo Bonal" userId="18c9fa0f-b53d-478b-9dc0-6ad88786c19f" providerId="ADAL" clId="{57E2D5E0-CA32-47BE-A2DC-7B0365E99328}" dt="2026-04-24T14:00:05.524" v="933" actId="26606"/>
+          <ac:grpSpMkLst>
+            <pc:docMk/>
+            <pc:sldMk cId="2301772930" sldId="283"/>
+            <ac:grpSpMk id="30" creationId="{967346A5-7569-4F15-AB5D-BE3DADF192C0}"/>
+          </ac:grpSpMkLst>
+        </pc:grpChg>
+        <pc:grpChg chg="add del">
+          <ac:chgData name="Margo Bonal" userId="18c9fa0f-b53d-478b-9dc0-6ad88786c19f" providerId="ADAL" clId="{57E2D5E0-CA32-47BE-A2DC-7B0365E99328}" dt="2026-04-24T14:00:05.524" v="933" actId="26606"/>
+          <ac:grpSpMkLst>
+            <pc:docMk/>
+            <pc:sldMk cId="2301772930" sldId="283"/>
+            <ac:grpSpMk id="37" creationId="{D76D63AC-0421-45EC-B383-E79A61A78C6B}"/>
+          </ac:grpSpMkLst>
+        </pc:grpChg>
+        <pc:picChg chg="add del mod">
+          <ac:chgData name="Margo Bonal" userId="18c9fa0f-b53d-478b-9dc0-6ad88786c19f" providerId="ADAL" clId="{57E2D5E0-CA32-47BE-A2DC-7B0365E99328}" dt="2026-04-24T13:57:58.806" v="924" actId="478"/>
+          <ac:picMkLst>
+            <pc:docMk/>
+            <pc:sldMk cId="2301772930" sldId="283"/>
+            <ac:picMk id="5" creationId="{7517AE13-4BF4-D6F7-E088-96B6B03A4FC7}"/>
+          </ac:picMkLst>
+        </pc:picChg>
+        <pc:picChg chg="add del">
+          <ac:chgData name="Margo Bonal" userId="18c9fa0f-b53d-478b-9dc0-6ad88786c19f" providerId="ADAL" clId="{57E2D5E0-CA32-47BE-A2DC-7B0365E99328}" dt="2026-04-24T14:00:30.564" v="935" actId="26606"/>
+          <ac:picMkLst>
+            <pc:docMk/>
+            <pc:sldMk cId="2301772930" sldId="283"/>
+            <ac:picMk id="6" creationId="{B0AED277-96FC-F301-724C-F6B2D5A270B3}"/>
+          </ac:picMkLst>
+        </pc:picChg>
+        <pc:cxnChg chg="add del">
+          <ac:chgData name="Margo Bonal" userId="18c9fa0f-b53d-478b-9dc0-6ad88786c19f" providerId="ADAL" clId="{57E2D5E0-CA32-47BE-A2DC-7B0365E99328}" dt="2026-04-24T14:00:30.564" v="935" actId="26606"/>
+          <ac:cxnSpMkLst>
+            <pc:docMk/>
+            <pc:sldMk cId="2301772930" sldId="283"/>
+            <ac:cxnSpMk id="14" creationId="{56020367-4FD5-4596-8E10-C5F095CD8DBF}"/>
+          </ac:cxnSpMkLst>
+        </pc:cxnChg>
+      </pc:sldChg>
+      <pc:sldChg chg="addSp delSp modSp add del mod">
+        <pc:chgData name="Margo Bonal" userId="18c9fa0f-b53d-478b-9dc0-6ad88786c19f" providerId="ADAL" clId="{57E2D5E0-CA32-47BE-A2DC-7B0365E99328}" dt="2026-04-24T14:06:30.664" v="991" actId="2696"/>
+        <pc:sldMkLst>
+          <pc:docMk/>
+          <pc:sldMk cId="1157091704" sldId="284"/>
+        </pc:sldMkLst>
+        <pc:spChg chg="del">
+          <ac:chgData name="Margo Bonal" userId="18c9fa0f-b53d-478b-9dc0-6ad88786c19f" providerId="ADAL" clId="{57E2D5E0-CA32-47BE-A2DC-7B0365E99328}" dt="2026-04-24T14:01:01.200" v="941" actId="478"/>
+          <ac:spMkLst>
+            <pc:docMk/>
+            <pc:sldMk cId="1157091704" sldId="284"/>
+            <ac:spMk id="2" creationId="{C1A84D1B-A785-DCEC-9F96-AD899F0321C2}"/>
+          </ac:spMkLst>
+        </pc:spChg>
+        <pc:spChg chg="del">
+          <ac:chgData name="Margo Bonal" userId="18c9fa0f-b53d-478b-9dc0-6ad88786c19f" providerId="ADAL" clId="{57E2D5E0-CA32-47BE-A2DC-7B0365E99328}" dt="2026-04-24T14:00:52.963" v="940" actId="478"/>
+          <ac:spMkLst>
+            <pc:docMk/>
+            <pc:sldMk cId="1157091704" sldId="284"/>
+            <ac:spMk id="3" creationId="{02A1E765-977B-7A29-138E-7E6BA06E717A}"/>
+          </ac:spMkLst>
+        </pc:spChg>
+        <pc:spChg chg="add mod">
+          <ac:chgData name="Margo Bonal" userId="18c9fa0f-b53d-478b-9dc0-6ad88786c19f" providerId="ADAL" clId="{57E2D5E0-CA32-47BE-A2DC-7B0365E99328}" dt="2026-04-24T14:03:00.021" v="955" actId="20577"/>
+          <ac:spMkLst>
+            <pc:docMk/>
+            <pc:sldMk cId="1157091704" sldId="284"/>
+            <ac:spMk id="6" creationId="{1776A02F-B45B-64A9-0726-61D9D56512D0}"/>
+          </ac:spMkLst>
+        </pc:spChg>
+        <pc:spChg chg="add del mod">
+          <ac:chgData name="Margo Bonal" userId="18c9fa0f-b53d-478b-9dc0-6ad88786c19f" providerId="ADAL" clId="{57E2D5E0-CA32-47BE-A2DC-7B0365E99328}" dt="2026-04-24T14:01:06.699" v="944" actId="478"/>
+          <ac:spMkLst>
+            <pc:docMk/>
+            <pc:sldMk cId="1157091704" sldId="284"/>
+            <ac:spMk id="8" creationId="{4C0834AA-99B1-A76A-6587-27AB9D4B0491}"/>
+          </ac:spMkLst>
+        </pc:spChg>
+        <pc:spChg chg="add mod">
+          <ac:chgData name="Margo Bonal" userId="18c9fa0f-b53d-478b-9dc0-6ad88786c19f" providerId="ADAL" clId="{57E2D5E0-CA32-47BE-A2DC-7B0365E99328}" dt="2026-04-24T14:01:04.954" v="943" actId="1076"/>
+          <ac:spMkLst>
+            <pc:docMk/>
+            <pc:sldMk cId="1157091704" sldId="284"/>
+            <ac:spMk id="9" creationId="{304A5BFC-4B45-ED1F-212D-191D812B4B83}"/>
+          </ac:spMkLst>
+        </pc:spChg>
+      </pc:sldChg>
+      <pc:sldChg chg="addSp delSp add del setBg delDesignElem">
+        <pc:chgData name="Margo Bonal" userId="18c9fa0f-b53d-478b-9dc0-6ad88786c19f" providerId="ADAL" clId="{57E2D5E0-CA32-47BE-A2DC-7B0365E99328}" dt="2026-04-24T14:00:44.751" v="938"/>
+        <pc:sldMkLst>
+          <pc:docMk/>
+          <pc:sldMk cId="3902440819" sldId="284"/>
+        </pc:sldMkLst>
+        <pc:spChg chg="add del">
+          <ac:chgData name="Margo Bonal" userId="18c9fa0f-b53d-478b-9dc0-6ad88786c19f" providerId="ADAL" clId="{57E2D5E0-CA32-47BE-A2DC-7B0365E99328}" dt="2026-04-24T14:00:44.751" v="938"/>
+          <ac:spMkLst>
+            <pc:docMk/>
+            <pc:sldMk cId="3902440819" sldId="284"/>
+            <ac:spMk id="45" creationId="{53B136C7-D936-2E0D-C3A0-6BB9B6FAD11B}"/>
+          </ac:spMkLst>
+        </pc:spChg>
+        <pc:spChg chg="add del">
+          <ac:chgData name="Margo Bonal" userId="18c9fa0f-b53d-478b-9dc0-6ad88786c19f" providerId="ADAL" clId="{57E2D5E0-CA32-47BE-A2DC-7B0365E99328}" dt="2026-04-24T14:00:44.751" v="938"/>
+          <ac:spMkLst>
+            <pc:docMk/>
+            <pc:sldMk cId="3902440819" sldId="284"/>
+            <ac:spMk id="47" creationId="{03ABAFB7-489F-A01B-5654-5F8FB1775D55}"/>
+          </ac:spMkLst>
+        </pc:spChg>
+        <pc:spChg chg="add del">
+          <ac:chgData name="Margo Bonal" userId="18c9fa0f-b53d-478b-9dc0-6ad88786c19f" providerId="ADAL" clId="{57E2D5E0-CA32-47BE-A2DC-7B0365E99328}" dt="2026-04-24T14:00:44.751" v="938"/>
+          <ac:spMkLst>
+            <pc:docMk/>
+            <pc:sldMk cId="3902440819" sldId="284"/>
+            <ac:spMk id="49" creationId="{F11C3F24-A031-B52F-1FA2-AB4C46B71875}"/>
+          </ac:spMkLst>
+        </pc:spChg>
+        <pc:cxnChg chg="add del">
+          <ac:chgData name="Margo Bonal" userId="18c9fa0f-b53d-478b-9dc0-6ad88786c19f" providerId="ADAL" clId="{57E2D5E0-CA32-47BE-A2DC-7B0365E99328}" dt="2026-04-24T14:00:44.751" v="938"/>
+          <ac:cxnSpMkLst>
+            <pc:docMk/>
+            <pc:sldMk cId="3902440819" sldId="284"/>
+            <ac:cxnSpMk id="51" creationId="{843C5FE8-5756-1408-2610-CD23EED30587}"/>
+          </ac:cxnSpMkLst>
+        </pc:cxnChg>
+      </pc:sldChg>
+      <pc:sldChg chg="addSp delSp modSp new del mod setBg">
+        <pc:chgData name="Margo Bonal" userId="18c9fa0f-b53d-478b-9dc0-6ad88786c19f" providerId="ADAL" clId="{57E2D5E0-CA32-47BE-A2DC-7B0365E99328}" dt="2026-04-24T14:17:47.444" v="1148" actId="2696"/>
+        <pc:sldMkLst>
+          <pc:docMk/>
+          <pc:sldMk cId="136517662" sldId="285"/>
+        </pc:sldMkLst>
+        <pc:spChg chg="del mod">
+          <ac:chgData name="Margo Bonal" userId="18c9fa0f-b53d-478b-9dc0-6ad88786c19f" providerId="ADAL" clId="{57E2D5E0-CA32-47BE-A2DC-7B0365E99328}" dt="2026-04-24T14:05:54.391" v="983" actId="478"/>
+          <ac:spMkLst>
+            <pc:docMk/>
+            <pc:sldMk cId="136517662" sldId="285"/>
+            <ac:spMk id="2" creationId="{2A11A01E-0E91-1722-A699-9D27C7A7D6E7}"/>
+          </ac:spMkLst>
+        </pc:spChg>
+        <pc:spChg chg="del mod">
+          <ac:chgData name="Margo Bonal" userId="18c9fa0f-b53d-478b-9dc0-6ad88786c19f" providerId="ADAL" clId="{57E2D5E0-CA32-47BE-A2DC-7B0365E99328}" dt="2026-04-24T14:05:51.709" v="982" actId="478"/>
+          <ac:spMkLst>
+            <pc:docMk/>
+            <pc:sldMk cId="136517662" sldId="285"/>
+            <ac:spMk id="3" creationId="{32C87325-4F22-7FCF-0193-B5596A4E82FE}"/>
+          </ac:spMkLst>
+        </pc:spChg>
+        <pc:spChg chg="mod">
+          <ac:chgData name="Margo Bonal" userId="18c9fa0f-b53d-478b-9dc0-6ad88786c19f" providerId="ADAL" clId="{57E2D5E0-CA32-47BE-A2DC-7B0365E99328}" dt="2026-04-24T14:05:48.489" v="981" actId="26606"/>
+          <ac:spMkLst>
+            <pc:docMk/>
+            <pc:sldMk cId="136517662" sldId="285"/>
+            <ac:spMk id="4" creationId="{F541EF38-6AB1-5CC0-C51C-E9E53561E8FF}"/>
+          </ac:spMkLst>
+        </pc:spChg>
+        <pc:spChg chg="add del mod">
+          <ac:chgData name="Margo Bonal" userId="18c9fa0f-b53d-478b-9dc0-6ad88786c19f" providerId="ADAL" clId="{57E2D5E0-CA32-47BE-A2DC-7B0365E99328}" dt="2026-04-24T14:05:56.276" v="984" actId="478"/>
+          <ac:spMkLst>
+            <pc:docMk/>
+            <pc:sldMk cId="136517662" sldId="285"/>
+            <ac:spMk id="6" creationId="{79E2F493-95A1-883D-F9AC-8C5728CB841E}"/>
+          </ac:spMkLst>
+        </pc:spChg>
+        <pc:spChg chg="add del mod">
+          <ac:chgData name="Margo Bonal" userId="18c9fa0f-b53d-478b-9dc0-6ad88786c19f" providerId="ADAL" clId="{57E2D5E0-CA32-47BE-A2DC-7B0365E99328}" dt="2026-04-24T14:15:28.041" v="1097" actId="478"/>
+          <ac:spMkLst>
+            <pc:docMk/>
+            <pc:sldMk cId="136517662" sldId="285"/>
+            <ac:spMk id="7" creationId="{BBD7D8B8-9ABA-9DCB-F78B-E783DEA03E79}"/>
+          </ac:spMkLst>
+        </pc:spChg>
+        <pc:spChg chg="add del mod">
+          <ac:chgData name="Margo Bonal" userId="18c9fa0f-b53d-478b-9dc0-6ad88786c19f" providerId="ADAL" clId="{57E2D5E0-CA32-47BE-A2DC-7B0365E99328}" dt="2026-04-24T14:15:35.900" v="1098" actId="478"/>
+          <ac:spMkLst>
+            <pc:docMk/>
+            <pc:sldMk cId="136517662" sldId="285"/>
+            <ac:spMk id="8" creationId="{08C15359-6155-0728-134C-A9BE6A52B12A}"/>
+          </ac:spMkLst>
+        </pc:spChg>
+        <pc:spChg chg="add del">
+          <ac:chgData name="Margo Bonal" userId="18c9fa0f-b53d-478b-9dc0-6ad88786c19f" providerId="ADAL" clId="{57E2D5E0-CA32-47BE-A2DC-7B0365E99328}" dt="2026-04-24T14:04:48.702" v="969" actId="26606"/>
+          <ac:spMkLst>
+            <pc:docMk/>
+            <pc:sldMk cId="136517662" sldId="285"/>
+            <ac:spMk id="9" creationId="{943CAA20-3569-4189-9E48-239A229A86CA}"/>
+          </ac:spMkLst>
+        </pc:spChg>
+        <pc:spChg chg="add mod">
+          <ac:chgData name="Margo Bonal" userId="18c9fa0f-b53d-478b-9dc0-6ad88786c19f" providerId="ADAL" clId="{57E2D5E0-CA32-47BE-A2DC-7B0365E99328}" dt="2026-04-24T14:15:25.085" v="1096" actId="1076"/>
+          <ac:spMkLst>
+            <pc:docMk/>
+            <pc:sldMk cId="136517662" sldId="285"/>
+            <ac:spMk id="10" creationId="{EF6D894A-D758-C3FD-EE89-0BCFCDAB77B8}"/>
+          </ac:spMkLst>
+        </pc:spChg>
+        <pc:spChg chg="add del">
+          <ac:chgData name="Margo Bonal" userId="18c9fa0f-b53d-478b-9dc0-6ad88786c19f" providerId="ADAL" clId="{57E2D5E0-CA32-47BE-A2DC-7B0365E99328}" dt="2026-04-24T14:04:48.702" v="969" actId="26606"/>
+          <ac:spMkLst>
+            <pc:docMk/>
+            <pc:sldMk cId="136517662" sldId="285"/>
+            <ac:spMk id="11" creationId="{DA542B6D-E775-4832-91DC-2D20F857813A}"/>
+          </ac:spMkLst>
+        </pc:spChg>
+        <pc:spChg chg="add del">
+          <ac:chgData name="Margo Bonal" userId="18c9fa0f-b53d-478b-9dc0-6ad88786c19f" providerId="ADAL" clId="{57E2D5E0-CA32-47BE-A2DC-7B0365E99328}" dt="2026-04-24T14:04:53.190" v="971" actId="26606"/>
+          <ac:spMkLst>
+            <pc:docMk/>
+            <pc:sldMk cId="136517662" sldId="285"/>
+            <ac:spMk id="14" creationId="{9095C1F4-AE7F-44E4-8693-40D3D6831140}"/>
+          </ac:spMkLst>
+        </pc:spChg>
+        <pc:spChg chg="add del">
+          <ac:chgData name="Margo Bonal" userId="18c9fa0f-b53d-478b-9dc0-6ad88786c19f" providerId="ADAL" clId="{57E2D5E0-CA32-47BE-A2DC-7B0365E99328}" dt="2026-04-24T14:04:53.190" v="971" actId="26606"/>
+          <ac:spMkLst>
+            <pc:docMk/>
+            <pc:sldMk cId="136517662" sldId="285"/>
+            <ac:spMk id="15" creationId="{871AEA07-1E14-44B4-8E55-64EF049CD66F}"/>
+          </ac:spMkLst>
+        </pc:spChg>
+        <pc:spChg chg="add del">
+          <ac:chgData name="Margo Bonal" userId="18c9fa0f-b53d-478b-9dc0-6ad88786c19f" providerId="ADAL" clId="{57E2D5E0-CA32-47BE-A2DC-7B0365E99328}" dt="2026-04-24T14:05:48.489" v="981" actId="26606"/>
+          <ac:spMkLst>
+            <pc:docMk/>
+            <pc:sldMk cId="136517662" sldId="285"/>
+            <ac:spMk id="17" creationId="{B0EE8A42-107A-4D4C-8D56-BBAE95C7FC0D}"/>
+          </ac:spMkLst>
+        </pc:spChg>
+        <pc:spChg chg="add del">
+          <ac:chgData name="Margo Bonal" userId="18c9fa0f-b53d-478b-9dc0-6ad88786c19f" providerId="ADAL" clId="{57E2D5E0-CA32-47BE-A2DC-7B0365E99328}" dt="2026-04-24T14:05:48.489" v="981" actId="26606"/>
+          <ac:spMkLst>
+            <pc:docMk/>
+            <pc:sldMk cId="136517662" sldId="285"/>
+            <ac:spMk id="18" creationId="{A7895A40-19A4-42D6-9D30-DBC1E8002635}"/>
+          </ac:spMkLst>
+        </pc:spChg>
+        <pc:spChg chg="add del">
+          <ac:chgData name="Margo Bonal" userId="18c9fa0f-b53d-478b-9dc0-6ad88786c19f" providerId="ADAL" clId="{57E2D5E0-CA32-47BE-A2DC-7B0365E99328}" dt="2026-04-24T14:05:48.489" v="981" actId="26606"/>
+          <ac:spMkLst>
+            <pc:docMk/>
+            <pc:sldMk cId="136517662" sldId="285"/>
+            <ac:spMk id="19" creationId="{02F429C4-ABC9-46FC-818A-B5429CDE4A96}"/>
+          </ac:spMkLst>
+        </pc:spChg>
+        <pc:spChg chg="add del">
+          <ac:chgData name="Margo Bonal" userId="18c9fa0f-b53d-478b-9dc0-6ad88786c19f" providerId="ADAL" clId="{57E2D5E0-CA32-47BE-A2DC-7B0365E99328}" dt="2026-04-24T14:05:48.489" v="981" actId="26606"/>
+          <ac:spMkLst>
+            <pc:docMk/>
+            <pc:sldMk cId="136517662" sldId="285"/>
+            <ac:spMk id="20" creationId="{2CEF98E4-3709-4952-8F42-2305CCE34FA3}"/>
+          </ac:spMkLst>
+        </pc:spChg>
+        <pc:spChg chg="add del">
+          <ac:chgData name="Margo Bonal" userId="18c9fa0f-b53d-478b-9dc0-6ad88786c19f" providerId="ADAL" clId="{57E2D5E0-CA32-47BE-A2DC-7B0365E99328}" dt="2026-04-24T14:05:48.489" v="981" actId="26606"/>
+          <ac:spMkLst>
+            <pc:docMk/>
+            <pc:sldMk cId="136517662" sldId="285"/>
+            <ac:spMk id="21" creationId="{F10BCCF5-D685-47FF-B675-647EAEB72C8E}"/>
+          </ac:spMkLst>
+        </pc:spChg>
+        <pc:spChg chg="add del mod">
+          <ac:chgData name="Margo Bonal" userId="18c9fa0f-b53d-478b-9dc0-6ad88786c19f" providerId="ADAL" clId="{57E2D5E0-CA32-47BE-A2DC-7B0365E99328}" dt="2026-04-24T14:15:39.099" v="1101"/>
+          <ac:spMkLst>
+            <pc:docMk/>
+            <pc:sldMk cId="136517662" sldId="285"/>
+            <ac:spMk id="23" creationId="{5DFA056B-990E-8153-BC82-C09B28D7587B}"/>
+          </ac:spMkLst>
+        </pc:spChg>
+        <pc:spChg chg="add mod">
+          <ac:chgData name="Margo Bonal" userId="18c9fa0f-b53d-478b-9dc0-6ad88786c19f" providerId="ADAL" clId="{57E2D5E0-CA32-47BE-A2DC-7B0365E99328}" dt="2026-04-24T14:15:37.996" v="1100"/>
+          <ac:spMkLst>
+            <pc:docMk/>
+            <pc:sldMk cId="136517662" sldId="285"/>
+            <ac:spMk id="24" creationId="{50A5A69A-6CD0-210E-B372-38BBF923D226}"/>
+          </ac:spMkLst>
+        </pc:spChg>
+        <pc:spChg chg="add mod">
+          <ac:chgData name="Margo Bonal" userId="18c9fa0f-b53d-478b-9dc0-6ad88786c19f" providerId="ADAL" clId="{57E2D5E0-CA32-47BE-A2DC-7B0365E99328}" dt="2026-04-24T14:16:15.219" v="1119" actId="1076"/>
+          <ac:spMkLst>
+            <pc:docMk/>
+            <pc:sldMk cId="136517662" sldId="285"/>
+            <ac:spMk id="25" creationId="{CD16E7D7-D95D-7F11-3260-7D4E8B5F682F}"/>
+          </ac:spMkLst>
+        </pc:spChg>
+        <pc:spChg chg="add del">
+          <ac:chgData name="Margo Bonal" userId="18c9fa0f-b53d-478b-9dc0-6ad88786c19f" providerId="ADAL" clId="{57E2D5E0-CA32-47BE-A2DC-7B0365E99328}" dt="2026-04-24T14:05:39.102" v="974" actId="26606"/>
+          <ac:spMkLst>
+            <pc:docMk/>
+            <pc:sldMk cId="136517662" sldId="285"/>
+            <ac:spMk id="26" creationId="{879EECFE-814E-4B68-96A7-86A795BD22F7}"/>
+          </ac:spMkLst>
+        </pc:spChg>
+        <pc:spChg chg="add del">
+          <ac:chgData name="Margo Bonal" userId="18c9fa0f-b53d-478b-9dc0-6ad88786c19f" providerId="ADAL" clId="{57E2D5E0-CA32-47BE-A2DC-7B0365E99328}" dt="2026-04-24T14:05:39.102" v="974" actId="26606"/>
+          <ac:spMkLst>
+            <pc:docMk/>
+            <pc:sldMk cId="136517662" sldId="285"/>
+            <ac:spMk id="28" creationId="{AF180F00-B4B2-4196-BB1C-ECD21B03F0A9}"/>
+          </ac:spMkLst>
+        </pc:spChg>
+        <pc:spChg chg="add del">
+          <ac:chgData name="Margo Bonal" userId="18c9fa0f-b53d-478b-9dc0-6ad88786c19f" providerId="ADAL" clId="{57E2D5E0-CA32-47BE-A2DC-7B0365E99328}" dt="2026-04-24T14:05:39.102" v="974" actId="26606"/>
+          <ac:spMkLst>
+            <pc:docMk/>
+            <pc:sldMk cId="136517662" sldId="285"/>
+            <ac:spMk id="30" creationId="{EE04B5EB-F158-4507-90DD-BD23620C7CC9}"/>
+          </ac:spMkLst>
+        </pc:spChg>
+        <pc:spChg chg="add del">
+          <ac:chgData name="Margo Bonal" userId="18c9fa0f-b53d-478b-9dc0-6ad88786c19f" providerId="ADAL" clId="{57E2D5E0-CA32-47BE-A2DC-7B0365E99328}" dt="2026-04-24T14:05:42.093" v="976" actId="26606"/>
+          <ac:spMkLst>
+            <pc:docMk/>
+            <pc:sldMk cId="136517662" sldId="285"/>
+            <ac:spMk id="34" creationId="{EA804283-B929-4503-802F-4585376E2B42}"/>
+          </ac:spMkLst>
+        </pc:spChg>
+        <pc:spChg chg="add del">
+          <ac:chgData name="Margo Bonal" userId="18c9fa0f-b53d-478b-9dc0-6ad88786c19f" providerId="ADAL" clId="{57E2D5E0-CA32-47BE-A2DC-7B0365E99328}" dt="2026-04-24T14:05:42.093" v="976" actId="26606"/>
+          <ac:spMkLst>
+            <pc:docMk/>
+            <pc:sldMk cId="136517662" sldId="285"/>
+            <ac:spMk id="35" creationId="{59EF30C2-29AC-4A0D-BC0A-A679CF113EDD}"/>
+          </ac:spMkLst>
+        </pc:spChg>
+        <pc:spChg chg="add del">
+          <ac:chgData name="Margo Bonal" userId="18c9fa0f-b53d-478b-9dc0-6ad88786c19f" providerId="ADAL" clId="{57E2D5E0-CA32-47BE-A2DC-7B0365E99328}" dt="2026-04-24T14:05:42.093" v="976" actId="26606"/>
+          <ac:spMkLst>
+            <pc:docMk/>
+            <pc:sldMk cId="136517662" sldId="285"/>
+            <ac:spMk id="37" creationId="{9C682A1A-5B2D-4111-BBD6-620165633E5B}"/>
+          </ac:spMkLst>
+        </pc:spChg>
+        <pc:spChg chg="add del">
+          <ac:chgData name="Margo Bonal" userId="18c9fa0f-b53d-478b-9dc0-6ad88786c19f" providerId="ADAL" clId="{57E2D5E0-CA32-47BE-A2DC-7B0365E99328}" dt="2026-04-24T14:05:42.093" v="976" actId="26606"/>
+          <ac:spMkLst>
+            <pc:docMk/>
+            <pc:sldMk cId="136517662" sldId="285"/>
+            <ac:spMk id="41" creationId="{A04F1504-431A-4D86-9091-AE7E4B33376B}"/>
+          </ac:spMkLst>
+        </pc:spChg>
+        <pc:spChg chg="add del">
+          <ac:chgData name="Margo Bonal" userId="18c9fa0f-b53d-478b-9dc0-6ad88786c19f" providerId="ADAL" clId="{57E2D5E0-CA32-47BE-A2DC-7B0365E99328}" dt="2026-04-24T14:05:43.849" v="978" actId="26606"/>
+          <ac:spMkLst>
+            <pc:docMk/>
+            <pc:sldMk cId="136517662" sldId="285"/>
+            <ac:spMk id="43" creationId="{934F1179-B481-4F9E-BCA3-AFB972070F83}"/>
+          </ac:spMkLst>
+        </pc:spChg>
+        <pc:spChg chg="add del">
+          <ac:chgData name="Margo Bonal" userId="18c9fa0f-b53d-478b-9dc0-6ad88786c19f" providerId="ADAL" clId="{57E2D5E0-CA32-47BE-A2DC-7B0365E99328}" dt="2026-04-24T14:05:43.849" v="978" actId="26606"/>
+          <ac:spMkLst>
+            <pc:docMk/>
+            <pc:sldMk cId="136517662" sldId="285"/>
+            <ac:spMk id="44" creationId="{827DC2C4-B485-428A-BF4A-472D2967F47F}"/>
+          </ac:spMkLst>
+        </pc:spChg>
+        <pc:spChg chg="add del">
+          <ac:chgData name="Margo Bonal" userId="18c9fa0f-b53d-478b-9dc0-6ad88786c19f" providerId="ADAL" clId="{57E2D5E0-CA32-47BE-A2DC-7B0365E99328}" dt="2026-04-24T14:05:43.849" v="978" actId="26606"/>
+          <ac:spMkLst>
+            <pc:docMk/>
+            <pc:sldMk cId="136517662" sldId="285"/>
+            <ac:spMk id="45" creationId="{EE04B5EB-F158-4507-90DD-BD23620C7CC9}"/>
+          </ac:spMkLst>
+        </pc:spChg>
+        <pc:spChg chg="add del">
+          <ac:chgData name="Margo Bonal" userId="18c9fa0f-b53d-478b-9dc0-6ad88786c19f" providerId="ADAL" clId="{57E2D5E0-CA32-47BE-A2DC-7B0365E99328}" dt="2026-04-24T14:05:48.489" v="980" actId="26606"/>
+          <ac:spMkLst>
+            <pc:docMk/>
+            <pc:sldMk cId="136517662" sldId="285"/>
+            <ac:spMk id="47" creationId="{1ACA2EA0-FFD3-42EC-9406-B595015ED96E}"/>
+          </ac:spMkLst>
+        </pc:spChg>
+        <pc:spChg chg="add del">
+          <ac:chgData name="Margo Bonal" userId="18c9fa0f-b53d-478b-9dc0-6ad88786c19f" providerId="ADAL" clId="{57E2D5E0-CA32-47BE-A2DC-7B0365E99328}" dt="2026-04-24T14:05:48.489" v="980" actId="26606"/>
+          <ac:spMkLst>
+            <pc:docMk/>
+            <pc:sldMk cId="136517662" sldId="285"/>
+            <ac:spMk id="48" creationId="{D5288BCE-665C-472A-8C43-664BCFA31E43}"/>
+          </ac:spMkLst>
+        </pc:spChg>
+        <pc:spChg chg="add">
+          <ac:chgData name="Margo Bonal" userId="18c9fa0f-b53d-478b-9dc0-6ad88786c19f" providerId="ADAL" clId="{57E2D5E0-CA32-47BE-A2DC-7B0365E99328}" dt="2026-04-24T14:05:48.489" v="981" actId="26606"/>
+          <ac:spMkLst>
+            <pc:docMk/>
+            <pc:sldMk cId="136517662" sldId="285"/>
+            <ac:spMk id="51" creationId="{D5B339F4-93B9-4E04-9721-143AD6782EA9}"/>
+          </ac:spMkLst>
+        </pc:spChg>
+        <pc:spChg chg="add">
+          <ac:chgData name="Margo Bonal" userId="18c9fa0f-b53d-478b-9dc0-6ad88786c19f" providerId="ADAL" clId="{57E2D5E0-CA32-47BE-A2DC-7B0365E99328}" dt="2026-04-24T14:05:48.489" v="981" actId="26606"/>
+          <ac:spMkLst>
+            <pc:docMk/>
+            <pc:sldMk cId="136517662" sldId="285"/>
+            <ac:spMk id="54" creationId="{871AEA07-1E14-44B4-8E55-64EF049CD66F}"/>
+          </ac:spMkLst>
+        </pc:spChg>
+        <pc:grpChg chg="add del">
+          <ac:chgData name="Margo Bonal" userId="18c9fa0f-b53d-478b-9dc0-6ad88786c19f" providerId="ADAL" clId="{57E2D5E0-CA32-47BE-A2DC-7B0365E99328}" dt="2026-04-24T14:04:53.190" v="971" actId="26606"/>
+          <ac:grpSpMkLst>
+            <pc:docMk/>
+            <pc:sldMk cId="136517662" sldId="285"/>
+            <ac:grpSpMk id="16" creationId="{8734DDD3-F723-4DD3-8ABE-EC0B2AC87D74}"/>
+          </ac:grpSpMkLst>
+        </pc:grpChg>
+      </pc:sldChg>
+      <pc:sldChg chg="addSp delSp modSp new mod setBg">
+        <pc:chgData name="Margo Bonal" userId="18c9fa0f-b53d-478b-9dc0-6ad88786c19f" providerId="ADAL" clId="{57E2D5E0-CA32-47BE-A2DC-7B0365E99328}" dt="2026-04-24T14:17:59.695" v="1153" actId="26606"/>
+        <pc:sldMkLst>
+          <pc:docMk/>
+          <pc:sldMk cId="294120850" sldId="286"/>
+        </pc:sldMkLst>
+        <pc:spChg chg="mod">
+          <ac:chgData name="Margo Bonal" userId="18c9fa0f-b53d-478b-9dc0-6ad88786c19f" providerId="ADAL" clId="{57E2D5E0-CA32-47BE-A2DC-7B0365E99328}" dt="2026-04-24T14:17:59.695" v="1153" actId="26606"/>
+          <ac:spMkLst>
+            <pc:docMk/>
+            <pc:sldMk cId="294120850" sldId="286"/>
+            <ac:spMk id="2" creationId="{E9C9ACDB-E88F-2B2C-A445-F5F7CD19BF57}"/>
+          </ac:spMkLst>
+        </pc:spChg>
+        <pc:spChg chg="del mod">
+          <ac:chgData name="Margo Bonal" userId="18c9fa0f-b53d-478b-9dc0-6ad88786c19f" providerId="ADAL" clId="{57E2D5E0-CA32-47BE-A2DC-7B0365E99328}" dt="2026-04-24T14:17:33.929" v="1145"/>
+          <ac:spMkLst>
+            <pc:docMk/>
+            <pc:sldMk cId="294120850" sldId="286"/>
+            <ac:spMk id="3" creationId="{E53C77C5-6D16-D666-EFB0-617970672F28}"/>
+          </ac:spMkLst>
+        </pc:spChg>
+        <pc:spChg chg="mod ord">
+          <ac:chgData name="Margo Bonal" userId="18c9fa0f-b53d-478b-9dc0-6ad88786c19f" providerId="ADAL" clId="{57E2D5E0-CA32-47BE-A2DC-7B0365E99328}" dt="2026-04-24T14:17:59.695" v="1153" actId="26606"/>
+          <ac:spMkLst>
+            <pc:docMk/>
+            <pc:sldMk cId="294120850" sldId="286"/>
+            <ac:spMk id="4" creationId="{E049FB81-7C3D-77BD-7D2D-40627D316BB6}"/>
+          </ac:spMkLst>
+        </pc:spChg>
+        <pc:spChg chg="add mod">
+          <ac:chgData name="Margo Bonal" userId="18c9fa0f-b53d-478b-9dc0-6ad88786c19f" providerId="ADAL" clId="{57E2D5E0-CA32-47BE-A2DC-7B0365E99328}" dt="2026-04-24T14:17:59.695" v="1153" actId="26606"/>
+          <ac:spMkLst>
+            <pc:docMk/>
+            <pc:sldMk cId="294120850" sldId="286"/>
+            <ac:spMk id="5" creationId="{8C93D68C-FF1A-6AAA-C0E9-D935E871DF40}"/>
+          </ac:spMkLst>
+        </pc:spChg>
+        <pc:spChg chg="add del">
+          <ac:chgData name="Margo Bonal" userId="18c9fa0f-b53d-478b-9dc0-6ad88786c19f" providerId="ADAL" clId="{57E2D5E0-CA32-47BE-A2DC-7B0365E99328}" dt="2026-04-24T14:17:23.762" v="1142" actId="26606"/>
+          <ac:spMkLst>
+            <pc:docMk/>
+            <pc:sldMk cId="294120850" sldId="286"/>
+            <ac:spMk id="9" creationId="{4E1BEB12-92AF-4445-98AD-4C7756E7C93B}"/>
+          </ac:spMkLst>
+        </pc:spChg>
+        <pc:spChg chg="add del">
+          <ac:chgData name="Margo Bonal" userId="18c9fa0f-b53d-478b-9dc0-6ad88786c19f" providerId="ADAL" clId="{57E2D5E0-CA32-47BE-A2DC-7B0365E99328}" dt="2026-04-24T14:17:23.762" v="1142" actId="26606"/>
+          <ac:spMkLst>
+            <pc:docMk/>
+            <pc:sldMk cId="294120850" sldId="286"/>
+            <ac:spMk id="11" creationId="{D0522C2C-7B5C-48A7-A969-03941E5D2E76}"/>
+          </ac:spMkLst>
+        </pc:spChg>
+        <pc:spChg chg="add del">
+          <ac:chgData name="Margo Bonal" userId="18c9fa0f-b53d-478b-9dc0-6ad88786c19f" providerId="ADAL" clId="{57E2D5E0-CA32-47BE-A2DC-7B0365E99328}" dt="2026-04-24T14:17:23.762" v="1142" actId="26606"/>
+          <ac:spMkLst>
+            <pc:docMk/>
+            <pc:sldMk cId="294120850" sldId="286"/>
+            <ac:spMk id="13" creationId="{9C682A1A-5B2D-4111-BBD6-620165633E5B}"/>
+          </ac:spMkLst>
+        </pc:spChg>
+        <pc:spChg chg="add del">
+          <ac:chgData name="Margo Bonal" userId="18c9fa0f-b53d-478b-9dc0-6ad88786c19f" providerId="ADAL" clId="{57E2D5E0-CA32-47BE-A2DC-7B0365E99328}" dt="2026-04-24T14:17:23.762" v="1142" actId="26606"/>
+          <ac:spMkLst>
+            <pc:docMk/>
+            <pc:sldMk cId="294120850" sldId="286"/>
+            <ac:spMk id="15" creationId="{D6EE29F2-D77F-4BD0-A20B-334D316A1C9D}"/>
+          </ac:spMkLst>
+        </pc:spChg>
+        <pc:spChg chg="add del">
+          <ac:chgData name="Margo Bonal" userId="18c9fa0f-b53d-478b-9dc0-6ad88786c19f" providerId="ADAL" clId="{57E2D5E0-CA32-47BE-A2DC-7B0365E99328}" dt="2026-04-24T14:17:59.695" v="1153" actId="26606"/>
+          <ac:spMkLst>
+            <pc:docMk/>
+            <pc:sldMk cId="294120850" sldId="286"/>
+            <ac:spMk id="16" creationId="{7653717E-6F8C-43E0-9893-C03AE87D18D6}"/>
+          </ac:spMkLst>
+        </pc:spChg>
+        <pc:spChg chg="add del">
+          <ac:chgData name="Margo Bonal" userId="18c9fa0f-b53d-478b-9dc0-6ad88786c19f" providerId="ADAL" clId="{57E2D5E0-CA32-47BE-A2DC-7B0365E99328}" dt="2026-04-24T14:17:23.762" v="1142" actId="26606"/>
+          <ac:spMkLst>
+            <pc:docMk/>
+            <pc:sldMk cId="294120850" sldId="286"/>
+            <ac:spMk id="17" creationId="{22D09ED2-868F-42C6-866E-F92E0CEF314F}"/>
+          </ac:spMkLst>
+        </pc:spChg>
+        <pc:spChg chg="add del">
+          <ac:chgData name="Margo Bonal" userId="18c9fa0f-b53d-478b-9dc0-6ad88786c19f" providerId="ADAL" clId="{57E2D5E0-CA32-47BE-A2DC-7B0365E99328}" dt="2026-04-24T14:17:59.695" v="1153" actId="26606"/>
+          <ac:spMkLst>
+            <pc:docMk/>
+            <pc:sldMk cId="294120850" sldId="286"/>
+            <ac:spMk id="18" creationId="{35BB14B4-EC3F-47C7-9AF3-B0E017B75C42}"/>
+          </ac:spMkLst>
+        </pc:spChg>
+        <pc:spChg chg="add del">
+          <ac:chgData name="Margo Bonal" userId="18c9fa0f-b53d-478b-9dc0-6ad88786c19f" providerId="ADAL" clId="{57E2D5E0-CA32-47BE-A2DC-7B0365E99328}" dt="2026-04-24T14:17:59.695" v="1153" actId="26606"/>
+          <ac:spMkLst>
+            <pc:docMk/>
+            <pc:sldMk cId="294120850" sldId="286"/>
+            <ac:spMk id="19" creationId="{8E2CC403-21CD-41DF-BAC4-329D7FF03C5C}"/>
+          </ac:spMkLst>
+        </pc:spChg>
+        <pc:spChg chg="add del">
+          <ac:chgData name="Margo Bonal" userId="18c9fa0f-b53d-478b-9dc0-6ad88786c19f" providerId="ADAL" clId="{57E2D5E0-CA32-47BE-A2DC-7B0365E99328}" dt="2026-04-24T14:17:58.274" v="1150" actId="26606"/>
+          <ac:spMkLst>
+            <pc:docMk/>
+            <pc:sldMk cId="294120850" sldId="286"/>
+            <ac:spMk id="26" creationId="{907EF6B7-1338-4443-8C46-6A318D952DFD}"/>
+          </ac:spMkLst>
+        </pc:spChg>
+        <pc:spChg chg="add del">
+          <ac:chgData name="Margo Bonal" userId="18c9fa0f-b53d-478b-9dc0-6ad88786c19f" providerId="ADAL" clId="{57E2D5E0-CA32-47BE-A2DC-7B0365E99328}" dt="2026-04-24T14:17:58.274" v="1150" actId="26606"/>
+          <ac:spMkLst>
+            <pc:docMk/>
+            <pc:sldMk cId="294120850" sldId="286"/>
+            <ac:spMk id="28" creationId="{DAAE4CDD-124C-4DCF-9584-B6033B545DD5}"/>
+          </ac:spMkLst>
+        </pc:spChg>
+        <pc:spChg chg="add del">
+          <ac:chgData name="Margo Bonal" userId="18c9fa0f-b53d-478b-9dc0-6ad88786c19f" providerId="ADAL" clId="{57E2D5E0-CA32-47BE-A2DC-7B0365E99328}" dt="2026-04-24T14:17:58.274" v="1150" actId="26606"/>
+          <ac:spMkLst>
+            <pc:docMk/>
+            <pc:sldMk cId="294120850" sldId="286"/>
+            <ac:spMk id="30" creationId="{081E4A58-353D-44AE-B2FC-2A74E2E400F7}"/>
+          </ac:spMkLst>
+        </pc:spChg>
+        <pc:spChg chg="add del">
+          <ac:chgData name="Margo Bonal" userId="18c9fa0f-b53d-478b-9dc0-6ad88786c19f" providerId="ADAL" clId="{57E2D5E0-CA32-47BE-A2DC-7B0365E99328}" dt="2026-04-24T14:17:59.681" v="1152" actId="26606"/>
+          <ac:spMkLst>
+            <pc:docMk/>
+            <pc:sldMk cId="294120850" sldId="286"/>
+            <ac:spMk id="32" creationId="{FA23A907-97FB-4A8F-880A-DD77401C4296}"/>
+          </ac:spMkLst>
+        </pc:spChg>
+        <pc:spChg chg="add del">
+          <ac:chgData name="Margo Bonal" userId="18c9fa0f-b53d-478b-9dc0-6ad88786c19f" providerId="ADAL" clId="{57E2D5E0-CA32-47BE-A2DC-7B0365E99328}" dt="2026-04-24T14:17:59.681" v="1152" actId="26606"/>
+          <ac:spMkLst>
+            <pc:docMk/>
+            <pc:sldMk cId="294120850" sldId="286"/>
+            <ac:spMk id="33" creationId="{C2554CA6-288E-4202-BC52-2E5A8F0C0AED}"/>
+          </ac:spMkLst>
+        </pc:spChg>
+        <pc:spChg chg="add del">
+          <ac:chgData name="Margo Bonal" userId="18c9fa0f-b53d-478b-9dc0-6ad88786c19f" providerId="ADAL" clId="{57E2D5E0-CA32-47BE-A2DC-7B0365E99328}" dt="2026-04-24T14:17:59.681" v="1152" actId="26606"/>
+          <ac:spMkLst>
+            <pc:docMk/>
+            <pc:sldMk cId="294120850" sldId="286"/>
+            <ac:spMk id="34" creationId="{B10BB131-AC8E-4A8E-A5D1-36260F720C3B}"/>
+          </ac:spMkLst>
+        </pc:spChg>
+        <pc:spChg chg="add del">
+          <ac:chgData name="Margo Bonal" userId="18c9fa0f-b53d-478b-9dc0-6ad88786c19f" providerId="ADAL" clId="{57E2D5E0-CA32-47BE-A2DC-7B0365E99328}" dt="2026-04-24T14:17:59.681" v="1152" actId="26606"/>
+          <ac:spMkLst>
+            <pc:docMk/>
+            <pc:sldMk cId="294120850" sldId="286"/>
+            <ac:spMk id="35" creationId="{5B7778FC-632E-4DCA-A7CB-0D7731CCF970}"/>
+          </ac:spMkLst>
+        </pc:spChg>
+        <pc:spChg chg="add">
+          <ac:chgData name="Margo Bonal" userId="18c9fa0f-b53d-478b-9dc0-6ad88786c19f" providerId="ADAL" clId="{57E2D5E0-CA32-47BE-A2DC-7B0365E99328}" dt="2026-04-24T14:17:59.695" v="1153" actId="26606"/>
+          <ac:spMkLst>
+            <pc:docMk/>
+            <pc:sldMk cId="294120850" sldId="286"/>
+            <ac:spMk id="37" creationId="{907EF6B7-1338-4443-8C46-6A318D952DFD}"/>
+          </ac:spMkLst>
+        </pc:spChg>
+        <pc:spChg chg="add">
+          <ac:chgData name="Margo Bonal" userId="18c9fa0f-b53d-478b-9dc0-6ad88786c19f" providerId="ADAL" clId="{57E2D5E0-CA32-47BE-A2DC-7B0365E99328}" dt="2026-04-24T14:17:59.695" v="1153" actId="26606"/>
+          <ac:spMkLst>
+            <pc:docMk/>
+            <pc:sldMk cId="294120850" sldId="286"/>
+            <ac:spMk id="38" creationId="{DAAE4CDD-124C-4DCF-9584-B6033B545DD5}"/>
+          </ac:spMkLst>
+        </pc:spChg>
+        <pc:spChg chg="add">
+          <ac:chgData name="Margo Bonal" userId="18c9fa0f-b53d-478b-9dc0-6ad88786c19f" providerId="ADAL" clId="{57E2D5E0-CA32-47BE-A2DC-7B0365E99328}" dt="2026-04-24T14:17:59.695" v="1153" actId="26606"/>
+          <ac:spMkLst>
+            <pc:docMk/>
+            <pc:sldMk cId="294120850" sldId="286"/>
+            <ac:spMk id="39" creationId="{081E4A58-353D-44AE-B2FC-2A74E2E400F7}"/>
+          </ac:spMkLst>
+        </pc:spChg>
+        <pc:grpChg chg="add del">
+          <ac:chgData name="Margo Bonal" userId="18c9fa0f-b53d-478b-9dc0-6ad88786c19f" providerId="ADAL" clId="{57E2D5E0-CA32-47BE-A2DC-7B0365E99328}" dt="2026-04-24T14:17:59.695" v="1153" actId="26606"/>
+          <ac:grpSpMkLst>
+            <pc:docMk/>
+            <pc:sldMk cId="294120850" sldId="286"/>
+            <ac:grpSpMk id="20" creationId="{B13AA5FE-3FFC-4725-9ADD-E428544EC61B}"/>
+          </ac:grpSpMkLst>
+        </pc:grpChg>
+      </pc:sldChg>
+      <pc:sldMasterChg chg="setBg modSldLayout">
+        <pc:chgData name="Margo Bonal" userId="18c9fa0f-b53d-478b-9dc0-6ad88786c19f" providerId="ADAL" clId="{57E2D5E0-CA32-47BE-A2DC-7B0365E99328}" dt="2026-04-24T13:54:46.104" v="857"/>
+        <pc:sldMasterMkLst>
+          <pc:docMk/>
+          <pc:sldMasterMk cId="450208615" sldId="2147483648"/>
+        </pc:sldMasterMkLst>
+        <pc:sldLayoutChg chg="setBg">
+          <pc:chgData name="Margo Bonal" userId="18c9fa0f-b53d-478b-9dc0-6ad88786c19f" providerId="ADAL" clId="{57E2D5E0-CA32-47BE-A2DC-7B0365E99328}" dt="2026-04-24T13:54:46.104" v="857"/>
+          <pc:sldLayoutMkLst>
+            <pc:docMk/>
+            <pc:sldMasterMk cId="450208615" sldId="2147483648"/>
+            <pc:sldLayoutMk cId="3346914439" sldId="2147483649"/>
+          </pc:sldLayoutMkLst>
+        </pc:sldLayoutChg>
+        <pc:sldLayoutChg chg="setBg">
+          <pc:chgData name="Margo Bonal" userId="18c9fa0f-b53d-478b-9dc0-6ad88786c19f" providerId="ADAL" clId="{57E2D5E0-CA32-47BE-A2DC-7B0365E99328}" dt="2026-04-24T13:54:46.104" v="857"/>
+          <pc:sldLayoutMkLst>
+            <pc:docMk/>
+            <pc:sldMasterMk cId="450208615" sldId="2147483648"/>
+            <pc:sldLayoutMk cId="199624701" sldId="2147483650"/>
+          </pc:sldLayoutMkLst>
+        </pc:sldLayoutChg>
+        <pc:sldLayoutChg chg="setBg">
+          <pc:chgData name="Margo Bonal" userId="18c9fa0f-b53d-478b-9dc0-6ad88786c19f" providerId="ADAL" clId="{57E2D5E0-CA32-47BE-A2DC-7B0365E99328}" dt="2026-04-24T13:54:46.104" v="857"/>
+          <pc:sldLayoutMkLst>
+            <pc:docMk/>
+            <pc:sldMasterMk cId="450208615" sldId="2147483648"/>
+            <pc:sldLayoutMk cId="2502619102" sldId="2147483651"/>
+          </pc:sldLayoutMkLst>
+        </pc:sldLayoutChg>
+        <pc:sldLayoutChg chg="setBg">
+          <pc:chgData name="Margo Bonal" userId="18c9fa0f-b53d-478b-9dc0-6ad88786c19f" providerId="ADAL" clId="{57E2D5E0-CA32-47BE-A2DC-7B0365E99328}" dt="2026-04-24T13:54:46.104" v="857"/>
+          <pc:sldLayoutMkLst>
+            <pc:docMk/>
+            <pc:sldMasterMk cId="450208615" sldId="2147483648"/>
+            <pc:sldLayoutMk cId="2310478409" sldId="2147483652"/>
+          </pc:sldLayoutMkLst>
+        </pc:sldLayoutChg>
+        <pc:sldLayoutChg chg="setBg">
+          <pc:chgData name="Margo Bonal" userId="18c9fa0f-b53d-478b-9dc0-6ad88786c19f" providerId="ADAL" clId="{57E2D5E0-CA32-47BE-A2DC-7B0365E99328}" dt="2026-04-24T13:54:46.104" v="857"/>
+          <pc:sldLayoutMkLst>
+            <pc:docMk/>
+            <pc:sldMasterMk cId="450208615" sldId="2147483648"/>
+            <pc:sldLayoutMk cId="3140129718" sldId="2147483653"/>
+          </pc:sldLayoutMkLst>
+        </pc:sldLayoutChg>
+        <pc:sldLayoutChg chg="setBg">
+          <pc:chgData name="Margo Bonal" userId="18c9fa0f-b53d-478b-9dc0-6ad88786c19f" providerId="ADAL" clId="{57E2D5E0-CA32-47BE-A2DC-7B0365E99328}" dt="2026-04-24T13:54:46.104" v="857"/>
+          <pc:sldLayoutMkLst>
+            <pc:docMk/>
+            <pc:sldMasterMk cId="450208615" sldId="2147483648"/>
+            <pc:sldLayoutMk cId="3066859592" sldId="2147483654"/>
+          </pc:sldLayoutMkLst>
+        </pc:sldLayoutChg>
+        <pc:sldLayoutChg chg="setBg">
+          <pc:chgData name="Margo Bonal" userId="18c9fa0f-b53d-478b-9dc0-6ad88786c19f" providerId="ADAL" clId="{57E2D5E0-CA32-47BE-A2DC-7B0365E99328}" dt="2026-04-24T13:54:46.104" v="857"/>
+          <pc:sldLayoutMkLst>
+            <pc:docMk/>
+            <pc:sldMasterMk cId="450208615" sldId="2147483648"/>
+            <pc:sldLayoutMk cId="3395074677" sldId="2147483655"/>
+          </pc:sldLayoutMkLst>
+        </pc:sldLayoutChg>
+        <pc:sldLayoutChg chg="setBg">
+          <pc:chgData name="Margo Bonal" userId="18c9fa0f-b53d-478b-9dc0-6ad88786c19f" providerId="ADAL" clId="{57E2D5E0-CA32-47BE-A2DC-7B0365E99328}" dt="2026-04-24T13:54:46.104" v="857"/>
+          <pc:sldLayoutMkLst>
+            <pc:docMk/>
+            <pc:sldMasterMk cId="450208615" sldId="2147483648"/>
+            <pc:sldLayoutMk cId="3789717152" sldId="2147483656"/>
+          </pc:sldLayoutMkLst>
+        </pc:sldLayoutChg>
+        <pc:sldLayoutChg chg="setBg">
+          <pc:chgData name="Margo Bonal" userId="18c9fa0f-b53d-478b-9dc0-6ad88786c19f" providerId="ADAL" clId="{57E2D5E0-CA32-47BE-A2DC-7B0365E99328}" dt="2026-04-24T13:54:46.104" v="857"/>
+          <pc:sldLayoutMkLst>
+            <pc:docMk/>
+            <pc:sldMasterMk cId="450208615" sldId="2147483648"/>
+            <pc:sldLayoutMk cId="768275673" sldId="2147483657"/>
+          </pc:sldLayoutMkLst>
+        </pc:sldLayoutChg>
+        <pc:sldLayoutChg chg="setBg">
+          <pc:chgData name="Margo Bonal" userId="18c9fa0f-b53d-478b-9dc0-6ad88786c19f" providerId="ADAL" clId="{57E2D5E0-CA32-47BE-A2DC-7B0365E99328}" dt="2026-04-24T13:54:46.104" v="857"/>
+          <pc:sldLayoutMkLst>
+            <pc:docMk/>
+            <pc:sldMasterMk cId="450208615" sldId="2147483648"/>
+            <pc:sldLayoutMk cId="543652303" sldId="2147483658"/>
+          </pc:sldLayoutMkLst>
+        </pc:sldLayoutChg>
+        <pc:sldLayoutChg chg="setBg">
+          <pc:chgData name="Margo Bonal" userId="18c9fa0f-b53d-478b-9dc0-6ad88786c19f" providerId="ADAL" clId="{57E2D5E0-CA32-47BE-A2DC-7B0365E99328}" dt="2026-04-24T13:54:46.104" v="857"/>
+          <pc:sldLayoutMkLst>
+            <pc:docMk/>
+            <pc:sldMasterMk cId="450208615" sldId="2147483648"/>
+            <pc:sldLayoutMk cId="2315433791" sldId="2147483659"/>
+          </pc:sldLayoutMkLst>
+        </pc:sldLayoutChg>
+      </pc:sldMasterChg>
     </pc:docChg>
   </pc:docChgLst>
 </pc:chgInfo>
@@ -881,7 +2052,7 @@
           <a:p>
             <a:fld id="{94B41067-BB97-4141-BE03-333F3191E3F1}" type="datetimeFigureOut">
               <a:rPr lang="en-US" smtClean="0"/>
-              <a:t>4/23/2026</a:t>
+              <a:t>4/24/2026</a:t>
             </a:fld>
             <a:endParaRPr lang="en-US"/>
           </a:p>
@@ -1059,7 +2230,7 @@
           <a:p>
             <a:fld id="{B1F2A6E6-BB86-4722-837C-048EA2408876}" type="datetimeFigureOut">
               <a:rPr lang="en-US" smtClean="0"/>
-              <a:t>4/23/2026</a:t>
+              <a:t>4/24/2026</a:t>
             </a:fld>
             <a:endParaRPr lang="en-US"/>
           </a:p>
@@ -1327,6 +2498,90 @@
 </p:notesMaster>
 </file>
 
+<file path=ppt/notesSlides/notesSlide1.xml><?xml version="1.0" encoding="utf-8"?>
+<p:notes xmlns:a="http://schemas.openxmlformats.org/drawingml/2006/main" xmlns:r="http://schemas.openxmlformats.org/officeDocument/2006/relationships" xmlns:p="http://schemas.openxmlformats.org/presentationml/2006/main">
+  <p:cSld>
+    <p:spTree>
+      <p:nvGrpSpPr>
+        <p:cNvPr id="1" name=""/>
+        <p:cNvGrpSpPr/>
+        <p:nvPr/>
+      </p:nvGrpSpPr>
+      <p:grpSpPr>
+        <a:xfrm>
+          <a:off x="0" y="0"/>
+          <a:ext cx="0" cy="0"/>
+          <a:chOff x="0" y="0"/>
+          <a:chExt cx="0" cy="0"/>
+        </a:xfrm>
+      </p:grpSpPr>
+      <p:sp>
+        <p:nvSpPr>
+          <p:cNvPr id="2" name="Slide Image Placeholder 1"/>
+          <p:cNvSpPr>
+            <a:spLocks noGrp="1" noRot="1" noChangeAspect="1"/>
+          </p:cNvSpPr>
+          <p:nvPr>
+            <p:ph type="sldImg"/>
+          </p:nvPr>
+        </p:nvSpPr>
+        <p:spPr/>
+      </p:sp>
+      <p:sp>
+        <p:nvSpPr>
+          <p:cNvPr id="3" name="Notes Placeholder 2"/>
+          <p:cNvSpPr>
+            <a:spLocks noGrp="1"/>
+          </p:cNvSpPr>
+          <p:nvPr>
+            <p:ph type="body" idx="1"/>
+          </p:nvPr>
+        </p:nvSpPr>
+        <p:spPr/>
+        <p:txBody>
+          <a:bodyPr/>
+          <a:lstStyle/>
+          <a:p>
+            <a:endParaRPr lang="en-US" dirty="0"/>
+          </a:p>
+        </p:txBody>
+      </p:sp>
+      <p:sp>
+        <p:nvSpPr>
+          <p:cNvPr id="4" name="Slide Number Placeholder 3"/>
+          <p:cNvSpPr>
+            <a:spLocks noGrp="1"/>
+          </p:cNvSpPr>
+          <p:nvPr>
+            <p:ph type="sldNum" sz="quarter" idx="5"/>
+          </p:nvPr>
+        </p:nvSpPr>
+        <p:spPr/>
+        <p:txBody>
+          <a:bodyPr/>
+          <a:lstStyle/>
+          <a:p>
+            <a:fld id="{DBA3B6B7-4283-4814-95B1-8D2476E93965}" type="slidenum">
+              <a:rPr lang="en-US" smtClean="0"/>
+              <a:t>6</a:t>
+            </a:fld>
+            <a:endParaRPr lang="en-US"/>
+          </a:p>
+        </p:txBody>
+      </p:sp>
+    </p:spTree>
+    <p:extLst>
+      <p:ext uri="{BB962C8B-B14F-4D97-AF65-F5344CB8AC3E}">
+        <p14:creationId xmlns:p14="http://schemas.microsoft.com/office/powerpoint/2010/main" val="1669343753"/>
+      </p:ext>
+    </p:extLst>
+  </p:cSld>
+  <p:clrMapOvr>
+    <a:masterClrMapping/>
+  </p:clrMapOvr>
+</p:notes>
+</file>
+
 <file path=ppt/slideLayouts/slideLayout1.xml><?xml version="1.0" encoding="utf-8"?>
 <p:sldLayout xmlns:a="http://schemas.openxmlformats.org/drawingml/2006/main" xmlns:r="http://schemas.openxmlformats.org/officeDocument/2006/relationships" xmlns:p="http://schemas.openxmlformats.org/presentationml/2006/main" type="title" preserve="1">
   <p:cSld name="Title Slide">
@@ -1474,7 +2729,7 @@
           <a:p>
             <a:fld id="{4AB6B06F-CD46-493E-B4C1-40B0073FF9CE}" type="datetime1">
               <a:rPr lang="en-US" smtClean="0"/>
-              <a:t>4/23/2026</a:t>
+              <a:t>4/24/2026</a:t>
             </a:fld>
             <a:endParaRPr lang="en-US"/>
           </a:p>
@@ -1672,7 +2927,7 @@
           <a:p>
             <a:fld id="{42C1183B-3CD1-4369-AAE8-CB56440A4F36}" type="datetime1">
               <a:rPr lang="en-US" smtClean="0"/>
-              <a:t>4/23/2026</a:t>
+              <a:t>4/24/2026</a:t>
             </a:fld>
             <a:endParaRPr lang="en-US"/>
           </a:p>
@@ -1880,7 +3135,7 @@
           <a:p>
             <a:fld id="{D5CA9937-735C-4AE0-B15E-EEF043CCC6A0}" type="datetime1">
               <a:rPr lang="en-US" smtClean="0"/>
-              <a:t>4/23/2026</a:t>
+              <a:t>4/24/2026</a:t>
             </a:fld>
             <a:endParaRPr lang="en-US"/>
           </a:p>
@@ -2078,7 +3333,7 @@
           <a:p>
             <a:fld id="{BB0D027D-103C-46C6-ADAD-0DC1C73EBC80}" type="datetime1">
               <a:rPr lang="en-US" smtClean="0"/>
-              <a:t>4/23/2026</a:t>
+              <a:t>4/24/2026</a:t>
             </a:fld>
             <a:endParaRPr lang="en-US"/>
           </a:p>
@@ -2353,7 +3608,7 @@
           <a:p>
             <a:fld id="{734F51D7-1495-4ADD-AC16-FF82DF6CAC20}" type="datetime1">
               <a:rPr lang="en-US" smtClean="0"/>
-              <a:t>4/23/2026</a:t>
+              <a:t>4/24/2026</a:t>
             </a:fld>
             <a:endParaRPr lang="en-US"/>
           </a:p>
@@ -2618,7 +3873,7 @@
           <a:p>
             <a:fld id="{78B03BB5-D48A-48C3-9CFB-DC9185E67675}" type="datetime1">
               <a:rPr lang="en-US" smtClean="0"/>
-              <a:t>4/23/2026</a:t>
+              <a:t>4/24/2026</a:t>
             </a:fld>
             <a:endParaRPr lang="en-US"/>
           </a:p>
@@ -3030,7 +4285,7 @@
           <a:p>
             <a:fld id="{F68F73DE-E7FB-4126-830F-99616741AA11}" type="datetime1">
               <a:rPr lang="en-US" smtClean="0"/>
-              <a:t>4/23/2026</a:t>
+              <a:t>4/24/2026</a:t>
             </a:fld>
             <a:endParaRPr lang="en-US"/>
           </a:p>
@@ -3171,7 +4426,7 @@
           <a:p>
             <a:fld id="{8056F203-9046-43D5-87CE-3C67C2F4D3F1}" type="datetime1">
               <a:rPr lang="en-US" smtClean="0"/>
-              <a:t>4/23/2026</a:t>
+              <a:t>4/24/2026</a:t>
             </a:fld>
             <a:endParaRPr lang="en-US"/>
           </a:p>
@@ -3284,7 +4539,7 @@
           <a:p>
             <a:fld id="{936CD8F1-3E73-46D1-AA5C-5366FE0387E8}" type="datetime1">
               <a:rPr lang="en-US" smtClean="0"/>
-              <a:t>4/23/2026</a:t>
+              <a:t>4/24/2026</a:t>
             </a:fld>
             <a:endParaRPr lang="en-US"/>
           </a:p>
@@ -3595,7 +4850,7 @@
           <a:p>
             <a:fld id="{D5E130E8-8094-4080-98F0-F0540BF5F6CC}" type="datetime1">
               <a:rPr lang="en-US" smtClean="0"/>
-              <a:t>4/23/2026</a:t>
+              <a:t>4/24/2026</a:t>
             </a:fld>
             <a:endParaRPr lang="en-US"/>
           </a:p>
@@ -3883,7 +5138,7 @@
           <a:p>
             <a:fld id="{C9587556-5D11-4218-8636-A360C44E36D7}" type="datetime1">
               <a:rPr lang="en-US" smtClean="0"/>
-              <a:t>4/23/2026</a:t>
+              <a:t>4/24/2026</a:t>
             </a:fld>
             <a:endParaRPr lang="en-US"/>
           </a:p>
@@ -4124,7 +5379,7 @@
           <a:p>
             <a:fld id="{7216C7B1-23C1-4975-8B1F-F3C993B7D970}" type="datetime1">
               <a:rPr lang="en-US" smtClean="0"/>
-              <a:t>4/23/2026</a:t>
+              <a:t>4/24/2026</a:t>
             </a:fld>
             <a:endParaRPr lang="en-US"/>
           </a:p>
@@ -4867,6 +6122,255 @@
 </p:sld>
 </file>
 
+<file path=ppt/slides/slide10.xml><?xml version="1.0" encoding="utf-8"?>
+<p:sld xmlns:a="http://schemas.openxmlformats.org/drawingml/2006/main" xmlns:r="http://schemas.openxmlformats.org/officeDocument/2006/relationships" xmlns:p="http://schemas.openxmlformats.org/presentationml/2006/main">
+  <p:cSld>
+    <p:spTree>
+      <p:nvGrpSpPr>
+        <p:cNvPr id="1" name=""/>
+        <p:cNvGrpSpPr/>
+        <p:nvPr/>
+      </p:nvGrpSpPr>
+      <p:grpSpPr>
+        <a:xfrm>
+          <a:off x="0" y="0"/>
+          <a:ext cx="0" cy="0"/>
+          <a:chOff x="0" y="0"/>
+          <a:chExt cx="0" cy="0"/>
+        </a:xfrm>
+      </p:grpSpPr>
+      <p:sp useBgFill="1">
+        <p:nvSpPr>
+          <p:cNvPr id="12" name="Rectangle 11">
+            <a:extLst>
+              <a:ext uri="{FF2B5EF4-FFF2-40B4-BE49-F238E27FC236}">
+                <a16:creationId xmlns:a16="http://schemas.microsoft.com/office/drawing/2014/main" id="{74751229-0244-4FBB-BED1-407467F4C951}"/>
+              </a:ext>
+              <a:ext uri="{C183D7F6-B498-43B3-948B-1728B52AA6E4}">
+                <adec:decorative xmlns:adec="http://schemas.microsoft.com/office/drawing/2017/decorative" val="1"/>
+              </a:ext>
+            </a:extLst>
+          </p:cNvPr>
+          <p:cNvSpPr>
+            <a:spLocks noGrp="1" noRot="1" noChangeAspect="1" noMove="1" noResize="1" noEditPoints="1" noAdjustHandles="1" noChangeArrowheads="1" noChangeShapeType="1" noTextEdit="1"/>
+          </p:cNvSpPr>
+          <p:nvPr>
+            <p:extLst>
+              <p:ext uri="{386F3935-93C4-4BCD-93E2-E3B085C9AB24}">
+                <p16:designElem xmlns:p16="http://schemas.microsoft.com/office/powerpoint/2015/main" val="1"/>
+              </p:ext>
+            </p:extLst>
+          </p:nvPr>
+        </p:nvSpPr>
+        <p:spPr>
+          <a:xfrm>
+            <a:off x="0" y="0"/>
+            <a:ext cx="12188952" cy="6858000"/>
+          </a:xfrm>
+          <a:prstGeom prst="rect">
+            <a:avLst/>
+          </a:prstGeom>
+          <a:ln>
+            <a:noFill/>
+          </a:ln>
+        </p:spPr>
+        <p:style>
+          <a:lnRef idx="2">
+            <a:schemeClr val="accent1">
+              <a:shade val="50000"/>
+            </a:schemeClr>
+          </a:lnRef>
+          <a:fillRef idx="1">
+            <a:schemeClr val="accent1"/>
+          </a:fillRef>
+          <a:effectRef idx="0">
+            <a:schemeClr val="accent1"/>
+          </a:effectRef>
+          <a:fontRef idx="minor">
+            <a:schemeClr val="lt1"/>
+          </a:fontRef>
+        </p:style>
+        <p:txBody>
+          <a:bodyPr rtlCol="0" anchor="ctr"/>
+          <a:lstStyle/>
+          <a:p>
+            <a:pPr algn="ctr"/>
+            <a:endParaRPr lang="en-US"/>
+          </a:p>
+        </p:txBody>
+      </p:sp>
+      <p:sp>
+        <p:nvSpPr>
+          <p:cNvPr id="2" name="Title 1">
+            <a:extLst>
+              <a:ext uri="{FF2B5EF4-FFF2-40B4-BE49-F238E27FC236}">
+                <a16:creationId xmlns:a16="http://schemas.microsoft.com/office/drawing/2014/main" id="{153C799C-4835-C8CB-B090-70E82B558CED}"/>
+              </a:ext>
+            </a:extLst>
+          </p:cNvPr>
+          <p:cNvSpPr>
+            <a:spLocks noGrp="1"/>
+          </p:cNvSpPr>
+          <p:nvPr>
+            <p:ph type="title"/>
+          </p:nvPr>
+        </p:nvSpPr>
+        <p:spPr>
+          <a:xfrm>
+            <a:off x="2396396" y="2777551"/>
+            <a:ext cx="4735924" cy="1198689"/>
+          </a:xfrm>
+        </p:spPr>
+        <p:txBody>
+          <a:bodyPr vert="horz" lIns="91440" tIns="45720" rIns="91440" bIns="45720" rtlCol="0" anchor="b">
+            <a:normAutofit/>
+          </a:bodyPr>
+          <a:lstStyle/>
+          <a:p>
+            <a:r>
+              <a:rPr lang="en-US" sz="8000" i="1" kern="1200" dirty="0">
+                <a:solidFill>
+                  <a:schemeClr val="tx1"/>
+                </a:solidFill>
+                <a:latin typeface="+mj-lt"/>
+                <a:ea typeface="+mj-ea"/>
+                <a:cs typeface="+mj-cs"/>
+              </a:rPr>
+              <a:t>Questions</a:t>
+            </a:r>
+          </a:p>
+        </p:txBody>
+      </p:sp>
+      <p:pic>
+        <p:nvPicPr>
+          <p:cNvPr id="7" name="Graphic 6" descr="Help">
+            <a:extLst>
+              <a:ext uri="{FF2B5EF4-FFF2-40B4-BE49-F238E27FC236}">
+                <a16:creationId xmlns:a16="http://schemas.microsoft.com/office/drawing/2014/main" id="{69A52293-75E5-359D-7395-51D899F9087B}"/>
+              </a:ext>
+            </a:extLst>
+          </p:cNvPr>
+          <p:cNvPicPr>
+            <a:picLocks noChangeAspect="1"/>
+          </p:cNvPicPr>
+          <p:nvPr/>
+        </p:nvPicPr>
+        <p:blipFill>
+          <a:blip>
+            <a:extLst>
+              <a:ext uri="{28A0092B-C50C-407E-A947-70E740481C1C}">
+                <a14:useLocalDpi xmlns:a14="http://schemas.microsoft.com/office/drawing/2010/main" val="0"/>
+              </a:ext>
+              <a:ext uri="{96DAC541-7B7A-43D3-8B79-37D633B846F1}">
+                <asvg:svgBlip xmlns:asvg="http://schemas.microsoft.com/office/drawing/2016/SVG/main" r:embed="rId2"/>
+              </a:ext>
+            </a:extLst>
+          </a:blip>
+          <a:stretch>
+            <a:fillRect/>
+          </a:stretch>
+        </p:blipFill>
+        <p:spPr>
+          <a:xfrm>
+            <a:off x="475949" y="2777552"/>
+            <a:ext cx="1289051" cy="1289051"/>
+          </a:xfrm>
+          <a:prstGeom prst="rect">
+            <a:avLst/>
+          </a:prstGeom>
+        </p:spPr>
+      </p:pic>
+      <p:pic>
+        <p:nvPicPr>
+          <p:cNvPr id="9" name="Graphic 8" descr="Help">
+            <a:extLst>
+              <a:ext uri="{FF2B5EF4-FFF2-40B4-BE49-F238E27FC236}">
+                <a16:creationId xmlns:a16="http://schemas.microsoft.com/office/drawing/2014/main" id="{F1648FD1-EAB6-4C51-B9EC-A31CFF67AC7F}"/>
+              </a:ext>
+              <a:ext uri="{C183D7F6-B498-43B3-948B-1728B52AA6E4}">
+                <adec:decorative xmlns:adec="http://schemas.microsoft.com/office/drawing/2017/decorative" val="1"/>
+              </a:ext>
+            </a:extLst>
+          </p:cNvPr>
+          <p:cNvPicPr>
+            <a:picLocks noGrp="1" noRot="1" noChangeAspect="1" noMove="1" noResize="1" noEditPoints="1" noAdjustHandles="1" noChangeArrowheads="1" noChangeShapeType="1" noCrop="1"/>
+          </p:cNvPicPr>
+          <p:nvPr>
+            <p:extLst>
+              <p:ext uri="{386F3935-93C4-4BCD-93E2-E3B085C9AB24}">
+                <p16:designElem xmlns:p16="http://schemas.microsoft.com/office/powerpoint/2015/main" val="1"/>
+              </p:ext>
+            </p:extLst>
+          </p:nvPr>
+        </p:nvPicPr>
+        <p:blipFill>
+          <a:blip>
+            <a:alphaModFix amt="15000"/>
+            <a:extLst>
+              <a:ext uri="{28A0092B-C50C-407E-A947-70E740481C1C}">
+                <a14:useLocalDpi xmlns:a14="http://schemas.microsoft.com/office/drawing/2010/main" val="0"/>
+              </a:ext>
+              <a:ext uri="{96DAC541-7B7A-43D3-8B79-37D633B846F1}">
+                <asvg:svgBlip xmlns:asvg="http://schemas.microsoft.com/office/drawing/2016/SVG/main" r:embed="rId2"/>
+              </a:ext>
+            </a:extLst>
+          </a:blip>
+          <a:stretch>
+            <a:fillRect/>
+          </a:stretch>
+        </p:blipFill>
+        <p:spPr>
+          <a:xfrm>
+            <a:off x="6607815" y="716407"/>
+            <a:ext cx="5411343" cy="5411343"/>
+          </a:xfrm>
+          <a:prstGeom prst="rect">
+            <a:avLst/>
+          </a:prstGeom>
+        </p:spPr>
+      </p:pic>
+      <p:sp>
+        <p:nvSpPr>
+          <p:cNvPr id="3" name="Slide Number Placeholder 2">
+            <a:extLst>
+              <a:ext uri="{FF2B5EF4-FFF2-40B4-BE49-F238E27FC236}">
+                <a16:creationId xmlns:a16="http://schemas.microsoft.com/office/drawing/2014/main" id="{986FFE89-6C3C-A07F-03B6-6620445DFD75}"/>
+              </a:ext>
+            </a:extLst>
+          </p:cNvPr>
+          <p:cNvSpPr>
+            <a:spLocks noGrp="1"/>
+          </p:cNvSpPr>
+          <p:nvPr>
+            <p:ph type="sldNum" sz="quarter" idx="12"/>
+          </p:nvPr>
+        </p:nvSpPr>
+        <p:spPr/>
+        <p:txBody>
+          <a:bodyPr/>
+          <a:lstStyle/>
+          <a:p>
+            <a:fld id="{6CC2E120-88CB-4223-BF42-F8F7A034DB50}" type="slidenum">
+              <a:rPr lang="en-US" smtClean="0"/>
+              <a:t>10</a:t>
+            </a:fld>
+            <a:endParaRPr lang="en-US"/>
+          </a:p>
+        </p:txBody>
+      </p:sp>
+    </p:spTree>
+    <p:extLst>
+      <p:ext uri="{BB962C8B-B14F-4D97-AF65-F5344CB8AC3E}">
+        <p14:creationId xmlns:p14="http://schemas.microsoft.com/office/powerpoint/2010/main" val="3773506301"/>
+      </p:ext>
+    </p:extLst>
+  </p:cSld>
+  <p:clrMapOvr>
+    <a:masterClrMapping/>
+  </p:clrMapOvr>
+</p:sld>
+</file>
+
 <file path=ppt/slides/slide2.xml><?xml version="1.0" encoding="utf-8"?>
 <p:sld xmlns:a="http://schemas.openxmlformats.org/drawingml/2006/main" xmlns:r="http://schemas.openxmlformats.org/officeDocument/2006/relationships" xmlns:p="http://schemas.openxmlformats.org/presentationml/2006/main">
   <p:cSld>
@@ -4989,7 +6493,7 @@
                 <a:ea typeface="+mj-ea"/>
                 <a:cs typeface="+mj-cs"/>
               </a:rPr>
-              <a:t>Description</a:t>
+              <a:t>Motivation</a:t>
             </a:r>
           </a:p>
         </p:txBody>
@@ -5033,6 +6537,20 @@
                 </a:solidFill>
               </a:rPr>
               <a:t>Fitness web app for tracking campus athletic activities</a:t>
+            </a:r>
+          </a:p>
+          <a:p>
+            <a:pPr marL="171450" indent="-171450">
+              <a:buFont typeface="Arial" panose="020B0604020202020204" pitchFamily="34" charset="0"/>
+              <a:buChar char="•"/>
+            </a:pPr>
+            <a:r>
+              <a:rPr lang="en-US" sz="2000" dirty="0">
+                <a:solidFill>
+                  <a:schemeClr val="tx1"/>
+                </a:solidFill>
+              </a:rPr>
+              <a:t>Accessible on PC, tablets, phones</a:t>
             </a:r>
           </a:p>
           <a:p>
@@ -7575,7 +9093,7 @@
                 <a:ea typeface="+mn-ea"/>
                 <a:cs typeface="+mn-cs"/>
               </a:rPr>
-              <a:t>Users stored as unique id</a:t>
+              <a:t>Users stored as unique id, never sent as raw data</a:t>
             </a:r>
           </a:p>
           <a:p>
@@ -7584,16 +9102,35 @@
               <a:buChar char="•"/>
             </a:pPr>
             <a:r>
-              <a:rPr lang="en-US" sz="2000" kern="1200" dirty="0">
+              <a:rPr lang="en-US" sz="2000" dirty="0">
                 <a:solidFill>
                   <a:schemeClr val="tx1"/>
                 </a:solidFill>
-                <a:latin typeface="+mn-lt"/>
-                <a:ea typeface="+mn-ea"/>
-                <a:cs typeface="+mn-cs"/>
               </a:rPr>
-              <a:t>User information never sent as raw data</a:t>
+              <a:t>Meet project specified criteria, successfully launch app, available online</a:t>
             </a:r>
+            <a:endParaRPr lang="en-US" sz="2000" kern="1200" dirty="0">
+              <a:solidFill>
+                <a:schemeClr val="tx1"/>
+              </a:solidFill>
+              <a:latin typeface="+mn-lt"/>
+              <a:ea typeface="+mn-ea"/>
+              <a:cs typeface="+mn-cs"/>
+            </a:endParaRPr>
+          </a:p>
+          <a:p>
+            <a:pPr marL="342900" indent="-342900">
+              <a:buFont typeface="Arial" panose="020B0604020202020204" pitchFamily="34" charset="0"/>
+              <a:buChar char="•"/>
+            </a:pPr>
+            <a:endParaRPr lang="en-US" sz="2000" kern="1200" dirty="0">
+              <a:solidFill>
+                <a:schemeClr val="tx1"/>
+              </a:solidFill>
+              <a:latin typeface="+mn-lt"/>
+              <a:ea typeface="+mn-ea"/>
+              <a:cs typeface="+mn-cs"/>
+            </a:endParaRPr>
           </a:p>
         </p:txBody>
       </p:sp>
@@ -7981,31 +9518,6 @@
           </a:p>
         </p:txBody>
       </p:sp>
-      <p:sp>
-        <p:nvSpPr>
-          <p:cNvPr id="8" name="Text Placeholder 7">
-            <a:extLst>
-              <a:ext uri="{FF2B5EF4-FFF2-40B4-BE49-F238E27FC236}">
-                <a16:creationId xmlns:a16="http://schemas.microsoft.com/office/drawing/2014/main" id="{243C43E9-308C-3F97-571D-4B2588459719}"/>
-              </a:ext>
-            </a:extLst>
-          </p:cNvPr>
-          <p:cNvSpPr>
-            <a:spLocks noGrp="1"/>
-          </p:cNvSpPr>
-          <p:nvPr>
-            <p:ph type="body" idx="1"/>
-          </p:nvPr>
-        </p:nvSpPr>
-        <p:spPr/>
-        <p:txBody>
-          <a:bodyPr/>
-          <a:lstStyle/>
-          <a:p>
-            <a:endParaRPr lang="en-US" dirty="0"/>
-          </a:p>
-        </p:txBody>
-      </p:sp>
       <p:pic>
         <p:nvPicPr>
           <p:cNvPr id="9" name="Picture 8">
@@ -8021,47 +9533,147 @@
           <p:nvPr/>
         </p:nvPicPr>
         <p:blipFill>
-          <a:blip r:embed="rId2"/>
+          <a:blip r:embed="rId3"/>
           <a:stretch>
             <a:fillRect/>
           </a:stretch>
         </p:blipFill>
         <p:spPr>
           <a:xfrm>
-            <a:off x="96891" y="2168842"/>
-            <a:ext cx="12095110" cy="4689158"/>
+            <a:off x="0" y="1934325"/>
+            <a:ext cx="12192000" cy="3707863"/>
+          </a:xfrm>
+          <a:prstGeom prst="rect">
+            <a:avLst/>
+          </a:prstGeom>
+          <a:ln>
+            <a:solidFill>
+              <a:schemeClr val="accent1"/>
+            </a:solidFill>
+          </a:ln>
+        </p:spPr>
+      </p:pic>
+      <p:sp>
+        <p:nvSpPr>
+          <p:cNvPr id="2" name="Slide Number Placeholder 1">
+            <a:extLst>
+              <a:ext uri="{FF2B5EF4-FFF2-40B4-BE49-F238E27FC236}">
+                <a16:creationId xmlns:a16="http://schemas.microsoft.com/office/drawing/2014/main" id="{C949607A-1666-A0C0-63B8-EA54F6E0DDC6}"/>
+              </a:ext>
+            </a:extLst>
+          </p:cNvPr>
+          <p:cNvSpPr>
+            <a:spLocks noGrp="1"/>
+          </p:cNvSpPr>
+          <p:nvPr>
+            <p:ph type="sldNum" sz="quarter" idx="12"/>
+          </p:nvPr>
+        </p:nvSpPr>
+        <p:spPr/>
+        <p:txBody>
+          <a:bodyPr/>
+          <a:lstStyle/>
+          <a:p>
+            <a:fld id="{6CC2E120-88CB-4223-BF42-F8F7A034DB50}" type="slidenum">
+              <a:rPr lang="en-US" smtClean="0"/>
+              <a:t>6</a:t>
+            </a:fld>
+            <a:endParaRPr lang="en-US"/>
+          </a:p>
+        </p:txBody>
+      </p:sp>
+      <p:sp>
+        <p:nvSpPr>
+          <p:cNvPr id="3" name="Title 1">
+            <a:extLst>
+              <a:ext uri="{FF2B5EF4-FFF2-40B4-BE49-F238E27FC236}">
+                <a16:creationId xmlns:a16="http://schemas.microsoft.com/office/drawing/2014/main" id="{5DF54A17-E1B3-F303-456C-DA742E6BC8C0}"/>
+              </a:ext>
+            </a:extLst>
+          </p:cNvPr>
+          <p:cNvSpPr txBox="1">
+            <a:spLocks/>
+          </p:cNvSpPr>
+          <p:nvPr/>
+        </p:nvSpPr>
+        <p:spPr>
+          <a:xfrm>
+            <a:off x="838201" y="5679306"/>
+            <a:ext cx="11353800" cy="1196446"/>
           </a:xfrm>
           <a:prstGeom prst="rect">
             <a:avLst/>
           </a:prstGeom>
         </p:spPr>
-      </p:pic>
-      <p:sp>
-        <p:nvSpPr>
-          <p:cNvPr id="2" name="Slide Number Placeholder 1">
-            <a:extLst>
-              <a:ext uri="{FF2B5EF4-FFF2-40B4-BE49-F238E27FC236}">
-                <a16:creationId xmlns:a16="http://schemas.microsoft.com/office/drawing/2014/main" id="{C949607A-1666-A0C0-63B8-EA54F6E0DDC6}"/>
-              </a:ext>
-            </a:extLst>
-          </p:cNvPr>
-          <p:cNvSpPr>
-            <a:spLocks noGrp="1"/>
-          </p:cNvSpPr>
-          <p:nvPr>
-            <p:ph type="sldNum" sz="quarter" idx="12"/>
-          </p:nvPr>
-        </p:nvSpPr>
-        <p:spPr/>
-        <p:txBody>
-          <a:bodyPr/>
-          <a:lstStyle/>
-          <a:p>
-            <a:fld id="{6CC2E120-88CB-4223-BF42-F8F7A034DB50}" type="slidenum">
-              <a:rPr lang="en-US" smtClean="0"/>
-              <a:t>6</a:t>
-            </a:fld>
-            <a:endParaRPr lang="en-US"/>
+        <p:txBody>
+          <a:bodyPr vert="horz" lIns="91440" tIns="45720" rIns="91440" bIns="45720" rtlCol="0" anchor="b">
+            <a:normAutofit lnSpcReduction="10000"/>
+          </a:bodyPr>
+          <a:lstStyle>
+            <a:lvl1pPr algn="l" defTabSz="914400" rtl="0" eaLnBrk="1" latinLnBrk="0" hangingPunct="1">
+              <a:lnSpc>
+                <a:spcPct val="90000"/>
+              </a:lnSpc>
+              <a:spcBef>
+                <a:spcPct val="0"/>
+              </a:spcBef>
+              <a:buNone/>
+              <a:defRPr sz="6000" kern="1200">
+                <a:solidFill>
+                  <a:schemeClr val="tx1"/>
+                </a:solidFill>
+                <a:latin typeface="+mj-lt"/>
+                <a:ea typeface="+mj-ea"/>
+                <a:cs typeface="+mj-cs"/>
+              </a:defRPr>
+            </a:lvl1pPr>
+          </a:lstStyle>
+          <a:p>
+            <a:r>
+              <a:rPr lang="en-US" sz="2800" dirty="0"/>
+              <a:t>Documentation: </a:t>
+            </a:r>
+            <a:r>
+              <a:rPr lang="en-US" sz="2800" dirty="0">
+                <a:solidFill>
+                  <a:srgbClr val="0070C0"/>
+                </a:solidFill>
+                <a:hlinkClick r:id="rId4">
+                  <a:extLst>
+                    <a:ext uri="{A12FA001-AC4F-418D-AE19-62706E023703}">
+                      <ahyp:hlinkClr xmlns:ahyp="http://schemas.microsoft.com/office/drawing/2018/hyperlinkcolor" val="tx"/>
+                    </a:ext>
+                  </a:extLst>
+                </a:hlinkClick>
+              </a:rPr>
+              <a:t>https://jjdeuce06.github.io/VulcanActivityTracker/</a:t>
+            </a:r>
+            <a:endParaRPr lang="en-US" sz="2800" dirty="0">
+              <a:solidFill>
+                <a:srgbClr val="0070C0"/>
+              </a:solidFill>
+            </a:endParaRPr>
+          </a:p>
+          <a:p>
+            <a:endParaRPr lang="en-US" sz="2800" dirty="0">
+              <a:solidFill>
+                <a:srgbClr val="0070C0"/>
+              </a:solidFill>
+            </a:endParaRPr>
+          </a:p>
+          <a:p>
+            <a:r>
+              <a:rPr lang="en-US" sz="2800" dirty="0"/>
+              <a:t>Live: </a:t>
+            </a:r>
+            <a:r>
+              <a:rPr lang="en-US" sz="2800" dirty="0">
+                <a:solidFill>
+                  <a:srgbClr val="0070C0"/>
+                </a:solidFill>
+              </a:rPr>
+              <a:t>https://vulcanactivitytracker.onrender.com</a:t>
+            </a:r>
           </a:p>
         </p:txBody>
       </p:sp>
@@ -9565,7 +11177,7 @@
           <p:nvPr>
             <p:extLst>
               <p:ext uri="{D42A27DB-BD31-4B8C-83A1-F6EECF244321}">
-                <p14:modId xmlns:p14="http://schemas.microsoft.com/office/powerpoint/2010/main" val="2563126350"/>
+                <p14:modId xmlns:p14="http://schemas.microsoft.com/office/powerpoint/2010/main" val="1875416205"/>
               </p:ext>
             </p:extLst>
           </p:nvPr>
@@ -10259,10 +11871,10 @@
       </p:grpSpPr>
       <p:sp useBgFill="1">
         <p:nvSpPr>
-          <p:cNvPr id="12" name="Rectangle 11">
-            <a:extLst>
-              <a:ext uri="{FF2B5EF4-FFF2-40B4-BE49-F238E27FC236}">
-                <a16:creationId xmlns:a16="http://schemas.microsoft.com/office/drawing/2014/main" id="{74751229-0244-4FBB-BED1-407467F4C951}"/>
+          <p:cNvPr id="37" name="Rectangle 36">
+            <a:extLst>
+              <a:ext uri="{FF2B5EF4-FFF2-40B4-BE49-F238E27FC236}">
+                <a16:creationId xmlns:a16="http://schemas.microsoft.com/office/drawing/2014/main" id="{907EF6B7-1338-4443-8C46-6A318D952DFD}"/>
               </a:ext>
               <a:ext uri="{C183D7F6-B498-43B3-948B-1728B52AA6E4}">
                 <adec:decorative xmlns:adec="http://schemas.microsoft.com/office/drawing/2017/decorative" val="1"/>
@@ -10282,7 +11894,7 @@
         </p:nvSpPr>
         <p:spPr>
           <a:xfrm>
-            <a:off x="0" y="0"/>
+            <a:off x="3048" y="0"/>
             <a:ext cx="12188952" cy="6858000"/>
           </a:xfrm>
           <a:prstGeom prst="rect">
@@ -10319,10 +11931,144 @@
       </p:sp>
       <p:sp>
         <p:nvSpPr>
+          <p:cNvPr id="38" name="Freeform: Shape 37">
+            <a:extLst>
+              <a:ext uri="{FF2B5EF4-FFF2-40B4-BE49-F238E27FC236}">
+                <a16:creationId xmlns:a16="http://schemas.microsoft.com/office/drawing/2014/main" id="{DAAE4CDD-124C-4DCF-9584-B6033B545DD5}"/>
+              </a:ext>
+              <a:ext uri="{C183D7F6-B498-43B3-948B-1728B52AA6E4}">
+                <adec:decorative xmlns:adec="http://schemas.microsoft.com/office/drawing/2017/decorative" val="1"/>
+              </a:ext>
+            </a:extLst>
+          </p:cNvPr>
+          <p:cNvSpPr>
+            <a:spLocks noGrp="1" noRot="1" noChangeAspect="1" noMove="1" noResize="1" noEditPoints="1" noAdjustHandles="1" noChangeArrowheads="1" noChangeShapeType="1" noTextEdit="1"/>
+          </p:cNvSpPr>
+          <p:nvPr>
+            <p:extLst>
+              <p:ext uri="{386F3935-93C4-4BCD-93E2-E3B085C9AB24}">
+                <p16:designElem xmlns:p16="http://schemas.microsoft.com/office/powerpoint/2015/main" val="1"/>
+              </p:ext>
+            </p:extLst>
+          </p:nvPr>
+        </p:nvSpPr>
+        <p:spPr>
+          <a:xfrm>
+            <a:off x="1" y="0"/>
+            <a:ext cx="4167271" cy="6858000"/>
+          </a:xfrm>
+          <a:custGeom>
+            <a:avLst/>
+            <a:gdLst>
+              <a:gd name="connsiteX0" fmla="*/ 0 w 4167271"/>
+              <a:gd name="connsiteY0" fmla="*/ 0 h 6858000"/>
+              <a:gd name="connsiteX1" fmla="*/ 2259550 w 4167271"/>
+              <a:gd name="connsiteY1" fmla="*/ 0 h 6858000"/>
+              <a:gd name="connsiteX2" fmla="*/ 2387803 w 4167271"/>
+              <a:gd name="connsiteY2" fmla="*/ 82222 h 6858000"/>
+              <a:gd name="connsiteX3" fmla="*/ 4167271 w 4167271"/>
+              <a:gd name="connsiteY3" fmla="*/ 3429000 h 6858000"/>
+              <a:gd name="connsiteX4" fmla="*/ 2387803 w 4167271"/>
+              <a:gd name="connsiteY4" fmla="*/ 6775779 h 6858000"/>
+              <a:gd name="connsiteX5" fmla="*/ 2259550 w 4167271"/>
+              <a:gd name="connsiteY5" fmla="*/ 6858000 h 6858000"/>
+              <a:gd name="connsiteX6" fmla="*/ 0 w 4167271"/>
+              <a:gd name="connsiteY6" fmla="*/ 6858000 h 6858000"/>
+            </a:gdLst>
+            <a:ahLst/>
+            <a:cxnLst>
+              <a:cxn ang="0">
+                <a:pos x="connsiteX0" y="connsiteY0"/>
+              </a:cxn>
+              <a:cxn ang="0">
+                <a:pos x="connsiteX1" y="connsiteY1"/>
+              </a:cxn>
+              <a:cxn ang="0">
+                <a:pos x="connsiteX2" y="connsiteY2"/>
+              </a:cxn>
+              <a:cxn ang="0">
+                <a:pos x="connsiteX3" y="connsiteY3"/>
+              </a:cxn>
+              <a:cxn ang="0">
+                <a:pos x="connsiteX4" y="connsiteY4"/>
+              </a:cxn>
+              <a:cxn ang="0">
+                <a:pos x="connsiteX5" y="connsiteY5"/>
+              </a:cxn>
+              <a:cxn ang="0">
+                <a:pos x="connsiteX6" y="connsiteY6"/>
+              </a:cxn>
+            </a:cxnLst>
+            <a:rect l="l" t="t" r="r" b="b"/>
+            <a:pathLst>
+              <a:path w="4167271" h="6858000">
+                <a:moveTo>
+                  <a:pt x="0" y="0"/>
+                </a:moveTo>
+                <a:lnTo>
+                  <a:pt x="2259550" y="0"/>
+                </a:lnTo>
+                <a:lnTo>
+                  <a:pt x="2387803" y="82222"/>
+                </a:lnTo>
+                <a:cubicBezTo>
+                  <a:pt x="3461407" y="807534"/>
+                  <a:pt x="4167271" y="2035835"/>
+                  <a:pt x="4167271" y="3429000"/>
+                </a:cubicBezTo>
+                <a:cubicBezTo>
+                  <a:pt x="4167271" y="4822165"/>
+                  <a:pt x="3461407" y="6050467"/>
+                  <a:pt x="2387803" y="6775779"/>
+                </a:cubicBezTo>
+                <a:lnTo>
+                  <a:pt x="2259550" y="6858000"/>
+                </a:lnTo>
+                <a:lnTo>
+                  <a:pt x="0" y="6858000"/>
+                </a:lnTo>
+                <a:close/>
+              </a:path>
+            </a:pathLst>
+          </a:custGeom>
+          <a:solidFill>
+            <a:schemeClr val="accent2"/>
+          </a:solidFill>
+          <a:ln>
+            <a:noFill/>
+          </a:ln>
+        </p:spPr>
+        <p:style>
+          <a:lnRef idx="2">
+            <a:schemeClr val="accent1">
+              <a:shade val="50000"/>
+            </a:schemeClr>
+          </a:lnRef>
+          <a:fillRef idx="1">
+            <a:schemeClr val="accent1"/>
+          </a:fillRef>
+          <a:effectRef idx="0">
+            <a:schemeClr val="accent1"/>
+          </a:effectRef>
+          <a:fontRef idx="minor">
+            <a:schemeClr val="lt1"/>
+          </a:fontRef>
+        </p:style>
+        <p:txBody>
+          <a:bodyPr rtlCol="0" anchor="ctr"/>
+          <a:lstStyle/>
+          <a:p>
+            <a:pPr algn="ctr"/>
+            <a:endParaRPr lang="en-US"/>
+          </a:p>
+        </p:txBody>
+      </p:sp>
+      <p:sp>
+        <p:nvSpPr>
           <p:cNvPr id="2" name="Title 1">
             <a:extLst>
               <a:ext uri="{FF2B5EF4-FFF2-40B4-BE49-F238E27FC236}">
-                <a16:creationId xmlns:a16="http://schemas.microsoft.com/office/drawing/2014/main" id="{153C799C-4835-C8CB-B090-70E82B558CED}"/>
+                <a16:creationId xmlns:a16="http://schemas.microsoft.com/office/drawing/2014/main" id="{E9C9ACDB-E88F-2B2C-A445-F5F7CD19BF57}"/>
               </a:ext>
             </a:extLst>
           </p:cNvPr>
@@ -10330,89 +12076,51 @@
             <a:spLocks noGrp="1"/>
           </p:cNvSpPr>
           <p:nvPr>
-            <p:ph type="title"/>
+            <p:ph type="ctrTitle"/>
           </p:nvPr>
         </p:nvSpPr>
         <p:spPr>
           <a:xfrm>
-            <a:off x="1845875" y="4102151"/>
-            <a:ext cx="3307465" cy="987570"/>
+            <a:off x="686834" y="1153572"/>
+            <a:ext cx="3200400" cy="4461163"/>
           </a:xfrm>
         </p:spPr>
         <p:txBody>
-          <a:bodyPr vert="horz" lIns="91440" tIns="45720" rIns="91440" bIns="45720" rtlCol="0" anchor="b">
+          <a:bodyPr vert="horz" lIns="91440" tIns="45720" rIns="91440" bIns="45720" rtlCol="0" anchor="ctr">
             <a:normAutofit/>
           </a:bodyPr>
           <a:lstStyle/>
           <a:p>
+            <a:pPr algn="l"/>
             <a:r>
-              <a:rPr lang="en-US" sz="5200" kern="1200" dirty="0">
+              <a:rPr lang="en-US" sz="3700" kern="1200">
                 <a:solidFill>
-                  <a:schemeClr val="tx1"/>
+                  <a:srgbClr val="FFFFFF"/>
                 </a:solidFill>
                 <a:latin typeface="+mj-lt"/>
                 <a:ea typeface="+mj-ea"/>
                 <a:cs typeface="+mj-cs"/>
               </a:rPr>
-              <a:t>Questions</a:t>
+              <a:t>Project Improvements</a:t>
             </a:r>
           </a:p>
         </p:txBody>
       </p:sp>
-      <p:pic>
-        <p:nvPicPr>
-          <p:cNvPr id="7" name="Graphic 6" descr="Help">
-            <a:extLst>
-              <a:ext uri="{FF2B5EF4-FFF2-40B4-BE49-F238E27FC236}">
-                <a16:creationId xmlns:a16="http://schemas.microsoft.com/office/drawing/2014/main" id="{69A52293-75E5-359D-7395-51D899F9087B}"/>
-              </a:ext>
-            </a:extLst>
-          </p:cNvPr>
-          <p:cNvPicPr>
-            <a:picLocks noChangeAspect="1"/>
-          </p:cNvPicPr>
-          <p:nvPr/>
-        </p:nvPicPr>
-        <p:blipFill>
-          <a:blip>
-            <a:extLst>
-              <a:ext uri="{28A0092B-C50C-407E-A947-70E740481C1C}">
-                <a14:useLocalDpi xmlns:a14="http://schemas.microsoft.com/office/drawing/2010/main" val="0"/>
-              </a:ext>
-              <a:ext uri="{96DAC541-7B7A-43D3-8B79-37D633B846F1}">
-                <asvg:svgBlip xmlns:asvg="http://schemas.microsoft.com/office/drawing/2016/SVG/main" r:embed="rId2"/>
-              </a:ext>
-            </a:extLst>
-          </a:blip>
-          <a:stretch>
-            <a:fillRect/>
-          </a:stretch>
-        </p:blipFill>
-        <p:spPr>
-          <a:xfrm>
-            <a:off x="420823" y="3951411"/>
-            <a:ext cx="1289051" cy="1289051"/>
-          </a:xfrm>
-          <a:prstGeom prst="rect">
-            <a:avLst/>
-          </a:prstGeom>
-        </p:spPr>
-      </p:pic>
-      <p:pic>
-        <p:nvPicPr>
-          <p:cNvPr id="9" name="Graphic 8" descr="Help">
-            <a:extLst>
-              <a:ext uri="{FF2B5EF4-FFF2-40B4-BE49-F238E27FC236}">
-                <a16:creationId xmlns:a16="http://schemas.microsoft.com/office/drawing/2014/main" id="{F1648FD1-EAB6-4C51-B9EC-A31CFF67AC7F}"/>
+      <p:sp>
+        <p:nvSpPr>
+          <p:cNvPr id="39" name="Arc 38">
+            <a:extLst>
+              <a:ext uri="{FF2B5EF4-FFF2-40B4-BE49-F238E27FC236}">
+                <a16:creationId xmlns:a16="http://schemas.microsoft.com/office/drawing/2014/main" id="{081E4A58-353D-44AE-B2FC-2A74E2E400F7}"/>
               </a:ext>
               <a:ext uri="{C183D7F6-B498-43B3-948B-1728B52AA6E4}">
                 <adec:decorative xmlns:adec="http://schemas.microsoft.com/office/drawing/2017/decorative" val="1"/>
               </a:ext>
             </a:extLst>
           </p:cNvPr>
-          <p:cNvPicPr>
-            <a:picLocks noGrp="1" noRot="1" noChangeAspect="1" noMove="1" noResize="1" noEditPoints="1" noAdjustHandles="1" noChangeArrowheads="1" noChangeShapeType="1" noCrop="1"/>
-          </p:cNvPicPr>
+          <p:cNvSpPr>
+            <a:spLocks noGrp="1" noRot="1" noChangeAspect="1" noMove="1" noResize="1" noEditPoints="1" noAdjustHandles="1" noChangeArrowheads="1" noChangeShapeType="1" noTextEdit="1"/>
+          </p:cNvSpPr>
           <p:nvPr>
             <p:extLst>
               <p:ext uri="{386F3935-93C4-4BCD-93E2-E3B085C9AB24}">
@@ -10420,280 +12128,183 @@
               </p:ext>
             </p:extLst>
           </p:nvPr>
-        </p:nvPicPr>
-        <p:blipFill>
-          <a:blip>
-            <a:alphaModFix amt="15000"/>
-            <a:extLst>
-              <a:ext uri="{28A0092B-C50C-407E-A947-70E740481C1C}">
-                <a14:useLocalDpi xmlns:a14="http://schemas.microsoft.com/office/drawing/2010/main" val="0"/>
-              </a:ext>
-              <a:ext uri="{96DAC541-7B7A-43D3-8B79-37D633B846F1}">
-                <asvg:svgBlip xmlns:asvg="http://schemas.microsoft.com/office/drawing/2016/SVG/main" r:embed="rId2"/>
-              </a:ext>
-            </a:extLst>
-          </a:blip>
-          <a:stretch>
-            <a:fillRect/>
-          </a:stretch>
-        </p:blipFill>
+        </p:nvSpPr>
+        <p:spPr>
+          <a:xfrm flipV="1">
+            <a:off x="7550402" y="2455479"/>
+            <a:ext cx="4083433" cy="4083433"/>
+          </a:xfrm>
+          <a:prstGeom prst="arc">
+            <a:avLst/>
+          </a:prstGeom>
+          <a:ln w="127000" cap="rnd">
+            <a:solidFill>
+              <a:schemeClr val="accent4"/>
+            </a:solidFill>
+            <a:prstDash val="dash"/>
+          </a:ln>
+        </p:spPr>
+        <p:style>
+          <a:lnRef idx="1">
+            <a:schemeClr val="accent1"/>
+          </a:lnRef>
+          <a:fillRef idx="0">
+            <a:schemeClr val="accent1"/>
+          </a:fillRef>
+          <a:effectRef idx="0">
+            <a:schemeClr val="accent1"/>
+          </a:effectRef>
+          <a:fontRef idx="minor">
+            <a:schemeClr val="tx1"/>
+          </a:fontRef>
+        </p:style>
+        <p:txBody>
+          <a:bodyPr rtlCol="0" anchor="ctr"/>
+          <a:lstStyle/>
+          <a:p>
+            <a:pPr algn="ctr"/>
+            <a:endParaRPr lang="en-US" dirty="0"/>
+          </a:p>
+        </p:txBody>
+      </p:sp>
+      <p:sp>
+        <p:nvSpPr>
+          <p:cNvPr id="5" name="Text Placeholder 5">
+            <a:extLst>
+              <a:ext uri="{FF2B5EF4-FFF2-40B4-BE49-F238E27FC236}">
+                <a16:creationId xmlns:a16="http://schemas.microsoft.com/office/drawing/2014/main" id="{8C93D68C-FF1A-6AAA-C0E9-D935E871DF40}"/>
+              </a:ext>
+            </a:extLst>
+          </p:cNvPr>
+          <p:cNvSpPr>
+            <a:spLocks noGrp="1"/>
+          </p:cNvSpPr>
+          <p:nvPr>
+            <p:ph type="subTitle" idx="1"/>
+          </p:nvPr>
+        </p:nvSpPr>
         <p:spPr>
           <a:xfrm>
-            <a:off x="6607815" y="716407"/>
-            <a:ext cx="5411343" cy="5411343"/>
+            <a:off x="4447308" y="591344"/>
+            <a:ext cx="6906491" cy="5585619"/>
           </a:xfrm>
-          <a:prstGeom prst="rect">
-            <a:avLst/>
-          </a:prstGeom>
         </p:spPr>
-      </p:pic>
+        <p:txBody>
+          <a:bodyPr vert="horz" lIns="91440" tIns="45720" rIns="91440" bIns="45720" rtlCol="0" anchor="ctr">
+            <a:normAutofit/>
+          </a:bodyPr>
+          <a:lstStyle/>
+          <a:p>
+            <a:pPr marL="342900" indent="-228600" algn="l">
+              <a:buFont typeface="Arial" panose="020B0604020202020204" pitchFamily="34" charset="0"/>
+              <a:buChar char="•"/>
+            </a:pPr>
+            <a:r>
+              <a:rPr lang="en-US"/>
+              <a:t>Email verification integration </a:t>
+            </a:r>
+          </a:p>
+          <a:p>
+            <a:pPr marL="342900" indent="-228600" algn="l">
+              <a:buFont typeface="Arial" panose="020B0604020202020204" pitchFamily="34" charset="0"/>
+              <a:buChar char="•"/>
+            </a:pPr>
+            <a:r>
+              <a:rPr lang="en-US"/>
+              <a:t>AI Coach</a:t>
+            </a:r>
+          </a:p>
+          <a:p>
+            <a:pPr marL="342900" indent="-228600" algn="l">
+              <a:buFont typeface="Arial" panose="020B0604020202020204" pitchFamily="34" charset="0"/>
+              <a:buChar char="•"/>
+            </a:pPr>
+            <a:r>
+              <a:rPr lang="en-US"/>
+              <a:t>Smart watch connectivity </a:t>
+            </a:r>
+          </a:p>
+          <a:p>
+            <a:pPr marL="342900" indent="-228600" algn="l">
+              <a:buFont typeface="Arial" panose="020B0604020202020204" pitchFamily="34" charset="0"/>
+              <a:buChar char="•"/>
+            </a:pPr>
+            <a:r>
+              <a:rPr lang="en-US"/>
+              <a:t>Database scalability </a:t>
+            </a:r>
+          </a:p>
+          <a:p>
+            <a:pPr indent="-228600" algn="l">
+              <a:buFont typeface="Arial" panose="020B0604020202020204" pitchFamily="34" charset="0"/>
+              <a:buChar char="•"/>
+            </a:pPr>
+            <a:endParaRPr lang="en-US"/>
+          </a:p>
+        </p:txBody>
+      </p:sp>
       <p:sp>
         <p:nvSpPr>
-          <p:cNvPr id="4" name="Title 1">
-            <a:extLst>
-              <a:ext uri="{FF2B5EF4-FFF2-40B4-BE49-F238E27FC236}">
-                <a16:creationId xmlns:a16="http://schemas.microsoft.com/office/drawing/2014/main" id="{B7AD252D-6AEF-5D34-92C0-C2F37203AEB8}"/>
-              </a:ext>
-            </a:extLst>
-          </p:cNvPr>
-          <p:cNvSpPr txBox="1">
-            <a:spLocks/>
-          </p:cNvSpPr>
-          <p:nvPr/>
+          <p:cNvPr id="4" name="Slide Number Placeholder 3">
+            <a:extLst>
+              <a:ext uri="{FF2B5EF4-FFF2-40B4-BE49-F238E27FC236}">
+                <a16:creationId xmlns:a16="http://schemas.microsoft.com/office/drawing/2014/main" id="{E049FB81-7C3D-77BD-7D2D-40627D316BB6}"/>
+              </a:ext>
+            </a:extLst>
+          </p:cNvPr>
+          <p:cNvSpPr>
+            <a:spLocks noGrp="1"/>
+          </p:cNvSpPr>
+          <p:nvPr>
+            <p:ph type="sldNum" sz="quarter" idx="12"/>
+          </p:nvPr>
         </p:nvSpPr>
         <p:spPr>
           <a:xfrm>
-            <a:off x="310853" y="5480501"/>
-            <a:ext cx="11476057" cy="1196446"/>
+            <a:off x="9541564" y="6356350"/>
+            <a:ext cx="1812235" cy="365125"/>
           </a:xfrm>
-          <a:prstGeom prst="rect">
-            <a:avLst/>
-          </a:prstGeom>
         </p:spPr>
         <p:txBody>
-          <a:bodyPr vert="horz" lIns="91440" tIns="45720" rIns="91440" bIns="45720" rtlCol="0" anchor="b">
-            <a:normAutofit fontScale="92500" lnSpcReduction="20000"/>
+          <a:bodyPr vert="horz" lIns="91440" tIns="45720" rIns="91440" bIns="45720" rtlCol="0" anchor="ctr">
+            <a:normAutofit/>
           </a:bodyPr>
-          <a:lstStyle>
-            <a:lvl1pPr algn="l" defTabSz="914400" rtl="0" eaLnBrk="1" latinLnBrk="0" hangingPunct="1">
-              <a:lnSpc>
-                <a:spcPct val="90000"/>
-              </a:lnSpc>
-              <a:spcBef>
-                <a:spcPct val="0"/>
-              </a:spcBef>
-              <a:buNone/>
-              <a:defRPr sz="6000" kern="1200">
+          <a:lstStyle/>
+          <a:p>
+            <a:pPr>
+              <a:spcAft>
+                <a:spcPts val="600"/>
+              </a:spcAft>
+            </a:pPr>
+            <a:fld id="{6CC2E120-88CB-4223-BF42-F8F7A034DB50}" type="slidenum">
+              <a:rPr lang="en-US" smtClean="0">
                 <a:solidFill>
-                  <a:schemeClr val="tx1"/>
+                  <a:schemeClr val="tx1">
+                    <a:tint val="75000"/>
+                  </a:schemeClr>
                 </a:solidFill>
-                <a:latin typeface="+mj-lt"/>
-                <a:ea typeface="+mj-ea"/>
-                <a:cs typeface="+mj-cs"/>
-              </a:defRPr>
-            </a:lvl1pPr>
-          </a:lstStyle>
-          <a:p>
-            <a:r>
-              <a:rPr lang="en-US" sz="3500" dirty="0"/>
-              <a:t>Documentation: </a:t>
-            </a:r>
-            <a:r>
-              <a:rPr lang="en-US" sz="3500" dirty="0">
-                <a:solidFill>
-                  <a:srgbClr val="0070C0"/>
-                </a:solidFill>
-                <a:hlinkClick r:id="rId3">
-                  <a:extLst>
-                    <a:ext uri="{A12FA001-AC4F-418D-AE19-62706E023703}">
-                      <ahyp:hlinkClr xmlns:ahyp="http://schemas.microsoft.com/office/drawing/2018/hyperlinkcolor" val="tx"/>
-                    </a:ext>
-                  </a:extLst>
-                </a:hlinkClick>
               </a:rPr>
-              <a:t>https://jjdeuce06.github.io/VulcanActivityTracker/</a:t>
-            </a:r>
-            <a:endParaRPr lang="en-US" sz="3500" dirty="0">
+              <a:pPr>
+                <a:spcAft>
+                  <a:spcPts val="600"/>
+                </a:spcAft>
+              </a:pPr>
+              <a:t>9</a:t>
+            </a:fld>
+            <a:endParaRPr lang="en-US">
               <a:solidFill>
-                <a:srgbClr val="0070C0"/>
+                <a:schemeClr val="tx1">
+                  <a:tint val="75000"/>
+                </a:schemeClr>
               </a:solidFill>
             </a:endParaRPr>
-          </a:p>
-          <a:p>
-            <a:endParaRPr lang="en-US" sz="3500" dirty="0">
-              <a:solidFill>
-                <a:srgbClr val="0070C0"/>
-              </a:solidFill>
-            </a:endParaRPr>
-          </a:p>
-          <a:p>
-            <a:r>
-              <a:rPr lang="en-US" sz="3500" dirty="0"/>
-              <a:t>Live: </a:t>
-            </a:r>
-            <a:r>
-              <a:rPr lang="en-US" sz="3500" dirty="0">
-                <a:solidFill>
-                  <a:srgbClr val="0070C0"/>
-                </a:solidFill>
-              </a:rPr>
-              <a:t>https://vulcanactivitytracker.onrender.com</a:t>
-            </a:r>
-          </a:p>
-        </p:txBody>
-      </p:sp>
-      <p:sp>
-        <p:nvSpPr>
-          <p:cNvPr id="3" name="Slide Number Placeholder 2">
-            <a:extLst>
-              <a:ext uri="{FF2B5EF4-FFF2-40B4-BE49-F238E27FC236}">
-                <a16:creationId xmlns:a16="http://schemas.microsoft.com/office/drawing/2014/main" id="{986FFE89-6C3C-A07F-03B6-6620445DFD75}"/>
-              </a:ext>
-            </a:extLst>
-          </p:cNvPr>
-          <p:cNvSpPr>
-            <a:spLocks noGrp="1"/>
-          </p:cNvSpPr>
-          <p:nvPr>
-            <p:ph type="sldNum" sz="quarter" idx="12"/>
-          </p:nvPr>
-        </p:nvSpPr>
-        <p:spPr/>
-        <p:txBody>
-          <a:bodyPr/>
-          <a:lstStyle/>
-          <a:p>
-            <a:fld id="{6CC2E120-88CB-4223-BF42-F8F7A034DB50}" type="slidenum">
-              <a:rPr lang="en-US" smtClean="0"/>
-              <a:t>9</a:t>
-            </a:fld>
-            <a:endParaRPr lang="en-US"/>
-          </a:p>
-        </p:txBody>
-      </p:sp>
-      <p:sp>
-        <p:nvSpPr>
-          <p:cNvPr id="6" name="Title 1">
-            <a:extLst>
-              <a:ext uri="{FF2B5EF4-FFF2-40B4-BE49-F238E27FC236}">
-                <a16:creationId xmlns:a16="http://schemas.microsoft.com/office/drawing/2014/main" id="{58B38568-C5E6-EDF1-6A58-E97B3EF311B9}"/>
-              </a:ext>
-            </a:extLst>
-          </p:cNvPr>
-          <p:cNvSpPr txBox="1">
-            <a:spLocks/>
-          </p:cNvSpPr>
-          <p:nvPr/>
-        </p:nvSpPr>
-        <p:spPr>
-          <a:xfrm>
-            <a:off x="671100" y="138161"/>
-            <a:ext cx="4827412" cy="854962"/>
-          </a:xfrm>
-          <a:prstGeom prst="rect">
-            <a:avLst/>
-          </a:prstGeom>
-        </p:spPr>
-        <p:txBody>
-          <a:bodyPr vert="horz" lIns="91440" tIns="45720" rIns="91440" bIns="45720" rtlCol="0" anchor="b">
-            <a:normAutofit fontScale="77500" lnSpcReduction="20000"/>
-          </a:bodyPr>
-          <a:lstStyle>
-            <a:lvl1pPr algn="l" defTabSz="914400" rtl="0" eaLnBrk="1" latinLnBrk="0" hangingPunct="1">
-              <a:lnSpc>
-                <a:spcPct val="90000"/>
-              </a:lnSpc>
-              <a:spcBef>
-                <a:spcPct val="0"/>
-              </a:spcBef>
-              <a:buNone/>
-              <a:defRPr sz="6000" kern="1200">
-                <a:solidFill>
-                  <a:schemeClr val="tx1"/>
-                </a:solidFill>
-                <a:latin typeface="+mj-lt"/>
-                <a:ea typeface="+mj-ea"/>
-                <a:cs typeface="+mj-cs"/>
-              </a:defRPr>
-            </a:lvl1pPr>
-          </a:lstStyle>
-          <a:p>
-            <a:r>
-              <a:rPr lang="en-US" sz="5200" dirty="0"/>
-              <a:t>Project Improvements</a:t>
-            </a:r>
-          </a:p>
-        </p:txBody>
-      </p:sp>
-      <p:sp>
-        <p:nvSpPr>
-          <p:cNvPr id="10" name="TextBox 9">
-            <a:extLst>
-              <a:ext uri="{FF2B5EF4-FFF2-40B4-BE49-F238E27FC236}">
-                <a16:creationId xmlns:a16="http://schemas.microsoft.com/office/drawing/2014/main" id="{B6A5AF98-EEC8-FE54-703A-15987C5508C2}"/>
-              </a:ext>
-            </a:extLst>
-          </p:cNvPr>
-          <p:cNvSpPr txBox="1"/>
-          <p:nvPr/>
-        </p:nvSpPr>
-        <p:spPr>
-          <a:xfrm>
-            <a:off x="671100" y="1259571"/>
-            <a:ext cx="4427740" cy="1754326"/>
-          </a:xfrm>
-          <a:prstGeom prst="rect">
-            <a:avLst/>
-          </a:prstGeom>
-          <a:noFill/>
-        </p:spPr>
-        <p:txBody>
-          <a:bodyPr wrap="square" rtlCol="0">
-            <a:spAutoFit/>
-          </a:bodyPr>
-          <a:lstStyle/>
-          <a:p>
-            <a:r>
-              <a:rPr lang="en-US" dirty="0"/>
-              <a:t>What did different</a:t>
-            </a:r>
-          </a:p>
-          <a:p>
-            <a:r>
-              <a:rPr lang="en-US" dirty="0"/>
-              <a:t>Email</a:t>
-            </a:r>
-          </a:p>
-          <a:p>
-            <a:r>
-              <a:rPr lang="en-US" dirty="0"/>
-              <a:t>Revisions</a:t>
-            </a:r>
-          </a:p>
-          <a:p>
-            <a:r>
-              <a:rPr lang="en-US" dirty="0"/>
-              <a:t>Database restrictions</a:t>
-            </a:r>
-          </a:p>
-          <a:p>
-            <a:r>
-              <a:rPr lang="en-US" dirty="0"/>
-              <a:t>Ai coach</a:t>
-            </a:r>
-          </a:p>
-          <a:p>
-            <a:r>
-              <a:rPr lang="en-US" dirty="0"/>
-              <a:t>Smart watch connectivity  </a:t>
-            </a:r>
           </a:p>
         </p:txBody>
       </p:sp>
     </p:spTree>
     <p:extLst>
       <p:ext uri="{BB962C8B-B14F-4D97-AF65-F5344CB8AC3E}">
-        <p14:creationId xmlns:p14="http://schemas.microsoft.com/office/powerpoint/2010/main" val="3773506301"/>
+        <p14:creationId xmlns:p14="http://schemas.microsoft.com/office/powerpoint/2010/main" val="294120850"/>
       </p:ext>
     </p:extLst>
   </p:cSld>

</xml_diff>